<commit_message>
POD2 deck: add "matches their schedule + operational" slide (now 13 slides)
New slide 11 shows the finalised_entry_dataset.xlsx deliverable: the Entry-by-Flight
sample (their columns + our Category/LF%/Entry Pax), a per-flight comparison against
the passenger estimate already in their schedule (0.993 correlation, totals within
6.5%), and a MATCHES / MAKES-IT-OPERATIONAL split. Caveats and summary shift to 12/13.

Co-Authored-By: Claude Opus 4.8 <noreply@anthropic.com>
</commit_message>
<xml_diff>
--- a/POD2/POD2_Entry_Overview.pptx
+++ b/POD2/POD2_Entry_Overview.pptx
@@ -17,9 +17,10 @@
     <p:sldId id="265" r:id="rId11"/>
     <p:sldId id="266" r:id="rId12"/>
     <p:sldId id="267" r:id="rId13"/>
+    <p:sldId id="268" r:id="rId14"/>
   </p:sldIdLst>
   <p:notesMasterIdLst>
-    <p:notesMasterId r:id="rId14"/>
+    <p:notesMasterId r:id="rId15"/>
   </p:notesMasterIdLst>
   <p:sldSz cx="12192000" cy="6858000"/>
   <p:notesSz cx="6858000" cy="12192000"/>
@@ -801,6 +802,94 @@
             <a:fld id="{F7021451-1387-4CA6-816F-3879F97B5CBC}" type="slidenum">
               <a:rPr lang="en-US"/>
               <a:t>12</a:t>
+            </a:fld>
+            <a:endParaRPr lang="en-US"/>
+          </a:p>
+        </p:txBody>
+      </p:sp>
+    </p:spTree>
+    <p:extLst>
+      <p:ext uri="{BB962C8B-B14F-4D97-AF65-F5344CB8AC3E}">
+        <p14:creationId xmlns:p14="http://schemas.microsoft.com/office/powerpoint/2010/main" val="1024086991"/>
+      </p:ext>
+    </p:extLst>
+  </p:cSld>
+  <p:clrMapOvr>
+    <a:masterClrMapping/>
+  </p:clrMapOvr>
+</p:notes>
+</file>
+
+<file path=ppt/notesSlides/notesSlide13.xml><?xml version="1.0" encoding="utf-8"?>
+<p:notes xmlns:a="http://schemas.openxmlformats.org/drawingml/2006/main" xmlns:r="http://schemas.openxmlformats.org/officeDocument/2006/relationships" xmlns:p="http://schemas.openxmlformats.org/presentationml/2006/main">
+  <p:cSld>
+    <p:spTree>
+      <p:nvGrpSpPr>
+        <p:cNvPr id="1" name=""/>
+        <p:cNvGrpSpPr/>
+        <p:nvPr/>
+      </p:nvGrpSpPr>
+      <p:grpSpPr>
+        <a:xfrm>
+          <a:off x="0" y="0"/>
+          <a:ext cx="0" cy="0"/>
+          <a:chOff x="0" y="0"/>
+          <a:chExt cx="0" cy="0"/>
+        </a:xfrm>
+      </p:grpSpPr>
+      <p:sp>
+        <p:nvSpPr>
+          <p:cNvPr id="2" name="Slide Image Placeholder 1"/>
+          <p:cNvSpPr>
+            <a:spLocks noGrp="1" noRot="1" noChangeAspect="1"/>
+          </p:cNvSpPr>
+          <p:nvPr>
+            <p:ph type="sldImg"/>
+          </p:nvPr>
+        </p:nvSpPr>
+        <p:spPr/>
+      </p:sp>
+      <p:sp>
+        <p:nvSpPr>
+          <p:cNvPr id="3" name="Notes Placeholder 2"/>
+          <p:cNvSpPr>
+            <a:spLocks noGrp="1"/>
+          </p:cNvSpPr>
+          <p:nvPr>
+            <p:ph type="body" idx="1"/>
+          </p:nvPr>
+        </p:nvSpPr>
+        <p:spPr/>
+        <p:txBody>
+          <a:bodyPr/>
+          <a:lstStyle/>
+          <a:p>
+            <a:r>
+              <a:rPr lang="en-US" dirty="0"/>
+              <a:t/>
+            </a:r>
+            <a:endParaRPr lang="en-US" dirty="0"/>
+          </a:p>
+        </p:txBody>
+      </p:sp>
+      <p:sp>
+        <p:nvSpPr>
+          <p:cNvPr id="4" name="Slide Number Placeholder 3"/>
+          <p:cNvSpPr>
+            <a:spLocks noGrp="1"/>
+          </p:cNvSpPr>
+          <p:nvPr>
+            <p:ph type="sldNum" sz="quarter" idx="10"/>
+          </p:nvPr>
+        </p:nvSpPr>
+        <p:spPr/>
+        <p:txBody>
+          <a:bodyPr/>
+          <a:lstStyle/>
+          <a:p>
+            <a:fld id="{F7021451-1387-4CA6-816F-3879F97B5CBC}" type="slidenum">
+              <a:rPr lang="en-US"/>
+              <a:t>13</a:t>
             </a:fld>
             <a:endParaRPr lang="en-US"/>
           </a:p>
@@ -3485,6 +3574,2264 @@
         </p:nvSpPr>
         <p:spPr>
           <a:xfrm>
+            <a:off x="640080" y="365760"/>
+            <a:ext cx="7315200" cy="274320"/>
+          </a:xfrm>
+          <a:prstGeom prst="rect">
+            <a:avLst/>
+          </a:prstGeom>
+          <a:noFill/>
+          <a:ln/>
+        </p:spPr>
+        <p:txBody>
+          <a:bodyPr wrap="square" lIns="0" tIns="0" rIns="0" bIns="0" rtlCol="0" anchor="ctr"/>
+          <a:lstStyle/>
+          <a:p>
+            <a:pPr indent="0" marL="0">
+              <a:buNone/>
+            </a:pPr>
+            <a:r>
+              <a:rPr lang="en-US" sz="1200" b="1" spc="200" kern="0" dirty="0">
+                <a:solidFill>
+                  <a:srgbClr val="2E8B57"/>
+                </a:solidFill>
+                <a:latin typeface="Calibri" pitchFamily="34" charset="0"/>
+                <a:ea typeface="Calibri" pitchFamily="34" charset="-122"/>
+                <a:cs typeface="Calibri" pitchFamily="34" charset="-120"/>
+              </a:rPr>
+              <a:t>THE DELIVERABLE  ·  FINALISED_ENTRY_DATASET.XLSX</a:t>
+            </a:r>
+            <a:endParaRPr lang="en-US" sz="1200" dirty="0"/>
+          </a:p>
+        </p:txBody>
+      </p:sp>
+      <p:sp>
+        <p:nvSpPr>
+          <p:cNvPr id="3" name="Text 1"/>
+          <p:cNvSpPr/>
+          <p:nvPr/>
+        </p:nvSpPr>
+        <p:spPr>
+          <a:xfrm>
+            <a:off x="640080" y="658368"/>
+            <a:ext cx="11155680" cy="731520"/>
+          </a:xfrm>
+          <a:prstGeom prst="rect">
+            <a:avLst/>
+          </a:prstGeom>
+          <a:noFill/>
+          <a:ln/>
+        </p:spPr>
+        <p:txBody>
+          <a:bodyPr wrap="square" lIns="0" tIns="0" rIns="0" bIns="0" rtlCol="0" anchor="ctr"/>
+          <a:lstStyle/>
+          <a:p>
+            <a:pPr indent="0" marL="0">
+              <a:buNone/>
+            </a:pPr>
+            <a:r>
+              <a:rPr lang="en-US" sz="3000" b="1" dirty="0">
+                <a:solidFill>
+                  <a:srgbClr val="1E2B37"/>
+                </a:solidFill>
+                <a:latin typeface="Cambria" pitchFamily="34" charset="0"/>
+                <a:ea typeface="Cambria" pitchFamily="34" charset="-122"/>
+                <a:cs typeface="Cambria" pitchFamily="34" charset="-120"/>
+              </a:rPr>
+              <a:t>Built on their schedule — and proven to match it</a:t>
+            </a:r>
+            <a:endParaRPr lang="en-US" sz="3000" dirty="0"/>
+          </a:p>
+        </p:txBody>
+      </p:sp>
+      <p:sp>
+        <p:nvSpPr>
+          <p:cNvPr id="4" name="Text 2"/>
+          <p:cNvSpPr/>
+          <p:nvPr/>
+        </p:nvSpPr>
+        <p:spPr>
+          <a:xfrm>
+            <a:off x="640080" y="1481328"/>
+            <a:ext cx="6766560" cy="320040"/>
+          </a:xfrm>
+          <a:prstGeom prst="rect">
+            <a:avLst/>
+          </a:prstGeom>
+          <a:noFill/>
+          <a:ln/>
+        </p:spPr>
+        <p:txBody>
+          <a:bodyPr wrap="square" lIns="0" tIns="0" rIns="0" bIns="0" rtlCol="0" anchor="ctr"/>
+          <a:lstStyle/>
+          <a:p>
+            <a:pPr indent="0" marL="0">
+              <a:buNone/>
+            </a:pPr>
+            <a:r>
+              <a:rPr lang="en-US" sz="1400" b="1" dirty="0">
+                <a:solidFill>
+                  <a:srgbClr val="0A3D5C"/>
+                </a:solidFill>
+                <a:latin typeface="Cambria" pitchFamily="34" charset="0"/>
+                <a:ea typeface="Cambria" pitchFamily="34" charset="-122"/>
+                <a:cs typeface="Cambria" pitchFamily="34" charset="-120"/>
+              </a:rPr>
+              <a:t>“Entry by Flight” sheet — the same 5,820 flights, with 3 columns appended</a:t>
+            </a:r>
+            <a:endParaRPr lang="en-US" sz="1400" dirty="0"/>
+          </a:p>
+        </p:txBody>
+      </p:sp>
+      <p:graphicFrame>
+        <p:nvGraphicFramePr>
+          <p:cNvPr id="12" name="Table 0"/>
+          <p:cNvGraphicFramePr>
+            <a:graphicFrameLocks noGrp="1"/>
+          </p:cNvGraphicFramePr>
+          <p:nvPr>
+            <p:extLst>
+              <p:ext uri="{D42A27DB-BD31-4B8C-83A1-F6EECF244321}">
+                <p14:modId xmlns:p14="http://schemas.microsoft.com/office/powerpoint/2010/main" val="1579011935"/>
+              </p:ext>
+            </p:extLst>
+          </p:nvPr>
+        </p:nvGraphicFramePr>
+        <p:xfrm>
+          <a:off x="640080" y="1874520"/>
+          <a:ext cx="7589520" cy="914400"/>
+        </p:xfrm>
+        <a:graphic>
+          <a:graphicData uri="http://schemas.openxmlformats.org/drawingml/2006/table">
+            <a:tbl>
+              <a:tblPr/>
+              <a:tblGrid>
+                <a:gridCol w="1325880"/>
+                <a:gridCol w="1280160"/>
+                <a:gridCol w="731520"/>
+                <a:gridCol w="822960"/>
+                <a:gridCol w="1234440"/>
+                <a:gridCol w="1280160"/>
+              </a:tblGrid>
+              <a:tr h="475488">
+                <a:tc>
+                  <a:txBody>
+                    <a:bodyPr/>
+                    <a:lstStyle/>
+                    <a:p>
+                      <a:pPr algn="l" indent="0" marL="0">
+                        <a:buNone/>
+                      </a:pPr>
+                      <a:r>
+                        <a:rPr lang="en-US" sz="1150" b="1" dirty="0">
+                          <a:solidFill>
+                            <a:srgbClr val="FFFFFF"/>
+                          </a:solidFill>
+                          <a:latin typeface="Cambria" pitchFamily="34" charset="0"/>
+                          <a:ea typeface="Cambria" pitchFamily="34" charset="-122"/>
+                          <a:cs typeface="Cambria" pitchFamily="34" charset="-120"/>
+                        </a:rPr>
+                        <a:t>Dep Flight</a:t>
+                      </a:r>
+                      <a:endParaRPr lang="en-US" sz="1150" dirty="0">
+                        <a:latin typeface="Cambria" charset="0"/>
+                        <a:ea typeface="Cambria" charset="0"/>
+                        <a:cs typeface="Cambria" charset="0"/>
+                      </a:endParaRPr>
+                    </a:p>
+                  </a:txBody>
+                  <a:tcPr marL="50800" marR="50800" marT="25400" marB="25400" anchor="ctr">
+                    <a:lnL w="12700" cap="flat" cmpd="sng" algn="ctr">
+                      <a:solidFill>
+                        <a:srgbClr val="D5DEE5"/>
+                      </a:solidFill>
+                      <a:prstDash val="solid"/>
+                      <a:round/>
+                      <a:headEnd type="none" w="med" len="med"/>
+                      <a:tailEnd type="none" w="med" len="med"/>
+                    </a:lnL>
+                    <a:lnR w="12700" cap="flat" cmpd="sng" algn="ctr">
+                      <a:solidFill>
+                        <a:srgbClr val="D5DEE5"/>
+                      </a:solidFill>
+                      <a:prstDash val="solid"/>
+                      <a:round/>
+                      <a:headEnd type="none" w="med" len="med"/>
+                      <a:tailEnd type="none" w="med" len="med"/>
+                    </a:lnR>
+                    <a:lnT w="12700" cap="flat" cmpd="sng" algn="ctr">
+                      <a:solidFill>
+                        <a:srgbClr val="D5DEE5"/>
+                      </a:solidFill>
+                      <a:prstDash val="solid"/>
+                      <a:round/>
+                      <a:headEnd type="none" w="med" len="med"/>
+                      <a:tailEnd type="none" w="med" len="med"/>
+                    </a:lnT>
+                    <a:lnB w="12700" cap="flat" cmpd="sng" algn="ctr">
+                      <a:solidFill>
+                        <a:srgbClr val="D5DEE5"/>
+                      </a:solidFill>
+                      <a:prstDash val="solid"/>
+                      <a:round/>
+                      <a:headEnd type="none" w="med" len="med"/>
+                      <a:tailEnd type="none" w="med" len="med"/>
+                    </a:lnB>
+                    <a:solidFill>
+                      <a:srgbClr val="0A3D5C"/>
+                    </a:solidFill>
+                  </a:tcPr>
+                </a:tc>
+                <a:tc>
+                  <a:txBody>
+                    <a:bodyPr/>
+                    <a:lstStyle/>
+                    <a:p>
+                      <a:pPr algn="ctr" indent="0" marL="0">
+                        <a:buNone/>
+                      </a:pPr>
+                      <a:r>
+                        <a:rPr lang="en-US" sz="1150" b="1" dirty="0">
+                          <a:solidFill>
+                            <a:srgbClr val="FFFFFF"/>
+                          </a:solidFill>
+                          <a:latin typeface="Cambria" pitchFamily="34" charset="0"/>
+                          <a:ea typeface="Cambria" pitchFamily="34" charset="-122"/>
+                          <a:cs typeface="Cambria" pitchFamily="34" charset="-120"/>
+                        </a:rPr>
+                        <a:t>Aircraft</a:t>
+                      </a:r>
+                      <a:endParaRPr lang="en-US" sz="1150" dirty="0">
+                        <a:latin typeface="Cambria" charset="0"/>
+                        <a:ea typeface="Cambria" charset="0"/>
+                        <a:cs typeface="Cambria" charset="0"/>
+                      </a:endParaRPr>
+                    </a:p>
+                  </a:txBody>
+                  <a:tcPr marL="50800" marR="50800" marT="25400" marB="25400" anchor="ctr">
+                    <a:lnL w="12700" cap="flat" cmpd="sng" algn="ctr">
+                      <a:solidFill>
+                        <a:srgbClr val="D5DEE5"/>
+                      </a:solidFill>
+                      <a:prstDash val="solid"/>
+                      <a:round/>
+                      <a:headEnd type="none" w="med" len="med"/>
+                      <a:tailEnd type="none" w="med" len="med"/>
+                    </a:lnL>
+                    <a:lnR w="12700" cap="flat" cmpd="sng" algn="ctr">
+                      <a:solidFill>
+                        <a:srgbClr val="D5DEE5"/>
+                      </a:solidFill>
+                      <a:prstDash val="solid"/>
+                      <a:round/>
+                      <a:headEnd type="none" w="med" len="med"/>
+                      <a:tailEnd type="none" w="med" len="med"/>
+                    </a:lnR>
+                    <a:lnT w="12700" cap="flat" cmpd="sng" algn="ctr">
+                      <a:solidFill>
+                        <a:srgbClr val="D5DEE5"/>
+                      </a:solidFill>
+                      <a:prstDash val="solid"/>
+                      <a:round/>
+                      <a:headEnd type="none" w="med" len="med"/>
+                      <a:tailEnd type="none" w="med" len="med"/>
+                    </a:lnT>
+                    <a:lnB w="12700" cap="flat" cmpd="sng" algn="ctr">
+                      <a:solidFill>
+                        <a:srgbClr val="D5DEE5"/>
+                      </a:solidFill>
+                      <a:prstDash val="solid"/>
+                      <a:round/>
+                      <a:headEnd type="none" w="med" len="med"/>
+                      <a:tailEnd type="none" w="med" len="med"/>
+                    </a:lnB>
+                    <a:solidFill>
+                      <a:srgbClr val="0A3D5C"/>
+                    </a:solidFill>
+                  </a:tcPr>
+                </a:tc>
+                <a:tc>
+                  <a:txBody>
+                    <a:bodyPr/>
+                    <a:lstStyle/>
+                    <a:p>
+                      <a:pPr algn="ctr" indent="0" marL="0">
+                        <a:buNone/>
+                      </a:pPr>
+                      <a:r>
+                        <a:rPr lang="en-US" sz="1150" b="1" dirty="0">
+                          <a:solidFill>
+                            <a:srgbClr val="FFFFFF"/>
+                          </a:solidFill>
+                          <a:latin typeface="Cambria" pitchFamily="34" charset="0"/>
+                          <a:ea typeface="Cambria" pitchFamily="34" charset="-122"/>
+                          <a:cs typeface="Cambria" pitchFamily="34" charset="-120"/>
+                        </a:rPr>
+                        <a:t>Cap</a:t>
+                      </a:r>
+                      <a:endParaRPr lang="en-US" sz="1150" dirty="0">
+                        <a:latin typeface="Cambria" charset="0"/>
+                        <a:ea typeface="Cambria" charset="0"/>
+                        <a:cs typeface="Cambria" charset="0"/>
+                      </a:endParaRPr>
+                    </a:p>
+                  </a:txBody>
+                  <a:tcPr marL="50800" marR="50800" marT="25400" marB="25400" anchor="ctr">
+                    <a:lnL w="12700" cap="flat" cmpd="sng" algn="ctr">
+                      <a:solidFill>
+                        <a:srgbClr val="D5DEE5"/>
+                      </a:solidFill>
+                      <a:prstDash val="solid"/>
+                      <a:round/>
+                      <a:headEnd type="none" w="med" len="med"/>
+                      <a:tailEnd type="none" w="med" len="med"/>
+                    </a:lnL>
+                    <a:lnR w="12700" cap="flat" cmpd="sng" algn="ctr">
+                      <a:solidFill>
+                        <a:srgbClr val="D5DEE5"/>
+                      </a:solidFill>
+                      <a:prstDash val="solid"/>
+                      <a:round/>
+                      <a:headEnd type="none" w="med" len="med"/>
+                      <a:tailEnd type="none" w="med" len="med"/>
+                    </a:lnR>
+                    <a:lnT w="12700" cap="flat" cmpd="sng" algn="ctr">
+                      <a:solidFill>
+                        <a:srgbClr val="D5DEE5"/>
+                      </a:solidFill>
+                      <a:prstDash val="solid"/>
+                      <a:round/>
+                      <a:headEnd type="none" w="med" len="med"/>
+                      <a:tailEnd type="none" w="med" len="med"/>
+                    </a:lnT>
+                    <a:lnB w="12700" cap="flat" cmpd="sng" algn="ctr">
+                      <a:solidFill>
+                        <a:srgbClr val="D5DEE5"/>
+                      </a:solidFill>
+                      <a:prstDash val="solid"/>
+                      <a:round/>
+                      <a:headEnd type="none" w="med" len="med"/>
+                      <a:tailEnd type="none" w="med" len="med"/>
+                    </a:lnB>
+                    <a:solidFill>
+                      <a:srgbClr val="0A3D5C"/>
+                    </a:solidFill>
+                  </a:tcPr>
+                </a:tc>
+                <a:tc>
+                  <a:txBody>
+                    <a:bodyPr/>
+                    <a:lstStyle/>
+                    <a:p>
+                      <a:pPr algn="ctr" indent="0" marL="0">
+                        <a:buNone/>
+                      </a:pPr>
+                      <a:r>
+                        <a:rPr lang="en-US" sz="1150" b="1" dirty="0">
+                          <a:solidFill>
+                            <a:srgbClr val="FFFFFF"/>
+                          </a:solidFill>
+                          <a:latin typeface="Cambria" pitchFamily="34" charset="0"/>
+                          <a:ea typeface="Cambria" pitchFamily="34" charset="-122"/>
+                          <a:cs typeface="Cambria" pitchFamily="34" charset="-120"/>
+                        </a:rPr>
+                        <a:t>LF %</a:t>
+                      </a:r>
+                      <a:endParaRPr lang="en-US" sz="1150" dirty="0">
+                        <a:latin typeface="Cambria" charset="0"/>
+                        <a:ea typeface="Cambria" charset="0"/>
+                        <a:cs typeface="Cambria" charset="0"/>
+                      </a:endParaRPr>
+                    </a:p>
+                  </a:txBody>
+                  <a:tcPr marL="50800" marR="50800" marT="25400" marB="25400" anchor="ctr">
+                    <a:lnL w="12700" cap="flat" cmpd="sng" algn="ctr">
+                      <a:solidFill>
+                        <a:srgbClr val="D5DEE5"/>
+                      </a:solidFill>
+                      <a:prstDash val="solid"/>
+                      <a:round/>
+                      <a:headEnd type="none" w="med" len="med"/>
+                      <a:tailEnd type="none" w="med" len="med"/>
+                    </a:lnL>
+                    <a:lnR w="12700" cap="flat" cmpd="sng" algn="ctr">
+                      <a:solidFill>
+                        <a:srgbClr val="D5DEE5"/>
+                      </a:solidFill>
+                      <a:prstDash val="solid"/>
+                      <a:round/>
+                      <a:headEnd type="none" w="med" len="med"/>
+                      <a:tailEnd type="none" w="med" len="med"/>
+                    </a:lnR>
+                    <a:lnT w="12700" cap="flat" cmpd="sng" algn="ctr">
+                      <a:solidFill>
+                        <a:srgbClr val="D5DEE5"/>
+                      </a:solidFill>
+                      <a:prstDash val="solid"/>
+                      <a:round/>
+                      <a:headEnd type="none" w="med" len="med"/>
+                      <a:tailEnd type="none" w="med" len="med"/>
+                    </a:lnT>
+                    <a:lnB w="12700" cap="flat" cmpd="sng" algn="ctr">
+                      <a:solidFill>
+                        <a:srgbClr val="D5DEE5"/>
+                      </a:solidFill>
+                      <a:prstDash val="solid"/>
+                      <a:round/>
+                      <a:headEnd type="none" w="med" len="med"/>
+                      <a:tailEnd type="none" w="med" len="med"/>
+                    </a:lnB>
+                    <a:solidFill>
+                      <a:srgbClr val="0A3D5C"/>
+                    </a:solidFill>
+                  </a:tcPr>
+                </a:tc>
+                <a:tc>
+                  <a:txBody>
+                    <a:bodyPr/>
+                    <a:lstStyle/>
+                    <a:p>
+                      <a:pPr algn="ctr" indent="0" marL="0">
+                        <a:buNone/>
+                      </a:pPr>
+                      <a:r>
+                        <a:rPr lang="en-US" sz="1150" b="1" dirty="0">
+                          <a:solidFill>
+                            <a:srgbClr val="FFFFFF"/>
+                          </a:solidFill>
+                          <a:latin typeface="Cambria" pitchFamily="34" charset="0"/>
+                          <a:ea typeface="Cambria" pitchFamily="34" charset="-122"/>
+                          <a:cs typeface="Cambria" pitchFamily="34" charset="-120"/>
+                        </a:rPr>
+                        <a:t>Entry Pax</a:t>
+                      </a:r>
+                      <a:endParaRPr lang="en-US" sz="1150" dirty="0">
+                        <a:latin typeface="Cambria" charset="0"/>
+                        <a:ea typeface="Cambria" charset="0"/>
+                        <a:cs typeface="Cambria" charset="0"/>
+                      </a:endParaRPr>
+                    </a:p>
+                  </a:txBody>
+                  <a:tcPr marL="50800" marR="50800" marT="25400" marB="25400" anchor="ctr">
+                    <a:lnL w="12700" cap="flat" cmpd="sng" algn="ctr">
+                      <a:solidFill>
+                        <a:srgbClr val="D5DEE5"/>
+                      </a:solidFill>
+                      <a:prstDash val="solid"/>
+                      <a:round/>
+                      <a:headEnd type="none" w="med" len="med"/>
+                      <a:tailEnd type="none" w="med" len="med"/>
+                    </a:lnL>
+                    <a:lnR w="12700" cap="flat" cmpd="sng" algn="ctr">
+                      <a:solidFill>
+                        <a:srgbClr val="D5DEE5"/>
+                      </a:solidFill>
+                      <a:prstDash val="solid"/>
+                      <a:round/>
+                      <a:headEnd type="none" w="med" len="med"/>
+                      <a:tailEnd type="none" w="med" len="med"/>
+                    </a:lnR>
+                    <a:lnT w="12700" cap="flat" cmpd="sng" algn="ctr">
+                      <a:solidFill>
+                        <a:srgbClr val="D5DEE5"/>
+                      </a:solidFill>
+                      <a:prstDash val="solid"/>
+                      <a:round/>
+                      <a:headEnd type="none" w="med" len="med"/>
+                      <a:tailEnd type="none" w="med" len="med"/>
+                    </a:lnT>
+                    <a:lnB w="12700" cap="flat" cmpd="sng" algn="ctr">
+                      <a:solidFill>
+                        <a:srgbClr val="D5DEE5"/>
+                      </a:solidFill>
+                      <a:prstDash val="solid"/>
+                      <a:round/>
+                      <a:headEnd type="none" w="med" len="med"/>
+                      <a:tailEnd type="none" w="med" len="med"/>
+                    </a:lnB>
+                    <a:solidFill>
+                      <a:srgbClr val="0A3D5C"/>
+                    </a:solidFill>
+                  </a:tcPr>
+                </a:tc>
+                <a:tc>
+                  <a:txBody>
+                    <a:bodyPr/>
+                    <a:lstStyle/>
+                    <a:p>
+                      <a:pPr algn="ctr" indent="0" marL="0">
+                        <a:buNone/>
+                      </a:pPr>
+                      <a:r>
+                        <a:rPr lang="en-US" sz="1150" b="1" dirty="0">
+                          <a:solidFill>
+                            <a:srgbClr val="FFFFFF"/>
+                          </a:solidFill>
+                          <a:latin typeface="Cambria" pitchFamily="34" charset="0"/>
+                          <a:ea typeface="Cambria" pitchFamily="34" charset="-122"/>
+                          <a:cs typeface="Cambria" pitchFamily="34" charset="-120"/>
+                        </a:rPr>
+                        <a:t>Their est.</a:t>
+                      </a:r>
+                      <a:endParaRPr lang="en-US" sz="1150" dirty="0">
+                        <a:latin typeface="Cambria" charset="0"/>
+                        <a:ea typeface="Cambria" charset="0"/>
+                        <a:cs typeface="Cambria" charset="0"/>
+                      </a:endParaRPr>
+                    </a:p>
+                  </a:txBody>
+                  <a:tcPr marL="50800" marR="50800" marT="25400" marB="25400" anchor="ctr">
+                    <a:lnL w="12700" cap="flat" cmpd="sng" algn="ctr">
+                      <a:solidFill>
+                        <a:srgbClr val="D5DEE5"/>
+                      </a:solidFill>
+                      <a:prstDash val="solid"/>
+                      <a:round/>
+                      <a:headEnd type="none" w="med" len="med"/>
+                      <a:tailEnd type="none" w="med" len="med"/>
+                    </a:lnL>
+                    <a:lnR w="12700" cap="flat" cmpd="sng" algn="ctr">
+                      <a:solidFill>
+                        <a:srgbClr val="D5DEE5"/>
+                      </a:solidFill>
+                      <a:prstDash val="solid"/>
+                      <a:round/>
+                      <a:headEnd type="none" w="med" len="med"/>
+                      <a:tailEnd type="none" w="med" len="med"/>
+                    </a:lnR>
+                    <a:lnT w="12700" cap="flat" cmpd="sng" algn="ctr">
+                      <a:solidFill>
+                        <a:srgbClr val="D5DEE5"/>
+                      </a:solidFill>
+                      <a:prstDash val="solid"/>
+                      <a:round/>
+                      <a:headEnd type="none" w="med" len="med"/>
+                      <a:tailEnd type="none" w="med" len="med"/>
+                    </a:lnT>
+                    <a:lnB w="12700" cap="flat" cmpd="sng" algn="ctr">
+                      <a:solidFill>
+                        <a:srgbClr val="D5DEE5"/>
+                      </a:solidFill>
+                      <a:prstDash val="solid"/>
+                      <a:round/>
+                      <a:headEnd type="none" w="med" len="med"/>
+                      <a:tailEnd type="none" w="med" len="med"/>
+                    </a:lnB>
+                    <a:solidFill>
+                      <a:srgbClr val="0A3D5C"/>
+                    </a:solidFill>
+                  </a:tcPr>
+                </a:tc>
+              </a:tr>
+              <a:tr h="475488">
+                <a:tc>
+                  <a:txBody>
+                    <a:bodyPr/>
+                    <a:lstStyle/>
+                    <a:p>
+                      <a:pPr algn="l" indent="0" marL="0">
+                        <a:buNone/>
+                      </a:pPr>
+                      <a:r>
+                        <a:rPr lang="en-US" sz="1250" dirty="0">
+                          <a:solidFill>
+                            <a:srgbClr val="1E2B37"/>
+                          </a:solidFill>
+                          <a:latin typeface="Calibri" pitchFamily="34" charset="0"/>
+                          <a:ea typeface="Calibri" pitchFamily="34" charset="-122"/>
+                          <a:cs typeface="Calibri" pitchFamily="34" charset="-120"/>
+                        </a:rPr>
+                        <a:t>6E6426</a:t>
+                      </a:r>
+                      <a:endParaRPr lang="en-US" sz="1250" dirty="0">
+                        <a:latin typeface="Calibri" charset="0"/>
+                        <a:ea typeface="Calibri" charset="0"/>
+                        <a:cs typeface="Calibri" charset="0"/>
+                      </a:endParaRPr>
+                    </a:p>
+                  </a:txBody>
+                  <a:tcPr marL="50800" marR="50800" marT="25400" marB="25400" anchor="ctr">
+                    <a:lnL w="12700" cap="flat" cmpd="sng" algn="ctr">
+                      <a:solidFill>
+                        <a:srgbClr val="D5DEE5"/>
+                      </a:solidFill>
+                      <a:prstDash val="solid"/>
+                      <a:round/>
+                      <a:headEnd type="none" w="med" len="med"/>
+                      <a:tailEnd type="none" w="med" len="med"/>
+                    </a:lnL>
+                    <a:lnR w="12700" cap="flat" cmpd="sng" algn="ctr">
+                      <a:solidFill>
+                        <a:srgbClr val="D5DEE5"/>
+                      </a:solidFill>
+                      <a:prstDash val="solid"/>
+                      <a:round/>
+                      <a:headEnd type="none" w="med" len="med"/>
+                      <a:tailEnd type="none" w="med" len="med"/>
+                    </a:lnR>
+                    <a:lnT w="12700" cap="flat" cmpd="sng" algn="ctr">
+                      <a:solidFill>
+                        <a:srgbClr val="D5DEE5"/>
+                      </a:solidFill>
+                      <a:prstDash val="solid"/>
+                      <a:round/>
+                      <a:headEnd type="none" w="med" len="med"/>
+                      <a:tailEnd type="none" w="med" len="med"/>
+                    </a:lnT>
+                    <a:lnB w="12700" cap="flat" cmpd="sng" algn="ctr">
+                      <a:solidFill>
+                        <a:srgbClr val="D5DEE5"/>
+                      </a:solidFill>
+                      <a:prstDash val="solid"/>
+                      <a:round/>
+                      <a:headEnd type="none" w="med" len="med"/>
+                      <a:tailEnd type="none" w="med" len="med"/>
+                    </a:lnB>
+                    <a:solidFill>
+                      <a:srgbClr val="F4F7F9"/>
+                    </a:solidFill>
+                  </a:tcPr>
+                </a:tc>
+                <a:tc>
+                  <a:txBody>
+                    <a:bodyPr/>
+                    <a:lstStyle/>
+                    <a:p>
+                      <a:pPr algn="ctr" indent="0" marL="0">
+                        <a:buNone/>
+                      </a:pPr>
+                      <a:r>
+                        <a:rPr lang="en-US" sz="1250" dirty="0">
+                          <a:solidFill>
+                            <a:srgbClr val="1E2B37"/>
+                          </a:solidFill>
+                          <a:latin typeface="Calibri" pitchFamily="34" charset="0"/>
+                          <a:ea typeface="Calibri" pitchFamily="34" charset="-122"/>
+                          <a:cs typeface="Calibri" pitchFamily="34" charset="-120"/>
+                        </a:rPr>
+                        <a:t>A320N</a:t>
+                      </a:r>
+                      <a:endParaRPr lang="en-US" sz="1250" dirty="0">
+                        <a:latin typeface="Calibri" charset="0"/>
+                        <a:ea typeface="Calibri" charset="0"/>
+                        <a:cs typeface="Calibri" charset="0"/>
+                      </a:endParaRPr>
+                    </a:p>
+                  </a:txBody>
+                  <a:tcPr marL="50800" marR="50800" marT="25400" marB="25400" anchor="ctr">
+                    <a:lnL w="12700" cap="flat" cmpd="sng" algn="ctr">
+                      <a:solidFill>
+                        <a:srgbClr val="D5DEE5"/>
+                      </a:solidFill>
+                      <a:prstDash val="solid"/>
+                      <a:round/>
+                      <a:headEnd type="none" w="med" len="med"/>
+                      <a:tailEnd type="none" w="med" len="med"/>
+                    </a:lnL>
+                    <a:lnR w="12700" cap="flat" cmpd="sng" algn="ctr">
+                      <a:solidFill>
+                        <a:srgbClr val="D5DEE5"/>
+                      </a:solidFill>
+                      <a:prstDash val="solid"/>
+                      <a:round/>
+                      <a:headEnd type="none" w="med" len="med"/>
+                      <a:tailEnd type="none" w="med" len="med"/>
+                    </a:lnR>
+                    <a:lnT w="12700" cap="flat" cmpd="sng" algn="ctr">
+                      <a:solidFill>
+                        <a:srgbClr val="D5DEE5"/>
+                      </a:solidFill>
+                      <a:prstDash val="solid"/>
+                      <a:round/>
+                      <a:headEnd type="none" w="med" len="med"/>
+                      <a:tailEnd type="none" w="med" len="med"/>
+                    </a:lnT>
+                    <a:lnB w="12700" cap="flat" cmpd="sng" algn="ctr">
+                      <a:solidFill>
+                        <a:srgbClr val="D5DEE5"/>
+                      </a:solidFill>
+                      <a:prstDash val="solid"/>
+                      <a:round/>
+                      <a:headEnd type="none" w="med" len="med"/>
+                      <a:tailEnd type="none" w="med" len="med"/>
+                    </a:lnB>
+                    <a:solidFill>
+                      <a:srgbClr val="F4F7F9"/>
+                    </a:solidFill>
+                  </a:tcPr>
+                </a:tc>
+                <a:tc>
+                  <a:txBody>
+                    <a:bodyPr/>
+                    <a:lstStyle/>
+                    <a:p>
+                      <a:pPr algn="ctr" indent="0" marL="0">
+                        <a:buNone/>
+                      </a:pPr>
+                      <a:r>
+                        <a:rPr lang="en-US" sz="1250" dirty="0">
+                          <a:solidFill>
+                            <a:srgbClr val="1E2B37"/>
+                          </a:solidFill>
+                          <a:latin typeface="Calibri" pitchFamily="34" charset="0"/>
+                          <a:ea typeface="Calibri" pitchFamily="34" charset="-122"/>
+                          <a:cs typeface="Calibri" pitchFamily="34" charset="-120"/>
+                        </a:rPr>
+                        <a:t>186</a:t>
+                      </a:r>
+                      <a:endParaRPr lang="en-US" sz="1250" dirty="0">
+                        <a:latin typeface="Calibri" charset="0"/>
+                        <a:ea typeface="Calibri" charset="0"/>
+                        <a:cs typeface="Calibri" charset="0"/>
+                      </a:endParaRPr>
+                    </a:p>
+                  </a:txBody>
+                  <a:tcPr marL="50800" marR="50800" marT="25400" marB="25400" anchor="ctr">
+                    <a:lnL w="12700" cap="flat" cmpd="sng" algn="ctr">
+                      <a:solidFill>
+                        <a:srgbClr val="D5DEE5"/>
+                      </a:solidFill>
+                      <a:prstDash val="solid"/>
+                      <a:round/>
+                      <a:headEnd type="none" w="med" len="med"/>
+                      <a:tailEnd type="none" w="med" len="med"/>
+                    </a:lnL>
+                    <a:lnR w="12700" cap="flat" cmpd="sng" algn="ctr">
+                      <a:solidFill>
+                        <a:srgbClr val="D5DEE5"/>
+                      </a:solidFill>
+                      <a:prstDash val="solid"/>
+                      <a:round/>
+                      <a:headEnd type="none" w="med" len="med"/>
+                      <a:tailEnd type="none" w="med" len="med"/>
+                    </a:lnR>
+                    <a:lnT w="12700" cap="flat" cmpd="sng" algn="ctr">
+                      <a:solidFill>
+                        <a:srgbClr val="D5DEE5"/>
+                      </a:solidFill>
+                      <a:prstDash val="solid"/>
+                      <a:round/>
+                      <a:headEnd type="none" w="med" len="med"/>
+                      <a:tailEnd type="none" w="med" len="med"/>
+                    </a:lnT>
+                    <a:lnB w="12700" cap="flat" cmpd="sng" algn="ctr">
+                      <a:solidFill>
+                        <a:srgbClr val="D5DEE5"/>
+                      </a:solidFill>
+                      <a:prstDash val="solid"/>
+                      <a:round/>
+                      <a:headEnd type="none" w="med" len="med"/>
+                      <a:tailEnd type="none" w="med" len="med"/>
+                    </a:lnB>
+                    <a:solidFill>
+                      <a:srgbClr val="F4F7F9"/>
+                    </a:solidFill>
+                  </a:tcPr>
+                </a:tc>
+                <a:tc>
+                  <a:txBody>
+                    <a:bodyPr/>
+                    <a:lstStyle/>
+                    <a:p>
+                      <a:pPr algn="ctr" indent="0" marL="0">
+                        <a:buNone/>
+                      </a:pPr>
+                      <a:r>
+                        <a:rPr lang="en-US" sz="1250" b="1" dirty="0">
+                          <a:solidFill>
+                            <a:srgbClr val="2E8B57"/>
+                          </a:solidFill>
+                          <a:latin typeface="Calibri" pitchFamily="34" charset="0"/>
+                          <a:ea typeface="Calibri" pitchFamily="34" charset="-122"/>
+                          <a:cs typeface="Calibri" pitchFamily="34" charset="-120"/>
+                        </a:rPr>
+                        <a:t>87.5</a:t>
+                      </a:r>
+                      <a:endParaRPr lang="en-US" sz="1250" dirty="0">
+                        <a:latin typeface="Calibri" charset="0"/>
+                        <a:ea typeface="Calibri" charset="0"/>
+                        <a:cs typeface="Calibri" charset="0"/>
+                      </a:endParaRPr>
+                    </a:p>
+                  </a:txBody>
+                  <a:tcPr marL="50800" marR="50800" marT="25400" marB="25400" anchor="ctr">
+                    <a:lnL w="12700" cap="flat" cmpd="sng" algn="ctr">
+                      <a:solidFill>
+                        <a:srgbClr val="D5DEE5"/>
+                      </a:solidFill>
+                      <a:prstDash val="solid"/>
+                      <a:round/>
+                      <a:headEnd type="none" w="med" len="med"/>
+                      <a:tailEnd type="none" w="med" len="med"/>
+                    </a:lnL>
+                    <a:lnR w="12700" cap="flat" cmpd="sng" algn="ctr">
+                      <a:solidFill>
+                        <a:srgbClr val="D5DEE5"/>
+                      </a:solidFill>
+                      <a:prstDash val="solid"/>
+                      <a:round/>
+                      <a:headEnd type="none" w="med" len="med"/>
+                      <a:tailEnd type="none" w="med" len="med"/>
+                    </a:lnR>
+                    <a:lnT w="12700" cap="flat" cmpd="sng" algn="ctr">
+                      <a:solidFill>
+                        <a:srgbClr val="D5DEE5"/>
+                      </a:solidFill>
+                      <a:prstDash val="solid"/>
+                      <a:round/>
+                      <a:headEnd type="none" w="med" len="med"/>
+                      <a:tailEnd type="none" w="med" len="med"/>
+                    </a:lnT>
+                    <a:lnB w="12700" cap="flat" cmpd="sng" algn="ctr">
+                      <a:solidFill>
+                        <a:srgbClr val="D5DEE5"/>
+                      </a:solidFill>
+                      <a:prstDash val="solid"/>
+                      <a:round/>
+                      <a:headEnd type="none" w="med" len="med"/>
+                      <a:tailEnd type="none" w="med" len="med"/>
+                    </a:lnB>
+                    <a:solidFill>
+                      <a:srgbClr val="F4F7F9"/>
+                    </a:solidFill>
+                  </a:tcPr>
+                </a:tc>
+                <a:tc>
+                  <a:txBody>
+                    <a:bodyPr/>
+                    <a:lstStyle/>
+                    <a:p>
+                      <a:pPr algn="ctr" indent="0" marL="0">
+                        <a:buNone/>
+                      </a:pPr>
+                      <a:r>
+                        <a:rPr lang="en-US" sz="1250" b="1" dirty="0">
+                          <a:solidFill>
+                            <a:srgbClr val="2E8B57"/>
+                          </a:solidFill>
+                          <a:latin typeface="Calibri" pitchFamily="34" charset="0"/>
+                          <a:ea typeface="Calibri" pitchFamily="34" charset="-122"/>
+                          <a:cs typeface="Calibri" pitchFamily="34" charset="-120"/>
+                        </a:rPr>
+                        <a:t>163</a:t>
+                      </a:r>
+                      <a:endParaRPr lang="en-US" sz="1250" dirty="0">
+                        <a:latin typeface="Calibri" charset="0"/>
+                        <a:ea typeface="Calibri" charset="0"/>
+                        <a:cs typeface="Calibri" charset="0"/>
+                      </a:endParaRPr>
+                    </a:p>
+                  </a:txBody>
+                  <a:tcPr marL="50800" marR="50800" marT="25400" marB="25400" anchor="ctr">
+                    <a:lnL w="12700" cap="flat" cmpd="sng" algn="ctr">
+                      <a:solidFill>
+                        <a:srgbClr val="D5DEE5"/>
+                      </a:solidFill>
+                      <a:prstDash val="solid"/>
+                      <a:round/>
+                      <a:headEnd type="none" w="med" len="med"/>
+                      <a:tailEnd type="none" w="med" len="med"/>
+                    </a:lnL>
+                    <a:lnR w="12700" cap="flat" cmpd="sng" algn="ctr">
+                      <a:solidFill>
+                        <a:srgbClr val="D5DEE5"/>
+                      </a:solidFill>
+                      <a:prstDash val="solid"/>
+                      <a:round/>
+                      <a:headEnd type="none" w="med" len="med"/>
+                      <a:tailEnd type="none" w="med" len="med"/>
+                    </a:lnR>
+                    <a:lnT w="12700" cap="flat" cmpd="sng" algn="ctr">
+                      <a:solidFill>
+                        <a:srgbClr val="D5DEE5"/>
+                      </a:solidFill>
+                      <a:prstDash val="solid"/>
+                      <a:round/>
+                      <a:headEnd type="none" w="med" len="med"/>
+                      <a:tailEnd type="none" w="med" len="med"/>
+                    </a:lnT>
+                    <a:lnB w="12700" cap="flat" cmpd="sng" algn="ctr">
+                      <a:solidFill>
+                        <a:srgbClr val="D5DEE5"/>
+                      </a:solidFill>
+                      <a:prstDash val="solid"/>
+                      <a:round/>
+                      <a:headEnd type="none" w="med" len="med"/>
+                      <a:tailEnd type="none" w="med" len="med"/>
+                    </a:lnB>
+                    <a:solidFill>
+                      <a:srgbClr val="F4F7F9"/>
+                    </a:solidFill>
+                  </a:tcPr>
+                </a:tc>
+                <a:tc>
+                  <a:txBody>
+                    <a:bodyPr/>
+                    <a:lstStyle/>
+                    <a:p>
+                      <a:pPr algn="ctr" indent="0" marL="0">
+                        <a:buNone/>
+                      </a:pPr>
+                      <a:r>
+                        <a:rPr lang="en-US" sz="1250" dirty="0">
+                          <a:solidFill>
+                            <a:srgbClr val="0B6E99"/>
+                          </a:solidFill>
+                          <a:latin typeface="Calibri" pitchFamily="34" charset="0"/>
+                          <a:ea typeface="Calibri" pitchFamily="34" charset="-122"/>
+                          <a:cs typeface="Calibri" pitchFamily="34" charset="-120"/>
+                        </a:rPr>
+                        <a:t>163.1</a:t>
+                      </a:r>
+                      <a:endParaRPr lang="en-US" sz="1250" dirty="0">
+                        <a:latin typeface="Calibri" charset="0"/>
+                        <a:ea typeface="Calibri" charset="0"/>
+                        <a:cs typeface="Calibri" charset="0"/>
+                      </a:endParaRPr>
+                    </a:p>
+                  </a:txBody>
+                  <a:tcPr marL="50800" marR="50800" marT="25400" marB="25400" anchor="ctr">
+                    <a:lnL w="12700" cap="flat" cmpd="sng" algn="ctr">
+                      <a:solidFill>
+                        <a:srgbClr val="D5DEE5"/>
+                      </a:solidFill>
+                      <a:prstDash val="solid"/>
+                      <a:round/>
+                      <a:headEnd type="none" w="med" len="med"/>
+                      <a:tailEnd type="none" w="med" len="med"/>
+                    </a:lnL>
+                    <a:lnR w="12700" cap="flat" cmpd="sng" algn="ctr">
+                      <a:solidFill>
+                        <a:srgbClr val="D5DEE5"/>
+                      </a:solidFill>
+                      <a:prstDash val="solid"/>
+                      <a:round/>
+                      <a:headEnd type="none" w="med" len="med"/>
+                      <a:tailEnd type="none" w="med" len="med"/>
+                    </a:lnR>
+                    <a:lnT w="12700" cap="flat" cmpd="sng" algn="ctr">
+                      <a:solidFill>
+                        <a:srgbClr val="D5DEE5"/>
+                      </a:solidFill>
+                      <a:prstDash val="solid"/>
+                      <a:round/>
+                      <a:headEnd type="none" w="med" len="med"/>
+                      <a:tailEnd type="none" w="med" len="med"/>
+                    </a:lnT>
+                    <a:lnB w="12700" cap="flat" cmpd="sng" algn="ctr">
+                      <a:solidFill>
+                        <a:srgbClr val="D5DEE5"/>
+                      </a:solidFill>
+                      <a:prstDash val="solid"/>
+                      <a:round/>
+                      <a:headEnd type="none" w="med" len="med"/>
+                      <a:tailEnd type="none" w="med" len="med"/>
+                    </a:lnB>
+                    <a:solidFill>
+                      <a:srgbClr val="F4F7F9"/>
+                    </a:solidFill>
+                  </a:tcPr>
+                </a:tc>
+              </a:tr>
+              <a:tr h="475488">
+                <a:tc>
+                  <a:txBody>
+                    <a:bodyPr/>
+                    <a:lstStyle/>
+                    <a:p>
+                      <a:pPr algn="l" indent="0" marL="0">
+                        <a:buNone/>
+                      </a:pPr>
+                      <a:r>
+                        <a:rPr lang="en-US" sz="1250" dirty="0">
+                          <a:solidFill>
+                            <a:srgbClr val="1E2B37"/>
+                          </a:solidFill>
+                          <a:latin typeface="Calibri" pitchFamily="34" charset="0"/>
+                          <a:ea typeface="Calibri" pitchFamily="34" charset="-122"/>
+                          <a:cs typeface="Calibri" pitchFamily="34" charset="-120"/>
+                        </a:rPr>
+                        <a:t>6E845</a:t>
+                      </a:r>
+                      <a:endParaRPr lang="en-US" sz="1250" dirty="0">
+                        <a:latin typeface="Calibri" charset="0"/>
+                        <a:ea typeface="Calibri" charset="0"/>
+                        <a:cs typeface="Calibri" charset="0"/>
+                      </a:endParaRPr>
+                    </a:p>
+                  </a:txBody>
+                  <a:tcPr marL="50800" marR="50800" marT="25400" marB="25400" anchor="ctr">
+                    <a:lnL w="12700" cap="flat" cmpd="sng" algn="ctr">
+                      <a:solidFill>
+                        <a:srgbClr val="D5DEE5"/>
+                      </a:solidFill>
+                      <a:prstDash val="solid"/>
+                      <a:round/>
+                      <a:headEnd type="none" w="med" len="med"/>
+                      <a:tailEnd type="none" w="med" len="med"/>
+                    </a:lnL>
+                    <a:lnR w="12700" cap="flat" cmpd="sng" algn="ctr">
+                      <a:solidFill>
+                        <a:srgbClr val="D5DEE5"/>
+                      </a:solidFill>
+                      <a:prstDash val="solid"/>
+                      <a:round/>
+                      <a:headEnd type="none" w="med" len="med"/>
+                      <a:tailEnd type="none" w="med" len="med"/>
+                    </a:lnR>
+                    <a:lnT w="12700" cap="flat" cmpd="sng" algn="ctr">
+                      <a:solidFill>
+                        <a:srgbClr val="D5DEE5"/>
+                      </a:solidFill>
+                      <a:prstDash val="solid"/>
+                      <a:round/>
+                      <a:headEnd type="none" w="med" len="med"/>
+                      <a:tailEnd type="none" w="med" len="med"/>
+                    </a:lnT>
+                    <a:lnB w="12700" cap="flat" cmpd="sng" algn="ctr">
+                      <a:solidFill>
+                        <a:srgbClr val="D5DEE5"/>
+                      </a:solidFill>
+                      <a:prstDash val="solid"/>
+                      <a:round/>
+                      <a:headEnd type="none" w="med" len="med"/>
+                      <a:tailEnd type="none" w="med" len="med"/>
+                    </a:lnB>
+                    <a:solidFill>
+                      <a:srgbClr val="FFFFFF"/>
+                    </a:solidFill>
+                  </a:tcPr>
+                </a:tc>
+                <a:tc>
+                  <a:txBody>
+                    <a:bodyPr/>
+                    <a:lstStyle/>
+                    <a:p>
+                      <a:pPr algn="ctr" indent="0" marL="0">
+                        <a:buNone/>
+                      </a:pPr>
+                      <a:r>
+                        <a:rPr lang="en-US" sz="1250" dirty="0">
+                          <a:solidFill>
+                            <a:srgbClr val="1E2B37"/>
+                          </a:solidFill>
+                          <a:latin typeface="Calibri" pitchFamily="34" charset="0"/>
+                          <a:ea typeface="Calibri" pitchFamily="34" charset="-122"/>
+                          <a:cs typeface="Calibri" pitchFamily="34" charset="-120"/>
+                        </a:rPr>
+                        <a:t>A320</a:t>
+                      </a:r>
+                      <a:endParaRPr lang="en-US" sz="1250" dirty="0">
+                        <a:latin typeface="Calibri" charset="0"/>
+                        <a:ea typeface="Calibri" charset="0"/>
+                        <a:cs typeface="Calibri" charset="0"/>
+                      </a:endParaRPr>
+                    </a:p>
+                  </a:txBody>
+                  <a:tcPr marL="50800" marR="50800" marT="25400" marB="25400" anchor="ctr">
+                    <a:lnL w="12700" cap="flat" cmpd="sng" algn="ctr">
+                      <a:solidFill>
+                        <a:srgbClr val="D5DEE5"/>
+                      </a:solidFill>
+                      <a:prstDash val="solid"/>
+                      <a:round/>
+                      <a:headEnd type="none" w="med" len="med"/>
+                      <a:tailEnd type="none" w="med" len="med"/>
+                    </a:lnL>
+                    <a:lnR w="12700" cap="flat" cmpd="sng" algn="ctr">
+                      <a:solidFill>
+                        <a:srgbClr val="D5DEE5"/>
+                      </a:solidFill>
+                      <a:prstDash val="solid"/>
+                      <a:round/>
+                      <a:headEnd type="none" w="med" len="med"/>
+                      <a:tailEnd type="none" w="med" len="med"/>
+                    </a:lnR>
+                    <a:lnT w="12700" cap="flat" cmpd="sng" algn="ctr">
+                      <a:solidFill>
+                        <a:srgbClr val="D5DEE5"/>
+                      </a:solidFill>
+                      <a:prstDash val="solid"/>
+                      <a:round/>
+                      <a:headEnd type="none" w="med" len="med"/>
+                      <a:tailEnd type="none" w="med" len="med"/>
+                    </a:lnT>
+                    <a:lnB w="12700" cap="flat" cmpd="sng" algn="ctr">
+                      <a:solidFill>
+                        <a:srgbClr val="D5DEE5"/>
+                      </a:solidFill>
+                      <a:prstDash val="solid"/>
+                      <a:round/>
+                      <a:headEnd type="none" w="med" len="med"/>
+                      <a:tailEnd type="none" w="med" len="med"/>
+                    </a:lnB>
+                    <a:solidFill>
+                      <a:srgbClr val="FFFFFF"/>
+                    </a:solidFill>
+                  </a:tcPr>
+                </a:tc>
+                <a:tc>
+                  <a:txBody>
+                    <a:bodyPr/>
+                    <a:lstStyle/>
+                    <a:p>
+                      <a:pPr algn="ctr" indent="0" marL="0">
+                        <a:buNone/>
+                      </a:pPr>
+                      <a:r>
+                        <a:rPr lang="en-US" sz="1250" dirty="0">
+                          <a:solidFill>
+                            <a:srgbClr val="1E2B37"/>
+                          </a:solidFill>
+                          <a:latin typeface="Calibri" pitchFamily="34" charset="0"/>
+                          <a:ea typeface="Calibri" pitchFamily="34" charset="-122"/>
+                          <a:cs typeface="Calibri" pitchFamily="34" charset="-120"/>
+                        </a:rPr>
+                        <a:t>186</a:t>
+                      </a:r>
+                      <a:endParaRPr lang="en-US" sz="1250" dirty="0">
+                        <a:latin typeface="Calibri" charset="0"/>
+                        <a:ea typeface="Calibri" charset="0"/>
+                        <a:cs typeface="Calibri" charset="0"/>
+                      </a:endParaRPr>
+                    </a:p>
+                  </a:txBody>
+                  <a:tcPr marL="50800" marR="50800" marT="25400" marB="25400" anchor="ctr">
+                    <a:lnL w="12700" cap="flat" cmpd="sng" algn="ctr">
+                      <a:solidFill>
+                        <a:srgbClr val="D5DEE5"/>
+                      </a:solidFill>
+                      <a:prstDash val="solid"/>
+                      <a:round/>
+                      <a:headEnd type="none" w="med" len="med"/>
+                      <a:tailEnd type="none" w="med" len="med"/>
+                    </a:lnL>
+                    <a:lnR w="12700" cap="flat" cmpd="sng" algn="ctr">
+                      <a:solidFill>
+                        <a:srgbClr val="D5DEE5"/>
+                      </a:solidFill>
+                      <a:prstDash val="solid"/>
+                      <a:round/>
+                      <a:headEnd type="none" w="med" len="med"/>
+                      <a:tailEnd type="none" w="med" len="med"/>
+                    </a:lnR>
+                    <a:lnT w="12700" cap="flat" cmpd="sng" algn="ctr">
+                      <a:solidFill>
+                        <a:srgbClr val="D5DEE5"/>
+                      </a:solidFill>
+                      <a:prstDash val="solid"/>
+                      <a:round/>
+                      <a:headEnd type="none" w="med" len="med"/>
+                      <a:tailEnd type="none" w="med" len="med"/>
+                    </a:lnT>
+                    <a:lnB w="12700" cap="flat" cmpd="sng" algn="ctr">
+                      <a:solidFill>
+                        <a:srgbClr val="D5DEE5"/>
+                      </a:solidFill>
+                      <a:prstDash val="solid"/>
+                      <a:round/>
+                      <a:headEnd type="none" w="med" len="med"/>
+                      <a:tailEnd type="none" w="med" len="med"/>
+                    </a:lnB>
+                    <a:solidFill>
+                      <a:srgbClr val="FFFFFF"/>
+                    </a:solidFill>
+                  </a:tcPr>
+                </a:tc>
+                <a:tc>
+                  <a:txBody>
+                    <a:bodyPr/>
+                    <a:lstStyle/>
+                    <a:p>
+                      <a:pPr algn="ctr" indent="0" marL="0">
+                        <a:buNone/>
+                      </a:pPr>
+                      <a:r>
+                        <a:rPr lang="en-US" sz="1250" b="1" dirty="0">
+                          <a:solidFill>
+                            <a:srgbClr val="2E8B57"/>
+                          </a:solidFill>
+                          <a:latin typeface="Calibri" pitchFamily="34" charset="0"/>
+                          <a:ea typeface="Calibri" pitchFamily="34" charset="-122"/>
+                          <a:cs typeface="Calibri" pitchFamily="34" charset="-120"/>
+                        </a:rPr>
+                        <a:t>87.5</a:t>
+                      </a:r>
+                      <a:endParaRPr lang="en-US" sz="1250" dirty="0">
+                        <a:latin typeface="Calibri" charset="0"/>
+                        <a:ea typeface="Calibri" charset="0"/>
+                        <a:cs typeface="Calibri" charset="0"/>
+                      </a:endParaRPr>
+                    </a:p>
+                  </a:txBody>
+                  <a:tcPr marL="50800" marR="50800" marT="25400" marB="25400" anchor="ctr">
+                    <a:lnL w="12700" cap="flat" cmpd="sng" algn="ctr">
+                      <a:solidFill>
+                        <a:srgbClr val="D5DEE5"/>
+                      </a:solidFill>
+                      <a:prstDash val="solid"/>
+                      <a:round/>
+                      <a:headEnd type="none" w="med" len="med"/>
+                      <a:tailEnd type="none" w="med" len="med"/>
+                    </a:lnL>
+                    <a:lnR w="12700" cap="flat" cmpd="sng" algn="ctr">
+                      <a:solidFill>
+                        <a:srgbClr val="D5DEE5"/>
+                      </a:solidFill>
+                      <a:prstDash val="solid"/>
+                      <a:round/>
+                      <a:headEnd type="none" w="med" len="med"/>
+                      <a:tailEnd type="none" w="med" len="med"/>
+                    </a:lnR>
+                    <a:lnT w="12700" cap="flat" cmpd="sng" algn="ctr">
+                      <a:solidFill>
+                        <a:srgbClr val="D5DEE5"/>
+                      </a:solidFill>
+                      <a:prstDash val="solid"/>
+                      <a:round/>
+                      <a:headEnd type="none" w="med" len="med"/>
+                      <a:tailEnd type="none" w="med" len="med"/>
+                    </a:lnT>
+                    <a:lnB w="12700" cap="flat" cmpd="sng" algn="ctr">
+                      <a:solidFill>
+                        <a:srgbClr val="D5DEE5"/>
+                      </a:solidFill>
+                      <a:prstDash val="solid"/>
+                      <a:round/>
+                      <a:headEnd type="none" w="med" len="med"/>
+                      <a:tailEnd type="none" w="med" len="med"/>
+                    </a:lnB>
+                    <a:solidFill>
+                      <a:srgbClr val="FFFFFF"/>
+                    </a:solidFill>
+                  </a:tcPr>
+                </a:tc>
+                <a:tc>
+                  <a:txBody>
+                    <a:bodyPr/>
+                    <a:lstStyle/>
+                    <a:p>
+                      <a:pPr algn="ctr" indent="0" marL="0">
+                        <a:buNone/>
+                      </a:pPr>
+                      <a:r>
+                        <a:rPr lang="en-US" sz="1250" b="1" dirty="0">
+                          <a:solidFill>
+                            <a:srgbClr val="2E8B57"/>
+                          </a:solidFill>
+                          <a:latin typeface="Calibri" pitchFamily="34" charset="0"/>
+                          <a:ea typeface="Calibri" pitchFamily="34" charset="-122"/>
+                          <a:cs typeface="Calibri" pitchFamily="34" charset="-120"/>
+                        </a:rPr>
+                        <a:t>163</a:t>
+                      </a:r>
+                      <a:endParaRPr lang="en-US" sz="1250" dirty="0">
+                        <a:latin typeface="Calibri" charset="0"/>
+                        <a:ea typeface="Calibri" charset="0"/>
+                        <a:cs typeface="Calibri" charset="0"/>
+                      </a:endParaRPr>
+                    </a:p>
+                  </a:txBody>
+                  <a:tcPr marL="50800" marR="50800" marT="25400" marB="25400" anchor="ctr">
+                    <a:lnL w="12700" cap="flat" cmpd="sng" algn="ctr">
+                      <a:solidFill>
+                        <a:srgbClr val="D5DEE5"/>
+                      </a:solidFill>
+                      <a:prstDash val="solid"/>
+                      <a:round/>
+                      <a:headEnd type="none" w="med" len="med"/>
+                      <a:tailEnd type="none" w="med" len="med"/>
+                    </a:lnL>
+                    <a:lnR w="12700" cap="flat" cmpd="sng" algn="ctr">
+                      <a:solidFill>
+                        <a:srgbClr val="D5DEE5"/>
+                      </a:solidFill>
+                      <a:prstDash val="solid"/>
+                      <a:round/>
+                      <a:headEnd type="none" w="med" len="med"/>
+                      <a:tailEnd type="none" w="med" len="med"/>
+                    </a:lnR>
+                    <a:lnT w="12700" cap="flat" cmpd="sng" algn="ctr">
+                      <a:solidFill>
+                        <a:srgbClr val="D5DEE5"/>
+                      </a:solidFill>
+                      <a:prstDash val="solid"/>
+                      <a:round/>
+                      <a:headEnd type="none" w="med" len="med"/>
+                      <a:tailEnd type="none" w="med" len="med"/>
+                    </a:lnT>
+                    <a:lnB w="12700" cap="flat" cmpd="sng" algn="ctr">
+                      <a:solidFill>
+                        <a:srgbClr val="D5DEE5"/>
+                      </a:solidFill>
+                      <a:prstDash val="solid"/>
+                      <a:round/>
+                      <a:headEnd type="none" w="med" len="med"/>
+                      <a:tailEnd type="none" w="med" len="med"/>
+                    </a:lnB>
+                    <a:solidFill>
+                      <a:srgbClr val="FFFFFF"/>
+                    </a:solidFill>
+                  </a:tcPr>
+                </a:tc>
+                <a:tc>
+                  <a:txBody>
+                    <a:bodyPr/>
+                    <a:lstStyle/>
+                    <a:p>
+                      <a:pPr algn="ctr" indent="0" marL="0">
+                        <a:buNone/>
+                      </a:pPr>
+                      <a:r>
+                        <a:rPr lang="en-US" sz="1250" dirty="0">
+                          <a:solidFill>
+                            <a:srgbClr val="0B6E99"/>
+                          </a:solidFill>
+                          <a:latin typeface="Calibri" pitchFamily="34" charset="0"/>
+                          <a:ea typeface="Calibri" pitchFamily="34" charset="-122"/>
+                          <a:cs typeface="Calibri" pitchFamily="34" charset="-120"/>
+                        </a:rPr>
+                        <a:t>163.1</a:t>
+                      </a:r>
+                      <a:endParaRPr lang="en-US" sz="1250" dirty="0">
+                        <a:latin typeface="Calibri" charset="0"/>
+                        <a:ea typeface="Calibri" charset="0"/>
+                        <a:cs typeface="Calibri" charset="0"/>
+                      </a:endParaRPr>
+                    </a:p>
+                  </a:txBody>
+                  <a:tcPr marL="50800" marR="50800" marT="25400" marB="25400" anchor="ctr">
+                    <a:lnL w="12700" cap="flat" cmpd="sng" algn="ctr">
+                      <a:solidFill>
+                        <a:srgbClr val="D5DEE5"/>
+                      </a:solidFill>
+                      <a:prstDash val="solid"/>
+                      <a:round/>
+                      <a:headEnd type="none" w="med" len="med"/>
+                      <a:tailEnd type="none" w="med" len="med"/>
+                    </a:lnL>
+                    <a:lnR w="12700" cap="flat" cmpd="sng" algn="ctr">
+                      <a:solidFill>
+                        <a:srgbClr val="D5DEE5"/>
+                      </a:solidFill>
+                      <a:prstDash val="solid"/>
+                      <a:round/>
+                      <a:headEnd type="none" w="med" len="med"/>
+                      <a:tailEnd type="none" w="med" len="med"/>
+                    </a:lnR>
+                    <a:lnT w="12700" cap="flat" cmpd="sng" algn="ctr">
+                      <a:solidFill>
+                        <a:srgbClr val="D5DEE5"/>
+                      </a:solidFill>
+                      <a:prstDash val="solid"/>
+                      <a:round/>
+                      <a:headEnd type="none" w="med" len="med"/>
+                      <a:tailEnd type="none" w="med" len="med"/>
+                    </a:lnT>
+                    <a:lnB w="12700" cap="flat" cmpd="sng" algn="ctr">
+                      <a:solidFill>
+                        <a:srgbClr val="D5DEE5"/>
+                      </a:solidFill>
+                      <a:prstDash val="solid"/>
+                      <a:round/>
+                      <a:headEnd type="none" w="med" len="med"/>
+                      <a:tailEnd type="none" w="med" len="med"/>
+                    </a:lnB>
+                    <a:solidFill>
+                      <a:srgbClr val="FFFFFF"/>
+                    </a:solidFill>
+                  </a:tcPr>
+                </a:tc>
+              </a:tr>
+              <a:tr h="475488">
+                <a:tc>
+                  <a:txBody>
+                    <a:bodyPr/>
+                    <a:lstStyle/>
+                    <a:p>
+                      <a:pPr algn="l" indent="0" marL="0">
+                        <a:buNone/>
+                      </a:pPr>
+                      <a:r>
+                        <a:rPr lang="en-US" sz="1250" dirty="0">
+                          <a:solidFill>
+                            <a:srgbClr val="1E2B37"/>
+                          </a:solidFill>
+                          <a:latin typeface="Calibri" pitchFamily="34" charset="0"/>
+                          <a:ea typeface="Calibri" pitchFamily="34" charset="-122"/>
+                          <a:cs typeface="Calibri" pitchFamily="34" charset="-120"/>
+                        </a:rPr>
+                        <a:t>IX2745</a:t>
+                      </a:r>
+                      <a:endParaRPr lang="en-US" sz="1250" dirty="0">
+                        <a:latin typeface="Calibri" charset="0"/>
+                        <a:ea typeface="Calibri" charset="0"/>
+                        <a:cs typeface="Calibri" charset="0"/>
+                      </a:endParaRPr>
+                    </a:p>
+                  </a:txBody>
+                  <a:tcPr marL="50800" marR="50800" marT="25400" marB="25400" anchor="ctr">
+                    <a:lnL w="12700" cap="flat" cmpd="sng" algn="ctr">
+                      <a:solidFill>
+                        <a:srgbClr val="D5DEE5"/>
+                      </a:solidFill>
+                      <a:prstDash val="solid"/>
+                      <a:round/>
+                      <a:headEnd type="none" w="med" len="med"/>
+                      <a:tailEnd type="none" w="med" len="med"/>
+                    </a:lnL>
+                    <a:lnR w="12700" cap="flat" cmpd="sng" algn="ctr">
+                      <a:solidFill>
+                        <a:srgbClr val="D5DEE5"/>
+                      </a:solidFill>
+                      <a:prstDash val="solid"/>
+                      <a:round/>
+                      <a:headEnd type="none" w="med" len="med"/>
+                      <a:tailEnd type="none" w="med" len="med"/>
+                    </a:lnR>
+                    <a:lnT w="12700" cap="flat" cmpd="sng" algn="ctr">
+                      <a:solidFill>
+                        <a:srgbClr val="D5DEE5"/>
+                      </a:solidFill>
+                      <a:prstDash val="solid"/>
+                      <a:round/>
+                      <a:headEnd type="none" w="med" len="med"/>
+                      <a:tailEnd type="none" w="med" len="med"/>
+                    </a:lnT>
+                    <a:lnB w="12700" cap="flat" cmpd="sng" algn="ctr">
+                      <a:solidFill>
+                        <a:srgbClr val="D5DEE5"/>
+                      </a:solidFill>
+                      <a:prstDash val="solid"/>
+                      <a:round/>
+                      <a:headEnd type="none" w="med" len="med"/>
+                      <a:tailEnd type="none" w="med" len="med"/>
+                    </a:lnB>
+                    <a:solidFill>
+                      <a:srgbClr val="F4F7F9"/>
+                    </a:solidFill>
+                  </a:tcPr>
+                </a:tc>
+                <a:tc>
+                  <a:txBody>
+                    <a:bodyPr/>
+                    <a:lstStyle/>
+                    <a:p>
+                      <a:pPr algn="ctr" indent="0" marL="0">
+                        <a:buNone/>
+                      </a:pPr>
+                      <a:r>
+                        <a:rPr lang="en-US" sz="1250" dirty="0">
+                          <a:solidFill>
+                            <a:srgbClr val="1E2B37"/>
+                          </a:solidFill>
+                          <a:latin typeface="Calibri" pitchFamily="34" charset="0"/>
+                          <a:ea typeface="Calibri" pitchFamily="34" charset="-122"/>
+                          <a:cs typeface="Calibri" pitchFamily="34" charset="-120"/>
+                        </a:rPr>
+                        <a:t>B737</a:t>
+                      </a:r>
+                      <a:endParaRPr lang="en-US" sz="1250" dirty="0">
+                        <a:latin typeface="Calibri" charset="0"/>
+                        <a:ea typeface="Calibri" charset="0"/>
+                        <a:cs typeface="Calibri" charset="0"/>
+                      </a:endParaRPr>
+                    </a:p>
+                  </a:txBody>
+                  <a:tcPr marL="50800" marR="50800" marT="25400" marB="25400" anchor="ctr">
+                    <a:lnL w="12700" cap="flat" cmpd="sng" algn="ctr">
+                      <a:solidFill>
+                        <a:srgbClr val="D5DEE5"/>
+                      </a:solidFill>
+                      <a:prstDash val="solid"/>
+                      <a:round/>
+                      <a:headEnd type="none" w="med" len="med"/>
+                      <a:tailEnd type="none" w="med" len="med"/>
+                    </a:lnL>
+                    <a:lnR w="12700" cap="flat" cmpd="sng" algn="ctr">
+                      <a:solidFill>
+                        <a:srgbClr val="D5DEE5"/>
+                      </a:solidFill>
+                      <a:prstDash val="solid"/>
+                      <a:round/>
+                      <a:headEnd type="none" w="med" len="med"/>
+                      <a:tailEnd type="none" w="med" len="med"/>
+                    </a:lnR>
+                    <a:lnT w="12700" cap="flat" cmpd="sng" algn="ctr">
+                      <a:solidFill>
+                        <a:srgbClr val="D5DEE5"/>
+                      </a:solidFill>
+                      <a:prstDash val="solid"/>
+                      <a:round/>
+                      <a:headEnd type="none" w="med" len="med"/>
+                      <a:tailEnd type="none" w="med" len="med"/>
+                    </a:lnT>
+                    <a:lnB w="12700" cap="flat" cmpd="sng" algn="ctr">
+                      <a:solidFill>
+                        <a:srgbClr val="D5DEE5"/>
+                      </a:solidFill>
+                      <a:prstDash val="solid"/>
+                      <a:round/>
+                      <a:headEnd type="none" w="med" len="med"/>
+                      <a:tailEnd type="none" w="med" len="med"/>
+                    </a:lnB>
+                    <a:solidFill>
+                      <a:srgbClr val="F4F7F9"/>
+                    </a:solidFill>
+                  </a:tcPr>
+                </a:tc>
+                <a:tc>
+                  <a:txBody>
+                    <a:bodyPr/>
+                    <a:lstStyle/>
+                    <a:p>
+                      <a:pPr algn="ctr" indent="0" marL="0">
+                        <a:buNone/>
+                      </a:pPr>
+                      <a:r>
+                        <a:rPr lang="en-US" sz="1250" dirty="0">
+                          <a:solidFill>
+                            <a:srgbClr val="1E2B37"/>
+                          </a:solidFill>
+                          <a:latin typeface="Calibri" pitchFamily="34" charset="0"/>
+                          <a:ea typeface="Calibri" pitchFamily="34" charset="-122"/>
+                          <a:cs typeface="Calibri" pitchFamily="34" charset="-120"/>
+                        </a:rPr>
+                        <a:t>189</a:t>
+                      </a:r>
+                      <a:endParaRPr lang="en-US" sz="1250" dirty="0">
+                        <a:latin typeface="Calibri" charset="0"/>
+                        <a:ea typeface="Calibri" charset="0"/>
+                        <a:cs typeface="Calibri" charset="0"/>
+                      </a:endParaRPr>
+                    </a:p>
+                  </a:txBody>
+                  <a:tcPr marL="50800" marR="50800" marT="25400" marB="25400" anchor="ctr">
+                    <a:lnL w="12700" cap="flat" cmpd="sng" algn="ctr">
+                      <a:solidFill>
+                        <a:srgbClr val="D5DEE5"/>
+                      </a:solidFill>
+                      <a:prstDash val="solid"/>
+                      <a:round/>
+                      <a:headEnd type="none" w="med" len="med"/>
+                      <a:tailEnd type="none" w="med" len="med"/>
+                    </a:lnL>
+                    <a:lnR w="12700" cap="flat" cmpd="sng" algn="ctr">
+                      <a:solidFill>
+                        <a:srgbClr val="D5DEE5"/>
+                      </a:solidFill>
+                      <a:prstDash val="solid"/>
+                      <a:round/>
+                      <a:headEnd type="none" w="med" len="med"/>
+                      <a:tailEnd type="none" w="med" len="med"/>
+                    </a:lnR>
+                    <a:lnT w="12700" cap="flat" cmpd="sng" algn="ctr">
+                      <a:solidFill>
+                        <a:srgbClr val="D5DEE5"/>
+                      </a:solidFill>
+                      <a:prstDash val="solid"/>
+                      <a:round/>
+                      <a:headEnd type="none" w="med" len="med"/>
+                      <a:tailEnd type="none" w="med" len="med"/>
+                    </a:lnT>
+                    <a:lnB w="12700" cap="flat" cmpd="sng" algn="ctr">
+                      <a:solidFill>
+                        <a:srgbClr val="D5DEE5"/>
+                      </a:solidFill>
+                      <a:prstDash val="solid"/>
+                      <a:round/>
+                      <a:headEnd type="none" w="med" len="med"/>
+                      <a:tailEnd type="none" w="med" len="med"/>
+                    </a:lnB>
+                    <a:solidFill>
+                      <a:srgbClr val="F4F7F9"/>
+                    </a:solidFill>
+                  </a:tcPr>
+                </a:tc>
+                <a:tc>
+                  <a:txBody>
+                    <a:bodyPr/>
+                    <a:lstStyle/>
+                    <a:p>
+                      <a:pPr algn="ctr" indent="0" marL="0">
+                        <a:buNone/>
+                      </a:pPr>
+                      <a:r>
+                        <a:rPr lang="en-US" sz="1250" b="1" dirty="0">
+                          <a:solidFill>
+                            <a:srgbClr val="2E8B57"/>
+                          </a:solidFill>
+                          <a:latin typeface="Calibri" pitchFamily="34" charset="0"/>
+                          <a:ea typeface="Calibri" pitchFamily="34" charset="-122"/>
+                          <a:cs typeface="Calibri" pitchFamily="34" charset="-120"/>
+                        </a:rPr>
+                        <a:t>87.5</a:t>
+                      </a:r>
+                      <a:endParaRPr lang="en-US" sz="1250" dirty="0">
+                        <a:latin typeface="Calibri" charset="0"/>
+                        <a:ea typeface="Calibri" charset="0"/>
+                        <a:cs typeface="Calibri" charset="0"/>
+                      </a:endParaRPr>
+                    </a:p>
+                  </a:txBody>
+                  <a:tcPr marL="50800" marR="50800" marT="25400" marB="25400" anchor="ctr">
+                    <a:lnL w="12700" cap="flat" cmpd="sng" algn="ctr">
+                      <a:solidFill>
+                        <a:srgbClr val="D5DEE5"/>
+                      </a:solidFill>
+                      <a:prstDash val="solid"/>
+                      <a:round/>
+                      <a:headEnd type="none" w="med" len="med"/>
+                      <a:tailEnd type="none" w="med" len="med"/>
+                    </a:lnL>
+                    <a:lnR w="12700" cap="flat" cmpd="sng" algn="ctr">
+                      <a:solidFill>
+                        <a:srgbClr val="D5DEE5"/>
+                      </a:solidFill>
+                      <a:prstDash val="solid"/>
+                      <a:round/>
+                      <a:headEnd type="none" w="med" len="med"/>
+                      <a:tailEnd type="none" w="med" len="med"/>
+                    </a:lnR>
+                    <a:lnT w="12700" cap="flat" cmpd="sng" algn="ctr">
+                      <a:solidFill>
+                        <a:srgbClr val="D5DEE5"/>
+                      </a:solidFill>
+                      <a:prstDash val="solid"/>
+                      <a:round/>
+                      <a:headEnd type="none" w="med" len="med"/>
+                      <a:tailEnd type="none" w="med" len="med"/>
+                    </a:lnT>
+                    <a:lnB w="12700" cap="flat" cmpd="sng" algn="ctr">
+                      <a:solidFill>
+                        <a:srgbClr val="D5DEE5"/>
+                      </a:solidFill>
+                      <a:prstDash val="solid"/>
+                      <a:round/>
+                      <a:headEnd type="none" w="med" len="med"/>
+                      <a:tailEnd type="none" w="med" len="med"/>
+                    </a:lnB>
+                    <a:solidFill>
+                      <a:srgbClr val="F4F7F9"/>
+                    </a:solidFill>
+                  </a:tcPr>
+                </a:tc>
+                <a:tc>
+                  <a:txBody>
+                    <a:bodyPr/>
+                    <a:lstStyle/>
+                    <a:p>
+                      <a:pPr algn="ctr" indent="0" marL="0">
+                        <a:buNone/>
+                      </a:pPr>
+                      <a:r>
+                        <a:rPr lang="en-US" sz="1250" b="1" dirty="0">
+                          <a:solidFill>
+                            <a:srgbClr val="2E8B57"/>
+                          </a:solidFill>
+                          <a:latin typeface="Calibri" pitchFamily="34" charset="0"/>
+                          <a:ea typeface="Calibri" pitchFamily="34" charset="-122"/>
+                          <a:cs typeface="Calibri" pitchFamily="34" charset="-120"/>
+                        </a:rPr>
+                        <a:t>165</a:t>
+                      </a:r>
+                      <a:endParaRPr lang="en-US" sz="1250" dirty="0">
+                        <a:latin typeface="Calibri" charset="0"/>
+                        <a:ea typeface="Calibri" charset="0"/>
+                        <a:cs typeface="Calibri" charset="0"/>
+                      </a:endParaRPr>
+                    </a:p>
+                  </a:txBody>
+                  <a:tcPr marL="50800" marR="50800" marT="25400" marB="25400" anchor="ctr">
+                    <a:lnL w="12700" cap="flat" cmpd="sng" algn="ctr">
+                      <a:solidFill>
+                        <a:srgbClr val="D5DEE5"/>
+                      </a:solidFill>
+                      <a:prstDash val="solid"/>
+                      <a:round/>
+                      <a:headEnd type="none" w="med" len="med"/>
+                      <a:tailEnd type="none" w="med" len="med"/>
+                    </a:lnL>
+                    <a:lnR w="12700" cap="flat" cmpd="sng" algn="ctr">
+                      <a:solidFill>
+                        <a:srgbClr val="D5DEE5"/>
+                      </a:solidFill>
+                      <a:prstDash val="solid"/>
+                      <a:round/>
+                      <a:headEnd type="none" w="med" len="med"/>
+                      <a:tailEnd type="none" w="med" len="med"/>
+                    </a:lnR>
+                    <a:lnT w="12700" cap="flat" cmpd="sng" algn="ctr">
+                      <a:solidFill>
+                        <a:srgbClr val="D5DEE5"/>
+                      </a:solidFill>
+                      <a:prstDash val="solid"/>
+                      <a:round/>
+                      <a:headEnd type="none" w="med" len="med"/>
+                      <a:tailEnd type="none" w="med" len="med"/>
+                    </a:lnT>
+                    <a:lnB w="12700" cap="flat" cmpd="sng" algn="ctr">
+                      <a:solidFill>
+                        <a:srgbClr val="D5DEE5"/>
+                      </a:solidFill>
+                      <a:prstDash val="solid"/>
+                      <a:round/>
+                      <a:headEnd type="none" w="med" len="med"/>
+                      <a:tailEnd type="none" w="med" len="med"/>
+                    </a:lnB>
+                    <a:solidFill>
+                      <a:srgbClr val="F4F7F9"/>
+                    </a:solidFill>
+                  </a:tcPr>
+                </a:tc>
+                <a:tc>
+                  <a:txBody>
+                    <a:bodyPr/>
+                    <a:lstStyle/>
+                    <a:p>
+                      <a:pPr algn="ctr" indent="0" marL="0">
+                        <a:buNone/>
+                      </a:pPr>
+                      <a:r>
+                        <a:rPr lang="en-US" sz="1250" dirty="0">
+                          <a:solidFill>
+                            <a:srgbClr val="0B6E99"/>
+                          </a:solidFill>
+                          <a:latin typeface="Calibri" pitchFamily="34" charset="0"/>
+                          <a:ea typeface="Calibri" pitchFamily="34" charset="-122"/>
+                          <a:cs typeface="Calibri" pitchFamily="34" charset="-120"/>
+                        </a:rPr>
+                        <a:t>165.7</a:t>
+                      </a:r>
+                      <a:endParaRPr lang="en-US" sz="1250" dirty="0">
+                        <a:latin typeface="Calibri" charset="0"/>
+                        <a:ea typeface="Calibri" charset="0"/>
+                        <a:cs typeface="Calibri" charset="0"/>
+                      </a:endParaRPr>
+                    </a:p>
+                  </a:txBody>
+                  <a:tcPr marL="50800" marR="50800" marT="25400" marB="25400" anchor="ctr">
+                    <a:lnL w="12700" cap="flat" cmpd="sng" algn="ctr">
+                      <a:solidFill>
+                        <a:srgbClr val="D5DEE5"/>
+                      </a:solidFill>
+                      <a:prstDash val="solid"/>
+                      <a:round/>
+                      <a:headEnd type="none" w="med" len="med"/>
+                      <a:tailEnd type="none" w="med" len="med"/>
+                    </a:lnL>
+                    <a:lnR w="12700" cap="flat" cmpd="sng" algn="ctr">
+                      <a:solidFill>
+                        <a:srgbClr val="D5DEE5"/>
+                      </a:solidFill>
+                      <a:prstDash val="solid"/>
+                      <a:round/>
+                      <a:headEnd type="none" w="med" len="med"/>
+                      <a:tailEnd type="none" w="med" len="med"/>
+                    </a:lnR>
+                    <a:lnT w="12700" cap="flat" cmpd="sng" algn="ctr">
+                      <a:solidFill>
+                        <a:srgbClr val="D5DEE5"/>
+                      </a:solidFill>
+                      <a:prstDash val="solid"/>
+                      <a:round/>
+                      <a:headEnd type="none" w="med" len="med"/>
+                      <a:tailEnd type="none" w="med" len="med"/>
+                    </a:lnT>
+                    <a:lnB w="12700" cap="flat" cmpd="sng" algn="ctr">
+                      <a:solidFill>
+                        <a:srgbClr val="D5DEE5"/>
+                      </a:solidFill>
+                      <a:prstDash val="solid"/>
+                      <a:round/>
+                      <a:headEnd type="none" w="med" len="med"/>
+                      <a:tailEnd type="none" w="med" len="med"/>
+                    </a:lnB>
+                    <a:solidFill>
+                      <a:srgbClr val="F4F7F9"/>
+                    </a:solidFill>
+                  </a:tcPr>
+                </a:tc>
+              </a:tr>
+            </a:tbl>
+          </a:graphicData>
+        </a:graphic>
+      </p:graphicFrame>
+      <p:sp>
+        <p:nvSpPr>
+          <p:cNvPr id="6" name="Text 3"/>
+          <p:cNvSpPr/>
+          <p:nvPr/>
+        </p:nvSpPr>
+        <p:spPr>
+          <a:xfrm>
+            <a:off x="640080" y="3977640"/>
+            <a:ext cx="7589520" cy="457200"/>
+          </a:xfrm>
+          <a:prstGeom prst="rect">
+            <a:avLst/>
+          </a:prstGeom>
+          <a:noFill/>
+          <a:ln/>
+        </p:spPr>
+        <p:txBody>
+          <a:bodyPr wrap="square" lIns="0" tIns="0" rIns="0" bIns="0" rtlCol="0" anchor="ctr"/>
+          <a:lstStyle/>
+          <a:p>
+            <a:pPr indent="0" marL="0">
+              <a:buNone/>
+            </a:pPr>
+            <a:r>
+              <a:rPr lang="en-US" sz="1150" b="1" i="1" dirty="0">
+                <a:solidFill>
+                  <a:srgbClr val="2E8B57"/>
+                </a:solidFill>
+                <a:latin typeface="Calibri" pitchFamily="34" charset="0"/>
+                <a:ea typeface="Calibri" pitchFamily="34" charset="-122"/>
+                <a:cs typeface="Calibri" pitchFamily="34" charset="-120"/>
+              </a:rPr>
+              <a:t>Green</a:t>
+            </a:r>
+            <a:pPr indent="0" marL="0">
+              <a:buNone/>
+            </a:pPr>
+            <a:r>
+              <a:rPr lang="en-US" sz="1150" i="1" dirty="0">
+                <a:solidFill>
+                  <a:srgbClr val="6B7B8A"/>
+                </a:solidFill>
+                <a:latin typeface="Calibri" pitchFamily="34" charset="0"/>
+                <a:ea typeface="Calibri" pitchFamily="34" charset="-122"/>
+                <a:cs typeface="Calibri" pitchFamily="34" charset="-120"/>
+              </a:rPr>
+              <a:t> = columns we add.   </a:t>
+            </a:r>
+            <a:pPr indent="0" marL="0">
+              <a:buNone/>
+            </a:pPr>
+            <a:r>
+              <a:rPr lang="en-US" sz="1150" b="1" i="1" dirty="0">
+                <a:solidFill>
+                  <a:srgbClr val="0B6E99"/>
+                </a:solidFill>
+                <a:latin typeface="Calibri" pitchFamily="34" charset="0"/>
+                <a:ea typeface="Calibri" pitchFamily="34" charset="-122"/>
+                <a:cs typeface="Calibri" pitchFamily="34" charset="-120"/>
+              </a:rPr>
+              <a:t>Blue</a:t>
+            </a:r>
+            <a:pPr indent="0" marL="0">
+              <a:buNone/>
+            </a:pPr>
+            <a:r>
+              <a:rPr lang="en-US" sz="1150" i="1" dirty="0">
+                <a:solidFill>
+                  <a:srgbClr val="6B7B8A"/>
+                </a:solidFill>
+                <a:latin typeface="Calibri" pitchFamily="34" charset="0"/>
+                <a:ea typeface="Calibri" pitchFamily="34" charset="-122"/>
+                <a:cs typeface="Calibri" pitchFamily="34" charset="-120"/>
+              </a:rPr>
+              <a:t> = the passenger estimate already in your schedule — our figure lands on it.</a:t>
+            </a:r>
+            <a:endParaRPr lang="en-US" sz="1150" dirty="0"/>
+          </a:p>
+        </p:txBody>
+      </p:sp>
+      <p:sp>
+        <p:nvSpPr>
+          <p:cNvPr id="7" name="Shape 4"/>
+          <p:cNvSpPr/>
+          <p:nvPr/>
+        </p:nvSpPr>
+        <p:spPr>
+          <a:xfrm>
+            <a:off x="640080" y="4709160"/>
+            <a:ext cx="7589520" cy="1600200"/>
+          </a:xfrm>
+          <a:prstGeom prst="roundRect">
+            <a:avLst>
+              <a:gd name="adj" fmla="val 4571"/>
+            </a:avLst>
+          </a:prstGeom>
+          <a:solidFill>
+            <a:srgbClr val="EAF6F5"/>
+          </a:solidFill>
+          <a:ln w="12700">
+            <a:solidFill>
+              <a:srgbClr val="E2E9EE"/>
+            </a:solidFill>
+            <a:prstDash val="solid"/>
+          </a:ln>
+          <a:effectLst>
+            <a:outerShdw sx="100000" sy="100000" kx="0" ky="0" algn="bl" rotWithShape="0" blurRad="76200" dist="25400" dir="5400000">
+              <a:srgbClr val="9FB0BC">
+                <a:alpha val="35000"/>
+              </a:srgbClr>
+            </a:outerShdw>
+          </a:effectLst>
+        </p:spPr>
+      </p:sp>
+      <p:sp>
+        <p:nvSpPr>
+          <p:cNvPr id="8" name="Text 5"/>
+          <p:cNvSpPr/>
+          <p:nvPr/>
+        </p:nvSpPr>
+        <p:spPr>
+          <a:xfrm>
+            <a:off x="868680" y="4828032"/>
+            <a:ext cx="2377440" cy="1371600"/>
+          </a:xfrm>
+          <a:prstGeom prst="rect">
+            <a:avLst/>
+          </a:prstGeom>
+          <a:noFill/>
+          <a:ln/>
+        </p:spPr>
+        <p:txBody>
+          <a:bodyPr wrap="square" lIns="0" tIns="0" rIns="0" bIns="0" rtlCol="0" anchor="ctr"/>
+          <a:lstStyle/>
+          <a:p>
+            <a:pPr algn="l" indent="0" marL="0">
+              <a:buNone/>
+            </a:pPr>
+            <a:r>
+              <a:rPr lang="en-US" sz="6000" b="1" dirty="0">
+                <a:solidFill>
+                  <a:srgbClr val="2E8B57"/>
+                </a:solidFill>
+                <a:latin typeface="Cambria" pitchFamily="34" charset="0"/>
+                <a:ea typeface="Cambria" pitchFamily="34" charset="-122"/>
+                <a:cs typeface="Cambria" pitchFamily="34" charset="-120"/>
+              </a:rPr>
+              <a:t>0.993</a:t>
+            </a:r>
+            <a:endParaRPr lang="en-US" sz="6000" dirty="0"/>
+          </a:p>
+        </p:txBody>
+      </p:sp>
+      <p:sp>
+        <p:nvSpPr>
+          <p:cNvPr id="9" name="Text 6"/>
+          <p:cNvSpPr/>
+          <p:nvPr/>
+        </p:nvSpPr>
+        <p:spPr>
+          <a:xfrm>
+            <a:off x="3383280" y="4892040"/>
+            <a:ext cx="4663440" cy="1280160"/>
+          </a:xfrm>
+          <a:prstGeom prst="rect">
+            <a:avLst/>
+          </a:prstGeom>
+          <a:noFill/>
+          <a:ln/>
+        </p:spPr>
+        <p:txBody>
+          <a:bodyPr wrap="square" lIns="0" tIns="0" rIns="0" bIns="0" rtlCol="0" anchor="ctr"/>
+          <a:lstStyle/>
+          <a:p>
+            <a:pPr indent="0" marL="0">
+              <a:buNone/>
+            </a:pPr>
+            <a:r>
+              <a:rPr lang="en-US" sz="1400" dirty="0">
+                <a:solidFill>
+                  <a:srgbClr val="1E2B37"/>
+                </a:solidFill>
+                <a:latin typeface="Calibri" pitchFamily="34" charset="0"/>
+                <a:ea typeface="Calibri" pitchFamily="34" charset="-122"/>
+                <a:cs typeface="Calibri" pitchFamily="34" charset="-120"/>
+              </a:rPr>
+              <a:t>correlation between our per-flight Entry Passengers and the estimate already in your schedule — across all 5,820 flights. Season totals agree within 6.5%.</a:t>
+            </a:r>
+            <a:endParaRPr lang="en-US" sz="1400" dirty="0"/>
+          </a:p>
+        </p:txBody>
+      </p:sp>
+      <p:sp>
+        <p:nvSpPr>
+          <p:cNvPr id="10" name="Text 7"/>
+          <p:cNvSpPr/>
+          <p:nvPr/>
+        </p:nvSpPr>
+        <p:spPr>
+          <a:xfrm>
+            <a:off x="8503920" y="1600200"/>
+            <a:ext cx="3108960" cy="274320"/>
+          </a:xfrm>
+          <a:prstGeom prst="rect">
+            <a:avLst/>
+          </a:prstGeom>
+          <a:noFill/>
+          <a:ln/>
+        </p:spPr>
+        <p:txBody>
+          <a:bodyPr wrap="square" lIns="0" tIns="0" rIns="0" bIns="0" rtlCol="0" anchor="ctr"/>
+          <a:lstStyle/>
+          <a:p>
+            <a:pPr indent="0" marL="0">
+              <a:buNone/>
+            </a:pPr>
+            <a:r>
+              <a:rPr lang="en-US" sz="1200" b="1" spc="100" kern="0" dirty="0">
+                <a:solidFill>
+                  <a:srgbClr val="2E8B57"/>
+                </a:solidFill>
+                <a:latin typeface="Calibri" pitchFamily="34" charset="0"/>
+                <a:ea typeface="Calibri" pitchFamily="34" charset="-122"/>
+                <a:cs typeface="Calibri" pitchFamily="34" charset="-120"/>
+              </a:rPr>
+              <a:t>MATCHES YOUR DATA</a:t>
+            </a:r>
+            <a:endParaRPr lang="en-US" sz="1200" dirty="0"/>
+          </a:p>
+        </p:txBody>
+      </p:sp>
+      <p:sp>
+        <p:nvSpPr>
+          <p:cNvPr id="11" name="Text 8"/>
+          <p:cNvSpPr/>
+          <p:nvPr/>
+        </p:nvSpPr>
+        <p:spPr>
+          <a:xfrm>
+            <a:off x="8503920" y="1965960"/>
+            <a:ext cx="3154680" cy="1920240"/>
+          </a:xfrm>
+          <a:prstGeom prst="rect">
+            <a:avLst/>
+          </a:prstGeom>
+          <a:noFill/>
+          <a:ln/>
+        </p:spPr>
+        <p:txBody>
+          <a:bodyPr wrap="square" lIns="0" tIns="0" rIns="0" bIns="0" rtlCol="0" anchor="t"/>
+          <a:lstStyle/>
+          <a:p>
+            <a:pPr marL="152400" indent="-152400">
+              <a:spcAft>
+                <a:spcPts val="900"/>
+              </a:spcAft>
+              <a:buSzPct val="100000"/>
+              <a:buChar char="•"/>
+            </a:pPr>
+            <a:r>
+              <a:rPr lang="en-US" sz="1250" dirty="0">
+                <a:solidFill>
+                  <a:srgbClr val="1E2B37"/>
+                </a:solidFill>
+                <a:latin typeface="Calibri" pitchFamily="34" charset="0"/>
+                <a:ea typeface="Calibri" pitchFamily="34" charset="-122"/>
+                <a:cs typeface="Calibri" pitchFamily="34" charset="-120"/>
+              </a:rPr>
+              <a:t>Same 5,820 flights, aircraft &amp; capacity — read straight from your schedule</a:t>
+            </a:r>
+            <a:endParaRPr lang="en-US" sz="1250" dirty="0"/>
+          </a:p>
+          <a:p>
+            <a:pPr marL="152400" indent="-152400">
+              <a:spcAft>
+                <a:spcPts val="900"/>
+              </a:spcAft>
+              <a:buSzPct val="100000"/>
+              <a:buChar char="•"/>
+            </a:pPr>
+            <a:r>
+              <a:rPr lang="en-US" sz="1250" dirty="0">
+                <a:solidFill>
+                  <a:srgbClr val="1E2B37"/>
+                </a:solidFill>
+                <a:latin typeface="Calibri" pitchFamily="34" charset="0"/>
+                <a:ea typeface="Calibri" pitchFamily="34" charset="-122"/>
+                <a:cs typeface="Calibri" pitchFamily="34" charset="-120"/>
+              </a:rPr>
+              <a:t>Load factor = your real June actuals; show-up = real HYD e-boarding</a:t>
+            </a:r>
+            <a:endParaRPr lang="en-US" sz="1250" dirty="0"/>
+          </a:p>
+          <a:p>
+            <a:pPr marL="152400" indent="-152400">
+              <a:buSzPct val="100000"/>
+              <a:buChar char="•"/>
+            </a:pPr>
+            <a:r>
+              <a:rPr lang="en-US" sz="1250" dirty="0">
+                <a:solidFill>
+                  <a:srgbClr val="1E2B37"/>
+                </a:solidFill>
+                <a:latin typeface="Calibri" pitchFamily="34" charset="0"/>
+                <a:ea typeface="Calibri" pitchFamily="34" charset="-122"/>
+                <a:cs typeface="Calibri" pitchFamily="34" charset="-120"/>
+              </a:rPr>
+              <a:t>Per-flight passenger numbers track your own estimate (0.993)</a:t>
+            </a:r>
+            <a:endParaRPr lang="en-US" sz="1250" dirty="0"/>
+          </a:p>
+        </p:txBody>
+      </p:sp>
+      <p:sp>
+        <p:nvSpPr>
+          <p:cNvPr id="12" name="Text 9"/>
+          <p:cNvSpPr/>
+          <p:nvPr/>
+        </p:nvSpPr>
+        <p:spPr>
+          <a:xfrm>
+            <a:off x="8503920" y="4114800"/>
+            <a:ext cx="3108960" cy="274320"/>
+          </a:xfrm>
+          <a:prstGeom prst="rect">
+            <a:avLst/>
+          </a:prstGeom>
+          <a:noFill/>
+          <a:ln/>
+        </p:spPr>
+        <p:txBody>
+          <a:bodyPr wrap="square" lIns="0" tIns="0" rIns="0" bIns="0" rtlCol="0" anchor="ctr"/>
+          <a:lstStyle/>
+          <a:p>
+            <a:pPr indent="0" marL="0">
+              <a:buNone/>
+            </a:pPr>
+            <a:r>
+              <a:rPr lang="en-US" sz="1200" b="1" spc="100" kern="0" dirty="0">
+                <a:solidFill>
+                  <a:srgbClr val="0B6E99"/>
+                </a:solidFill>
+                <a:latin typeface="Calibri" pitchFamily="34" charset="0"/>
+                <a:ea typeface="Calibri" pitchFamily="34" charset="-122"/>
+                <a:cs typeface="Calibri" pitchFamily="34" charset="-120"/>
+              </a:rPr>
+              <a:t>MAKES IT OPERATIONAL</a:t>
+            </a:r>
+            <a:endParaRPr lang="en-US" sz="1200" dirty="0"/>
+          </a:p>
+        </p:txBody>
+      </p:sp>
+      <p:sp>
+        <p:nvSpPr>
+          <p:cNvPr id="13" name="Text 10"/>
+          <p:cNvSpPr/>
+          <p:nvPr/>
+        </p:nvSpPr>
+        <p:spPr>
+          <a:xfrm>
+            <a:off x="8503920" y="4480560"/>
+            <a:ext cx="3154680" cy="1828800"/>
+          </a:xfrm>
+          <a:prstGeom prst="rect">
+            <a:avLst/>
+          </a:prstGeom>
+          <a:noFill/>
+          <a:ln/>
+        </p:spPr>
+        <p:txBody>
+          <a:bodyPr wrap="square" lIns="0" tIns="0" rIns="0" bIns="0" rtlCol="0" anchor="t"/>
+          <a:lstStyle/>
+          <a:p>
+            <a:pPr marL="152400" indent="-152400">
+              <a:spcAft>
+                <a:spcPts val="900"/>
+              </a:spcAft>
+              <a:buSzPct val="100000"/>
+              <a:buChar char="•"/>
+            </a:pPr>
+            <a:r>
+              <a:rPr lang="en-US" sz="1250" dirty="0">
+                <a:solidFill>
+                  <a:srgbClr val="1E2B37"/>
+                </a:solidFill>
+                <a:latin typeface="Calibri" pitchFamily="34" charset="0"/>
+                <a:ea typeface="Calibri" pitchFamily="34" charset="-122"/>
+                <a:cs typeface="Calibri" pitchFamily="34" charset="-120"/>
+              </a:rPr>
+              <a:t>Time-phased entry demand every 5 minutes — your schedule has none</a:t>
+            </a:r>
+            <a:endParaRPr lang="en-US" sz="1250" dirty="0"/>
+          </a:p>
+          <a:p>
+            <a:pPr marL="152400" indent="-152400">
+              <a:spcAft>
+                <a:spcPts val="900"/>
+              </a:spcAft>
+              <a:buSzPct val="100000"/>
+              <a:buChar char="•"/>
+            </a:pPr>
+            <a:r>
+              <a:rPr lang="en-US" sz="1250" dirty="0">
+                <a:solidFill>
+                  <a:srgbClr val="1E2B37"/>
+                </a:solidFill>
+                <a:latin typeface="Calibri" pitchFamily="34" charset="0"/>
+                <a:ea typeface="Calibri" pitchFamily="34" charset="-122"/>
+                <a:cs typeface="Calibri" pitchFamily="34" charset="-120"/>
+              </a:rPr>
+              <a:t>30-minute projection → lanes required (peaks at 4)</a:t>
+            </a:r>
+            <a:endParaRPr lang="en-US" sz="1250" dirty="0"/>
+          </a:p>
+          <a:p>
+            <a:pPr marL="152400" indent="-152400">
+              <a:buSzPct val="100000"/>
+              <a:buChar char="•"/>
+            </a:pPr>
+            <a:r>
+              <a:rPr lang="en-US" sz="1250" dirty="0">
+                <a:solidFill>
+                  <a:srgbClr val="1E2B37"/>
+                </a:solidFill>
+                <a:latin typeface="Calibri" pitchFamily="34" charset="0"/>
+                <a:ea typeface="Calibri" pitchFamily="34" charset="-122"/>
+                <a:cs typeface="Calibri" pitchFamily="34" charset="-120"/>
+              </a:rPr>
+              <a:t>Load factor varies by weekday — captures the Sunday peak, not a flat factor</a:t>
+            </a:r>
+            <a:endParaRPr lang="en-US" sz="1250" dirty="0"/>
+          </a:p>
+        </p:txBody>
+      </p:sp>
+    </p:spTree>
+  </p:cSld>
+  <p:clrMapOvr>
+    <a:masterClrMapping/>
+  </p:clrMapOvr>
+</p:sld>
+</file>
+
+<file path=ppt/slides/slide12.xml><?xml version="1.0" encoding="utf-8"?>
+<p:sld xmlns:a="http://schemas.openxmlformats.org/drawingml/2006/main" xmlns:r="http://schemas.openxmlformats.org/officeDocument/2006/relationships" xmlns:p="http://schemas.openxmlformats.org/presentationml/2006/main">
+  <p:cSld name="Slide 12">
+    <p:bg>
+      <p:bgPr>
+        <a:solidFill>
+          <a:srgbClr val="FFFFFF"/>
+        </a:solidFill>
+      </p:bgPr>
+    </p:bg>
+    <p:spTree>
+      <p:nvGrpSpPr>
+        <p:cNvPr id="1" name=""/>
+        <p:cNvGrpSpPr/>
+        <p:nvPr/>
+      </p:nvGrpSpPr>
+      <p:grpSpPr>
+        <a:xfrm>
+          <a:off x="0" y="0"/>
+          <a:ext cx="0" cy="0"/>
+          <a:chOff x="0" y="0"/>
+          <a:chExt cx="0" cy="0"/>
+        </a:xfrm>
+      </p:grpSpPr>
+      <p:sp>
+        <p:nvSpPr>
+          <p:cNvPr id="2" name="Text 0"/>
+          <p:cNvSpPr/>
+          <p:nvPr/>
+        </p:nvSpPr>
+        <p:spPr>
+          <a:xfrm>
             <a:off x="640080" y="457200"/>
             <a:ext cx="7315200" cy="274320"/>
           </a:xfrm>
@@ -4082,9 +6429,9 @@
 </p:sld>
 </file>
 
-<file path=ppt/slides/slide12.xml><?xml version="1.0" encoding="utf-8"?>
+<file path=ppt/slides/slide13.xml><?xml version="1.0" encoding="utf-8"?>
 <p:sld xmlns:a="http://schemas.openxmlformats.org/drawingml/2006/main" xmlns:r="http://schemas.openxmlformats.org/officeDocument/2006/relationships" xmlns:p="http://schemas.openxmlformats.org/presentationml/2006/main">
-  <p:cSld name="Slide 12">
+  <p:cSld name="Slide 13">
     <p:bg>
       <p:bgPr>
         <a:solidFill>

</xml_diff>

<commit_message>
POD2 deck: add gate-layout + lane-rate sensitivity slide (now 14 slides)
New slide 12 "3 gates x A/B - sized with room to spare": visual of the 6 lanes
(01-A..03-B) with the 4 open at peak highlighted, plus the lane-rate sensitivity table
(60..180 pax/hr/lane -> peak lanes / verdict, 120 default highlighted) and the decision
prompt for Avra. Caveats/summary shift to 13/14.

Co-Authored-By: Claude Opus 4.8 <noreply@anthropic.com>
</commit_message>
<xml_diff>
--- a/POD2/POD2_Entry_Overview.pptx
+++ b/POD2/POD2_Entry_Overview.pptx
@@ -18,9 +18,10 @@
     <p:sldId id="266" r:id="rId12"/>
     <p:sldId id="267" r:id="rId13"/>
     <p:sldId id="268" r:id="rId14"/>
+    <p:sldId id="269" r:id="rId15"/>
   </p:sldIdLst>
   <p:notesMasterIdLst>
-    <p:notesMasterId r:id="rId15"/>
+    <p:notesMasterId r:id="rId16"/>
   </p:notesMasterIdLst>
   <p:sldSz cx="12192000" cy="6858000"/>
   <p:notesSz cx="6858000" cy="12192000"/>
@@ -890,6 +891,94 @@
             <a:fld id="{F7021451-1387-4CA6-816F-3879F97B5CBC}" type="slidenum">
               <a:rPr lang="en-US"/>
               <a:t>13</a:t>
+            </a:fld>
+            <a:endParaRPr lang="en-US"/>
+          </a:p>
+        </p:txBody>
+      </p:sp>
+    </p:spTree>
+    <p:extLst>
+      <p:ext uri="{BB962C8B-B14F-4D97-AF65-F5344CB8AC3E}">
+        <p14:creationId xmlns:p14="http://schemas.microsoft.com/office/powerpoint/2010/main" val="1024086991"/>
+      </p:ext>
+    </p:extLst>
+  </p:cSld>
+  <p:clrMapOvr>
+    <a:masterClrMapping/>
+  </p:clrMapOvr>
+</p:notes>
+</file>
+
+<file path=ppt/notesSlides/notesSlide14.xml><?xml version="1.0" encoding="utf-8"?>
+<p:notes xmlns:a="http://schemas.openxmlformats.org/drawingml/2006/main" xmlns:r="http://schemas.openxmlformats.org/officeDocument/2006/relationships" xmlns:p="http://schemas.openxmlformats.org/presentationml/2006/main">
+  <p:cSld>
+    <p:spTree>
+      <p:nvGrpSpPr>
+        <p:cNvPr id="1" name=""/>
+        <p:cNvGrpSpPr/>
+        <p:nvPr/>
+      </p:nvGrpSpPr>
+      <p:grpSpPr>
+        <a:xfrm>
+          <a:off x="0" y="0"/>
+          <a:ext cx="0" cy="0"/>
+          <a:chOff x="0" y="0"/>
+          <a:chExt cx="0" cy="0"/>
+        </a:xfrm>
+      </p:grpSpPr>
+      <p:sp>
+        <p:nvSpPr>
+          <p:cNvPr id="2" name="Slide Image Placeholder 1"/>
+          <p:cNvSpPr>
+            <a:spLocks noGrp="1" noRot="1" noChangeAspect="1"/>
+          </p:cNvSpPr>
+          <p:nvPr>
+            <p:ph type="sldImg"/>
+          </p:nvPr>
+        </p:nvSpPr>
+        <p:spPr/>
+      </p:sp>
+      <p:sp>
+        <p:nvSpPr>
+          <p:cNvPr id="3" name="Notes Placeholder 2"/>
+          <p:cNvSpPr>
+            <a:spLocks noGrp="1"/>
+          </p:cNvSpPr>
+          <p:nvPr>
+            <p:ph type="body" idx="1"/>
+          </p:nvPr>
+        </p:nvSpPr>
+        <p:spPr/>
+        <p:txBody>
+          <a:bodyPr/>
+          <a:lstStyle/>
+          <a:p>
+            <a:r>
+              <a:rPr lang="en-US" dirty="0"/>
+              <a:t/>
+            </a:r>
+            <a:endParaRPr lang="en-US" dirty="0"/>
+          </a:p>
+        </p:txBody>
+      </p:sp>
+      <p:sp>
+        <p:nvSpPr>
+          <p:cNvPr id="4" name="Slide Number Placeholder 3"/>
+          <p:cNvSpPr>
+            <a:spLocks noGrp="1"/>
+          </p:cNvSpPr>
+          <p:nvPr>
+            <p:ph type="sldNum" sz="quarter" idx="10"/>
+          </p:nvPr>
+        </p:nvSpPr>
+        <p:spPr/>
+        <p:txBody>
+          <a:bodyPr/>
+          <a:lstStyle/>
+          <a:p>
+            <a:fld id="{F7021451-1387-4CA6-816F-3879F97B5CBC}" type="slidenum">
+              <a:rPr lang="en-US"/>
+              <a:t>14</a:t>
             </a:fld>
             <a:endParaRPr lang="en-US"/>
           </a:p>
@@ -5832,7 +5921,7 @@
         </p:nvSpPr>
         <p:spPr>
           <a:xfrm>
-            <a:off x="640080" y="457200"/>
+            <a:off x="640080" y="365760"/>
             <a:ext cx="7315200" cy="274320"/>
           </a:xfrm>
           <a:prstGeom prst="rect">
@@ -5857,7 +5946,7 @@
                 <a:ea typeface="Calibri" pitchFamily="34" charset="-122"/>
                 <a:cs typeface="Calibri" pitchFamily="34" charset="-120"/>
               </a:rPr>
-              <a:t>TO CONFIRM WITH AVRA</a:t>
+              <a:t>ENTRY INFRASTRUCTURE  ·  PER AVRA</a:t>
             </a:r>
             <a:endParaRPr lang="en-US" sz="1200" dirty="0"/>
           </a:p>
@@ -5871,8 +5960,8 @@
         </p:nvSpPr>
         <p:spPr>
           <a:xfrm>
-            <a:off x="640080" y="731520"/>
-            <a:ext cx="10972800" cy="731520"/>
+            <a:off x="640080" y="658368"/>
+            <a:ext cx="11155680" cy="731520"/>
           </a:xfrm>
           <a:prstGeom prst="rect">
             <a:avLst/>
@@ -5896,7 +5985,7 @@
                 <a:ea typeface="Cambria" pitchFamily="34" charset="-122"/>
                 <a:cs typeface="Cambria" pitchFamily="34" charset="-120"/>
               </a:rPr>
-              <a:t>Open questions before sign-off</a:t>
+              <a:t>3 gates × A/B — sized with room to spare</a:t>
             </a:r>
             <a:endParaRPr lang="en-US" sz="3000" dirty="0"/>
           </a:p>
@@ -5904,18 +5993,57 @@
       </p:sp>
       <p:sp>
         <p:nvSpPr>
-          <p:cNvPr id="4" name="Shape 2"/>
-          <p:cNvSpPr/>
-          <p:nvPr/>
-        </p:nvSpPr>
-        <p:spPr>
-          <a:xfrm>
-            <a:off x="640080" y="1783080"/>
-            <a:ext cx="10972800" cy="1234440"/>
+          <p:cNvPr id="4" name="Text 2"/>
+          <p:cNvSpPr/>
+          <p:nvPr/>
+        </p:nvSpPr>
+        <p:spPr>
+          <a:xfrm>
+            <a:off x="640080" y="1517904"/>
+            <a:ext cx="4937760" cy="320040"/>
+          </a:xfrm>
+          <a:prstGeom prst="rect">
+            <a:avLst/>
+          </a:prstGeom>
+          <a:noFill/>
+          <a:ln/>
+        </p:spPr>
+        <p:txBody>
+          <a:bodyPr wrap="square" lIns="0" tIns="0" rIns="0" bIns="0" rtlCol="0" anchor="ctr"/>
+          <a:lstStyle/>
+          <a:p>
+            <a:pPr indent="0" marL="0">
+              <a:buNone/>
+            </a:pPr>
+            <a:r>
+              <a:rPr lang="en-US" sz="1350" b="1" dirty="0">
+                <a:solidFill>
+                  <a:srgbClr val="0A3D5C"/>
+                </a:solidFill>
+                <a:latin typeface="Cambria" pitchFamily="34" charset="0"/>
+                <a:ea typeface="Cambria" pitchFamily="34" charset="-122"/>
+                <a:cs typeface="Cambria" pitchFamily="34" charset="-120"/>
+              </a:rPr>
+              <a:t>6 scanning lanes; peak opens 4 (balance across gates)</a:t>
+            </a:r>
+            <a:endParaRPr lang="en-US" sz="1350" dirty="0"/>
+          </a:p>
+        </p:txBody>
+      </p:sp>
+      <p:sp>
+        <p:nvSpPr>
+          <p:cNvPr id="5" name="Shape 3"/>
+          <p:cNvSpPr/>
+          <p:nvPr/>
+        </p:nvSpPr>
+        <p:spPr>
+          <a:xfrm>
+            <a:off x="640080" y="1965960"/>
+            <a:ext cx="1463040" cy="2148840"/>
           </a:xfrm>
           <a:prstGeom prst="roundRect">
             <a:avLst>
-              <a:gd name="adj" fmla="val 5926"/>
+              <a:gd name="adj" fmla="val 5000"/>
             </a:avLst>
           </a:prstGeom>
           <a:solidFill>
@@ -5938,36 +6066,14 @@
       </p:sp>
       <p:sp>
         <p:nvSpPr>
-          <p:cNvPr id="5" name="Shape 3"/>
-          <p:cNvSpPr/>
-          <p:nvPr/>
-        </p:nvSpPr>
-        <p:spPr>
-          <a:xfrm>
-            <a:off x="868680" y="2039112"/>
-            <a:ext cx="731520" cy="731520"/>
-          </a:xfrm>
-          <a:prstGeom prst="roundRect">
-            <a:avLst>
-              <a:gd name="adj" fmla="val 50000"/>
-            </a:avLst>
-          </a:prstGeom>
-          <a:solidFill>
-            <a:srgbClr val="D98A2B"/>
-          </a:solidFill>
-          <a:ln/>
-        </p:spPr>
-      </p:sp>
-      <p:sp>
-        <p:nvSpPr>
           <p:cNvPr id="6" name="Text 4"/>
           <p:cNvSpPr/>
           <p:nvPr/>
         </p:nvSpPr>
         <p:spPr>
           <a:xfrm>
-            <a:off x="868680" y="2039112"/>
-            <a:ext cx="731520" cy="731520"/>
+            <a:off x="640080" y="2093976"/>
+            <a:ext cx="1463040" cy="320040"/>
           </a:xfrm>
           <a:prstGeom prst="rect">
             <a:avLst/>
@@ -5983,30 +6089,52 @@
               <a:buNone/>
             </a:pPr>
             <a:r>
-              <a:rPr lang="en-US" sz="3000" b="1" dirty="0">
-                <a:solidFill>
-                  <a:srgbClr val="FFFFFF"/>
+              <a:rPr lang="en-US" sz="1400" b="1" dirty="0">
+                <a:solidFill>
+                  <a:srgbClr val="1E2B37"/>
                 </a:solidFill>
                 <a:latin typeface="Cambria" pitchFamily="34" charset="0"/>
                 <a:ea typeface="Cambria" pitchFamily="34" charset="-122"/>
                 <a:cs typeface="Cambria" pitchFamily="34" charset="-120"/>
               </a:rPr>
-              <a:t>?</a:t>
-            </a:r>
-            <a:endParaRPr lang="en-US" sz="3000" dirty="0"/>
-          </a:p>
-        </p:txBody>
-      </p:sp>
-      <p:sp>
-        <p:nvSpPr>
-          <p:cNvPr id="7" name="Text 5"/>
-          <p:cNvSpPr/>
-          <p:nvPr/>
-        </p:nvSpPr>
-        <p:spPr>
-          <a:xfrm>
-            <a:off x="1828800" y="1984248"/>
-            <a:ext cx="9509760" cy="411480"/>
+              <a:t>Gate 01</a:t>
+            </a:r>
+            <a:endParaRPr lang="en-US" sz="1400" dirty="0"/>
+          </a:p>
+        </p:txBody>
+      </p:sp>
+      <p:sp>
+        <p:nvSpPr>
+          <p:cNvPr id="7" name="Shape 5"/>
+          <p:cNvSpPr/>
+          <p:nvPr/>
+        </p:nvSpPr>
+        <p:spPr>
+          <a:xfrm>
+            <a:off x="896112" y="2532888"/>
+            <a:ext cx="950976" cy="603504"/>
+          </a:xfrm>
+          <a:prstGeom prst="roundRect">
+            <a:avLst>
+              <a:gd name="adj" fmla="val 9091"/>
+            </a:avLst>
+          </a:prstGeom>
+          <a:solidFill>
+            <a:srgbClr val="2E8B57"/>
+          </a:solidFill>
+          <a:ln/>
+        </p:spPr>
+      </p:sp>
+      <p:sp>
+        <p:nvSpPr>
+          <p:cNvPr id="8" name="Text 6"/>
+          <p:cNvSpPr/>
+          <p:nvPr/>
+        </p:nvSpPr>
+        <p:spPr>
+          <a:xfrm>
+            <a:off x="896112" y="2532888"/>
+            <a:ext cx="950976" cy="603504"/>
           </a:xfrm>
           <a:prstGeom prst="rect">
             <a:avLst/>
@@ -6018,60 +6146,21 @@
           <a:bodyPr wrap="square" lIns="0" tIns="0" rIns="0" bIns="0" rtlCol="0" anchor="ctr"/>
           <a:lstStyle/>
           <a:p>
-            <a:pPr indent="0" marL="0">
+            <a:pPr algn="ctr" indent="0" marL="0">
               <a:buNone/>
             </a:pPr>
             <a:r>
-              <a:rPr lang="en-US" sz="1800" b="1" dirty="0">
-                <a:solidFill>
-                  <a:srgbClr val="1E2B37"/>
+              <a:rPr lang="en-US" sz="1400" b="1" dirty="0">
+                <a:solidFill>
+                  <a:srgbClr val="FFFFFF"/>
                 </a:solidFill>
                 <a:latin typeface="Cambria" pitchFamily="34" charset="0"/>
                 <a:ea typeface="Cambria" pitchFamily="34" charset="-122"/>
                 <a:cs typeface="Cambria" pitchFamily="34" charset="-120"/>
               </a:rPr>
-              <a:t>E-boarding = 2 days only</a:t>
-            </a:r>
-            <a:endParaRPr lang="en-US" sz="1800" dirty="0"/>
-          </a:p>
-        </p:txBody>
-      </p:sp>
-      <p:sp>
-        <p:nvSpPr>
-          <p:cNvPr id="8" name="Text 6"/>
-          <p:cNvSpPr/>
-          <p:nvPr/>
-        </p:nvSpPr>
-        <p:spPr>
-          <a:xfrm>
-            <a:off x="1828800" y="2404872"/>
-            <a:ext cx="9509760" cy="502920"/>
-          </a:xfrm>
-          <a:prstGeom prst="rect">
-            <a:avLst/>
-          </a:prstGeom>
-          <a:noFill/>
-          <a:ln/>
-        </p:spPr>
-        <p:txBody>
-          <a:bodyPr wrap="square" lIns="0" tIns="0" rIns="0" bIns="0" rtlCol="0" anchor="ctr"/>
-          <a:lstStyle/>
-          <a:p>
-            <a:pPr indent="0" marL="0">
-              <a:buNone/>
-            </a:pPr>
-            <a:r>
-              <a:rPr lang="en-US" sz="1350" dirty="0">
-                <a:solidFill>
-                  <a:srgbClr val="6B7B8A"/>
-                </a:solidFill>
-                <a:latin typeface="Calibri" pitchFamily="34" charset="0"/>
-                <a:ea typeface="Calibri" pitchFamily="34" charset="-122"/>
-                <a:cs typeface="Calibri" pitchFamily="34" charset="-120"/>
-              </a:rPr>
-              <a:t>Great for the overall show-up profile, but a full month is needed for day-of-week splits.</a:t>
-            </a:r>
-            <a:endParaRPr lang="en-US" sz="1350" dirty="0"/>
+              <a:t>01-A</a:t>
+            </a:r>
+            <a:endParaRPr lang="en-US" sz="1400" dirty="0"/>
           </a:p>
         </p:txBody>
       </p:sp>
@@ -6083,12 +6172,73 @@
         </p:nvSpPr>
         <p:spPr>
           <a:xfrm>
-            <a:off x="640080" y="3200400"/>
-            <a:ext cx="10972800" cy="1234440"/>
+            <a:off x="896112" y="3282696"/>
+            <a:ext cx="950976" cy="603504"/>
           </a:xfrm>
           <a:prstGeom prst="roundRect">
             <a:avLst>
-              <a:gd name="adj" fmla="val 5926"/>
+              <a:gd name="adj" fmla="val 9091"/>
+            </a:avLst>
+          </a:prstGeom>
+          <a:solidFill>
+            <a:srgbClr val="2E8B57"/>
+          </a:solidFill>
+          <a:ln/>
+        </p:spPr>
+      </p:sp>
+      <p:sp>
+        <p:nvSpPr>
+          <p:cNvPr id="10" name="Text 8"/>
+          <p:cNvSpPr/>
+          <p:nvPr/>
+        </p:nvSpPr>
+        <p:spPr>
+          <a:xfrm>
+            <a:off x="896112" y="3282696"/>
+            <a:ext cx="950976" cy="603504"/>
+          </a:xfrm>
+          <a:prstGeom prst="rect">
+            <a:avLst/>
+          </a:prstGeom>
+          <a:noFill/>
+          <a:ln/>
+        </p:spPr>
+        <p:txBody>
+          <a:bodyPr wrap="square" lIns="0" tIns="0" rIns="0" bIns="0" rtlCol="0" anchor="ctr"/>
+          <a:lstStyle/>
+          <a:p>
+            <a:pPr algn="ctr" indent="0" marL="0">
+              <a:buNone/>
+            </a:pPr>
+            <a:r>
+              <a:rPr lang="en-US" sz="1400" b="1" dirty="0">
+                <a:solidFill>
+                  <a:srgbClr val="FFFFFF"/>
+                </a:solidFill>
+                <a:latin typeface="Cambria" pitchFamily="34" charset="0"/>
+                <a:ea typeface="Cambria" pitchFamily="34" charset="-122"/>
+                <a:cs typeface="Cambria" pitchFamily="34" charset="-120"/>
+              </a:rPr>
+              <a:t>01-B</a:t>
+            </a:r>
+            <a:endParaRPr lang="en-US" sz="1400" dirty="0"/>
+          </a:p>
+        </p:txBody>
+      </p:sp>
+      <p:sp>
+        <p:nvSpPr>
+          <p:cNvPr id="11" name="Shape 9"/>
+          <p:cNvSpPr/>
+          <p:nvPr/>
+        </p:nvSpPr>
+        <p:spPr>
+          <a:xfrm>
+            <a:off x="2267712" y="1965960"/>
+            <a:ext cx="1463040" cy="2148840"/>
+          </a:xfrm>
+          <a:prstGeom prst="roundRect">
+            <a:avLst>
+              <a:gd name="adj" fmla="val 5000"/>
             </a:avLst>
           </a:prstGeom>
           <a:solidFill>
@@ -6111,36 +6261,14 @@
       </p:sp>
       <p:sp>
         <p:nvSpPr>
-          <p:cNvPr id="10" name="Shape 8"/>
-          <p:cNvSpPr/>
-          <p:nvPr/>
-        </p:nvSpPr>
-        <p:spPr>
-          <a:xfrm>
-            <a:off x="868680" y="3456432"/>
-            <a:ext cx="731520" cy="731520"/>
-          </a:xfrm>
-          <a:prstGeom prst="roundRect">
-            <a:avLst>
-              <a:gd name="adj" fmla="val 50000"/>
-            </a:avLst>
-          </a:prstGeom>
-          <a:solidFill>
-            <a:srgbClr val="D98A2B"/>
-          </a:solidFill>
-          <a:ln/>
-        </p:spPr>
-      </p:sp>
-      <p:sp>
-        <p:nvSpPr>
-          <p:cNvPr id="11" name="Text 9"/>
-          <p:cNvSpPr/>
-          <p:nvPr/>
-        </p:nvSpPr>
-        <p:spPr>
-          <a:xfrm>
-            <a:off x="868680" y="3456432"/>
-            <a:ext cx="731520" cy="731520"/>
+          <p:cNvPr id="12" name="Text 10"/>
+          <p:cNvSpPr/>
+          <p:nvPr/>
+        </p:nvSpPr>
+        <p:spPr>
+          <a:xfrm>
+            <a:off x="2267712" y="2093976"/>
+            <a:ext cx="1463040" cy="320040"/>
           </a:xfrm>
           <a:prstGeom prst="rect">
             <a:avLst/>
@@ -6156,30 +6284,52 @@
               <a:buNone/>
             </a:pPr>
             <a:r>
-              <a:rPr lang="en-US" sz="3000" b="1" dirty="0">
-                <a:solidFill>
-                  <a:srgbClr val="FFFFFF"/>
+              <a:rPr lang="en-US" sz="1400" b="1" dirty="0">
+                <a:solidFill>
+                  <a:srgbClr val="1E2B37"/>
                 </a:solidFill>
                 <a:latin typeface="Cambria" pitchFamily="34" charset="0"/>
                 <a:ea typeface="Cambria" pitchFamily="34" charset="-122"/>
                 <a:cs typeface="Cambria" pitchFamily="34" charset="-120"/>
               </a:rPr>
-              <a:t>?</a:t>
-            </a:r>
-            <a:endParaRPr lang="en-US" sz="3000" dirty="0"/>
-          </a:p>
-        </p:txBody>
-      </p:sp>
-      <p:sp>
-        <p:nvSpPr>
-          <p:cNvPr id="12" name="Text 10"/>
-          <p:cNvSpPr/>
-          <p:nvPr/>
-        </p:nvSpPr>
-        <p:spPr>
-          <a:xfrm>
-            <a:off x="1828800" y="3401568"/>
-            <a:ext cx="9509760" cy="411480"/>
+              <a:t>Gate 02</a:t>
+            </a:r>
+            <a:endParaRPr lang="en-US" sz="1400" dirty="0"/>
+          </a:p>
+        </p:txBody>
+      </p:sp>
+      <p:sp>
+        <p:nvSpPr>
+          <p:cNvPr id="13" name="Shape 11"/>
+          <p:cNvSpPr/>
+          <p:nvPr/>
+        </p:nvSpPr>
+        <p:spPr>
+          <a:xfrm>
+            <a:off x="2523744" y="2532888"/>
+            <a:ext cx="950976" cy="603504"/>
+          </a:xfrm>
+          <a:prstGeom prst="roundRect">
+            <a:avLst>
+              <a:gd name="adj" fmla="val 9091"/>
+            </a:avLst>
+          </a:prstGeom>
+          <a:solidFill>
+            <a:srgbClr val="2E8B57"/>
+          </a:solidFill>
+          <a:ln/>
+        </p:spPr>
+      </p:sp>
+      <p:sp>
+        <p:nvSpPr>
+          <p:cNvPr id="14" name="Text 12"/>
+          <p:cNvSpPr/>
+          <p:nvPr/>
+        </p:nvSpPr>
+        <p:spPr>
+          <a:xfrm>
+            <a:off x="2523744" y="2532888"/>
+            <a:ext cx="950976" cy="603504"/>
           </a:xfrm>
           <a:prstGeom prst="rect">
             <a:avLst/>
@@ -6191,77 +6341,99 @@
           <a:bodyPr wrap="square" lIns="0" tIns="0" rIns="0" bIns="0" rtlCol="0" anchor="ctr"/>
           <a:lstStyle/>
           <a:p>
-            <a:pPr indent="0" marL="0">
+            <a:pPr algn="ctr" indent="0" marL="0">
               <a:buNone/>
             </a:pPr>
             <a:r>
-              <a:rPr lang="en-US" sz="1800" b="1" dirty="0">
-                <a:solidFill>
-                  <a:srgbClr val="1E2B37"/>
+              <a:rPr lang="en-US" sz="1400" b="1" dirty="0">
+                <a:solidFill>
+                  <a:srgbClr val="FFFFFF"/>
                 </a:solidFill>
                 <a:latin typeface="Cambria" pitchFamily="34" charset="0"/>
                 <a:ea typeface="Cambria" pitchFamily="34" charset="-122"/>
                 <a:cs typeface="Cambria" pitchFamily="34" charset="-120"/>
               </a:rPr>
-              <a:t>June sheet ambiguity</a:t>
-            </a:r>
-            <a:endParaRPr lang="en-US" sz="1800" dirty="0"/>
-          </a:p>
-        </p:txBody>
-      </p:sp>
-      <p:sp>
-        <p:nvSpPr>
-          <p:cNvPr id="13" name="Text 11"/>
-          <p:cNvSpPr/>
-          <p:nvPr/>
-        </p:nvSpPr>
-        <p:spPr>
-          <a:xfrm>
-            <a:off x="1828800" y="3822192"/>
-            <a:ext cx="9509760" cy="502920"/>
-          </a:xfrm>
-          <a:prstGeom prst="rect">
-            <a:avLst/>
-          </a:prstGeom>
-          <a:noFill/>
-          <a:ln/>
-        </p:spPr>
-        <p:txBody>
-          <a:bodyPr wrap="square" lIns="0" tIns="0" rIns="0" bIns="0" rtlCol="0" anchor="ctr"/>
-          <a:lstStyle/>
-          <a:p>
-            <a:pPr indent="0" marL="0">
-              <a:buNone/>
-            </a:pPr>
-            <a:r>
-              <a:rPr lang="en-US" sz="1350" dirty="0">
-                <a:solidFill>
-                  <a:srgbClr val="6B7B8A"/>
-                </a:solidFill>
-                <a:latin typeface="Calibri" pitchFamily="34" charset="0"/>
-                <a:ea typeface="Calibri" pitchFamily="34" charset="-122"/>
-                <a:cs typeface="Calibri" pitchFamily="34" charset="-120"/>
-              </a:rPr>
-              <a:t>The workbook’s second sheet is a July-labelled calculated copy; we used the clean June sheet only — confirm.</a:t>
-            </a:r>
-            <a:endParaRPr lang="en-US" sz="1350" dirty="0"/>
-          </a:p>
-        </p:txBody>
-      </p:sp>
-      <p:sp>
-        <p:nvSpPr>
-          <p:cNvPr id="14" name="Shape 12"/>
-          <p:cNvSpPr/>
-          <p:nvPr/>
-        </p:nvSpPr>
-        <p:spPr>
-          <a:xfrm>
-            <a:off x="640080" y="4617720"/>
-            <a:ext cx="10972800" cy="1234440"/>
+              <a:t>02-A</a:t>
+            </a:r>
+            <a:endParaRPr lang="en-US" sz="1400" dirty="0"/>
+          </a:p>
+        </p:txBody>
+      </p:sp>
+      <p:sp>
+        <p:nvSpPr>
+          <p:cNvPr id="15" name="Shape 13"/>
+          <p:cNvSpPr/>
+          <p:nvPr/>
+        </p:nvSpPr>
+        <p:spPr>
+          <a:xfrm>
+            <a:off x="2523744" y="3282696"/>
+            <a:ext cx="950976" cy="603504"/>
           </a:xfrm>
           <a:prstGeom prst="roundRect">
             <a:avLst>
-              <a:gd name="adj" fmla="val 5926"/>
+              <a:gd name="adj" fmla="val 9091"/>
+            </a:avLst>
+          </a:prstGeom>
+          <a:solidFill>
+            <a:srgbClr val="DBE2E7"/>
+          </a:solidFill>
+          <a:ln/>
+        </p:spPr>
+      </p:sp>
+      <p:sp>
+        <p:nvSpPr>
+          <p:cNvPr id="16" name="Text 14"/>
+          <p:cNvSpPr/>
+          <p:nvPr/>
+        </p:nvSpPr>
+        <p:spPr>
+          <a:xfrm>
+            <a:off x="2523744" y="3282696"/>
+            <a:ext cx="950976" cy="603504"/>
+          </a:xfrm>
+          <a:prstGeom prst="rect">
+            <a:avLst/>
+          </a:prstGeom>
+          <a:noFill/>
+          <a:ln/>
+        </p:spPr>
+        <p:txBody>
+          <a:bodyPr wrap="square" lIns="0" tIns="0" rIns="0" bIns="0" rtlCol="0" anchor="ctr"/>
+          <a:lstStyle/>
+          <a:p>
+            <a:pPr algn="ctr" indent="0" marL="0">
+              <a:buNone/>
+            </a:pPr>
+            <a:r>
+              <a:rPr lang="en-US" sz="1400" b="1" dirty="0">
+                <a:solidFill>
+                  <a:srgbClr val="6B7B8A"/>
+                </a:solidFill>
+                <a:latin typeface="Cambria" pitchFamily="34" charset="0"/>
+                <a:ea typeface="Cambria" pitchFamily="34" charset="-122"/>
+                <a:cs typeface="Cambria" pitchFamily="34" charset="-120"/>
+              </a:rPr>
+              <a:t>02-B</a:t>
+            </a:r>
+            <a:endParaRPr lang="en-US" sz="1400" dirty="0"/>
+          </a:p>
+        </p:txBody>
+      </p:sp>
+      <p:sp>
+        <p:nvSpPr>
+          <p:cNvPr id="17" name="Shape 15"/>
+          <p:cNvSpPr/>
+          <p:nvPr/>
+        </p:nvSpPr>
+        <p:spPr>
+          <a:xfrm>
+            <a:off x="3895344" y="1965960"/>
+            <a:ext cx="1463040" cy="2148840"/>
+          </a:xfrm>
+          <a:prstGeom prst="roundRect">
+            <a:avLst>
+              <a:gd name="adj" fmla="val 5000"/>
             </a:avLst>
           </a:prstGeom>
           <a:solidFill>
@@ -6284,36 +6456,14 @@
       </p:sp>
       <p:sp>
         <p:nvSpPr>
-          <p:cNvPr id="15" name="Shape 13"/>
-          <p:cNvSpPr/>
-          <p:nvPr/>
-        </p:nvSpPr>
-        <p:spPr>
-          <a:xfrm>
-            <a:off x="868680" y="4873752"/>
-            <a:ext cx="731520" cy="731520"/>
-          </a:xfrm>
-          <a:prstGeom prst="roundRect">
-            <a:avLst>
-              <a:gd name="adj" fmla="val 50000"/>
-            </a:avLst>
-          </a:prstGeom>
-          <a:solidFill>
-            <a:srgbClr val="D98A2B"/>
-          </a:solidFill>
-          <a:ln/>
-        </p:spPr>
-      </p:sp>
-      <p:sp>
-        <p:nvSpPr>
-          <p:cNvPr id="16" name="Text 14"/>
-          <p:cNvSpPr/>
-          <p:nvPr/>
-        </p:nvSpPr>
-        <p:spPr>
-          <a:xfrm>
-            <a:off x="868680" y="4873752"/>
-            <a:ext cx="731520" cy="731520"/>
+          <p:cNvPr id="18" name="Text 16"/>
+          <p:cNvSpPr/>
+          <p:nvPr/>
+        </p:nvSpPr>
+        <p:spPr>
+          <a:xfrm>
+            <a:off x="3895344" y="2093976"/>
+            <a:ext cx="1463040" cy="320040"/>
           </a:xfrm>
           <a:prstGeom prst="rect">
             <a:avLst/>
@@ -6329,30 +6479,52 @@
               <a:buNone/>
             </a:pPr>
             <a:r>
-              <a:rPr lang="en-US" sz="3000" b="1" dirty="0">
-                <a:solidFill>
-                  <a:srgbClr val="FFFFFF"/>
+              <a:rPr lang="en-US" sz="1400" b="1" dirty="0">
+                <a:solidFill>
+                  <a:srgbClr val="1E2B37"/>
                 </a:solidFill>
                 <a:latin typeface="Cambria" pitchFamily="34" charset="0"/>
                 <a:ea typeface="Cambria" pitchFamily="34" charset="-122"/>
                 <a:cs typeface="Cambria" pitchFamily="34" charset="-120"/>
               </a:rPr>
-              <a:t>?</a:t>
-            </a:r>
-            <a:endParaRPr lang="en-US" sz="3000" dirty="0"/>
-          </a:p>
-        </p:txBody>
-      </p:sp>
-      <p:sp>
-        <p:nvSpPr>
-          <p:cNvPr id="17" name="Text 15"/>
-          <p:cNvSpPr/>
-          <p:nvPr/>
-        </p:nvSpPr>
-        <p:spPr>
-          <a:xfrm>
-            <a:off x="1828800" y="4818888"/>
-            <a:ext cx="9509760" cy="411480"/>
+              <a:t>Gate 03</a:t>
+            </a:r>
+            <a:endParaRPr lang="en-US" sz="1400" dirty="0"/>
+          </a:p>
+        </p:txBody>
+      </p:sp>
+      <p:sp>
+        <p:nvSpPr>
+          <p:cNvPr id="19" name="Shape 17"/>
+          <p:cNvSpPr/>
+          <p:nvPr/>
+        </p:nvSpPr>
+        <p:spPr>
+          <a:xfrm>
+            <a:off x="4151376" y="2532888"/>
+            <a:ext cx="950976" cy="603504"/>
+          </a:xfrm>
+          <a:prstGeom prst="roundRect">
+            <a:avLst>
+              <a:gd name="adj" fmla="val 9091"/>
+            </a:avLst>
+          </a:prstGeom>
+          <a:solidFill>
+            <a:srgbClr val="2E8B57"/>
+          </a:solidFill>
+          <a:ln/>
+        </p:spPr>
+      </p:sp>
+      <p:sp>
+        <p:nvSpPr>
+          <p:cNvPr id="20" name="Text 18"/>
+          <p:cNvSpPr/>
+          <p:nvPr/>
+        </p:nvSpPr>
+        <p:spPr>
+          <a:xfrm>
+            <a:off x="4151376" y="2532888"/>
+            <a:ext cx="950976" cy="603504"/>
           </a:xfrm>
           <a:prstGeom prst="rect">
             <a:avLst/>
@@ -6364,34 +6536,117 @@
           <a:bodyPr wrap="square" lIns="0" tIns="0" rIns="0" bIns="0" rtlCol="0" anchor="ctr"/>
           <a:lstStyle/>
           <a:p>
-            <a:pPr indent="0" marL="0">
+            <a:pPr algn="ctr" indent="0" marL="0">
               <a:buNone/>
             </a:pPr>
             <a:r>
-              <a:rPr lang="en-US" sz="1800" b="1" dirty="0">
-                <a:solidFill>
-                  <a:srgbClr val="1E2B37"/>
+              <a:rPr lang="en-US" sz="1400" b="1" dirty="0">
+                <a:solidFill>
+                  <a:srgbClr val="FFFFFF"/>
                 </a:solidFill>
                 <a:latin typeface="Cambria" pitchFamily="34" charset="0"/>
                 <a:ea typeface="Cambria" pitchFamily="34" charset="-122"/>
                 <a:cs typeface="Cambria" pitchFamily="34" charset="-120"/>
               </a:rPr>
-              <a:t>Throughput assumption</a:t>
-            </a:r>
-            <a:endParaRPr lang="en-US" sz="1800" dirty="0"/>
-          </a:p>
-        </p:txBody>
-      </p:sp>
-      <p:sp>
-        <p:nvSpPr>
-          <p:cNvPr id="18" name="Text 16"/>
-          <p:cNvSpPr/>
-          <p:nvPr/>
-        </p:nvSpPr>
-        <p:spPr>
-          <a:xfrm>
-            <a:off x="1828800" y="5239512"/>
-            <a:ext cx="9509760" cy="502920"/>
+              <a:t>03-A</a:t>
+            </a:r>
+            <a:endParaRPr lang="en-US" sz="1400" dirty="0"/>
+          </a:p>
+        </p:txBody>
+      </p:sp>
+      <p:sp>
+        <p:nvSpPr>
+          <p:cNvPr id="21" name="Shape 19"/>
+          <p:cNvSpPr/>
+          <p:nvPr/>
+        </p:nvSpPr>
+        <p:spPr>
+          <a:xfrm>
+            <a:off x="4151376" y="3282696"/>
+            <a:ext cx="950976" cy="603504"/>
+          </a:xfrm>
+          <a:prstGeom prst="roundRect">
+            <a:avLst>
+              <a:gd name="adj" fmla="val 9091"/>
+            </a:avLst>
+          </a:prstGeom>
+          <a:solidFill>
+            <a:srgbClr val="DBE2E7"/>
+          </a:solidFill>
+          <a:ln/>
+        </p:spPr>
+      </p:sp>
+      <p:sp>
+        <p:nvSpPr>
+          <p:cNvPr id="22" name="Text 20"/>
+          <p:cNvSpPr/>
+          <p:nvPr/>
+        </p:nvSpPr>
+        <p:spPr>
+          <a:xfrm>
+            <a:off x="4151376" y="3282696"/>
+            <a:ext cx="950976" cy="603504"/>
+          </a:xfrm>
+          <a:prstGeom prst="rect">
+            <a:avLst/>
+          </a:prstGeom>
+          <a:noFill/>
+          <a:ln/>
+        </p:spPr>
+        <p:txBody>
+          <a:bodyPr wrap="square" lIns="0" tIns="0" rIns="0" bIns="0" rtlCol="0" anchor="ctr"/>
+          <a:lstStyle/>
+          <a:p>
+            <a:pPr algn="ctr" indent="0" marL="0">
+              <a:buNone/>
+            </a:pPr>
+            <a:r>
+              <a:rPr lang="en-US" sz="1400" b="1" dirty="0">
+                <a:solidFill>
+                  <a:srgbClr val="6B7B8A"/>
+                </a:solidFill>
+                <a:latin typeface="Cambria" pitchFamily="34" charset="0"/>
+                <a:ea typeface="Cambria" pitchFamily="34" charset="-122"/>
+                <a:cs typeface="Cambria" pitchFamily="34" charset="-120"/>
+              </a:rPr>
+              <a:t>03-B</a:t>
+            </a:r>
+            <a:endParaRPr lang="en-US" sz="1400" dirty="0"/>
+          </a:p>
+        </p:txBody>
+      </p:sp>
+      <p:sp>
+        <p:nvSpPr>
+          <p:cNvPr id="23" name="Shape 21"/>
+          <p:cNvSpPr/>
+          <p:nvPr/>
+        </p:nvSpPr>
+        <p:spPr>
+          <a:xfrm>
+            <a:off x="640080" y="4343400"/>
+            <a:ext cx="4882896" cy="457200"/>
+          </a:xfrm>
+          <a:prstGeom prst="roundRect">
+            <a:avLst>
+              <a:gd name="adj" fmla="val 10000"/>
+            </a:avLst>
+          </a:prstGeom>
+          <a:solidFill>
+            <a:srgbClr val="EAF6F5"/>
+          </a:solidFill>
+          <a:ln/>
+        </p:spPr>
+      </p:sp>
+      <p:sp>
+        <p:nvSpPr>
+          <p:cNvPr id="24" name="Text 22"/>
+          <p:cNvSpPr/>
+          <p:nvPr/>
+        </p:nvSpPr>
+        <p:spPr>
+          <a:xfrm>
+            <a:off x="822960" y="4343400"/>
+            <a:ext cx="4572000" cy="457200"/>
           </a:xfrm>
           <a:prstGeom prst="rect">
             <a:avLst/>
@@ -6407,17 +6662,1863 @@
               <a:buNone/>
             </a:pPr>
             <a:r>
-              <a:rPr lang="en-US" sz="1350" dirty="0">
-                <a:solidFill>
-                  <a:srgbClr val="6B7B8A"/>
+              <a:rPr lang="en-US" sz="1250" b="1" dirty="0">
+                <a:solidFill>
+                  <a:srgbClr val="0A3D5C"/>
                 </a:solidFill>
                 <a:latin typeface="Calibri" pitchFamily="34" charset="0"/>
                 <a:ea typeface="Calibri" pitchFamily="34" charset="-122"/>
                 <a:cs typeface="Calibri" pitchFamily="34" charset="-120"/>
               </a:rPr>
-              <a:t>ATRS 180 trays/hr and 1.5 trays/pax → 120 pax/hr/lane (60 per 30 min). Confirm the rate.</a:t>
+              <a:t>At peak: </a:t>
+            </a:r>
+            <a:pPr indent="0" marL="0">
+              <a:buNone/>
+            </a:pPr>
+            <a:r>
+              <a:rPr lang="en-US" sz="1250" dirty="0">
+                <a:solidFill>
+                  <a:srgbClr val="1E2B37"/>
+                </a:solidFill>
+                <a:latin typeface="Calibri" pitchFamily="34" charset="0"/>
+                <a:ea typeface="Calibri" pitchFamily="34" charset="-122"/>
+                <a:cs typeface="Calibri" pitchFamily="34" charset="-120"/>
+              </a:rPr>
+              <a:t>4 of 6 lanes, all 3 gates open — 2 lanes spare (at 120 pax/hr/lane).</a:t>
+            </a:r>
+            <a:endParaRPr lang="en-US" sz="1250" dirty="0"/>
+          </a:p>
+        </p:txBody>
+      </p:sp>
+      <p:sp>
+        <p:nvSpPr>
+          <p:cNvPr id="25" name="Text 23"/>
+          <p:cNvSpPr/>
+          <p:nvPr/>
+        </p:nvSpPr>
+        <p:spPr>
+          <a:xfrm>
+            <a:off x="640080" y="4892040"/>
+            <a:ext cx="4846320" cy="274320"/>
+          </a:xfrm>
+          <a:prstGeom prst="rect">
+            <a:avLst/>
+          </a:prstGeom>
+          <a:noFill/>
+          <a:ln/>
+        </p:spPr>
+        <p:txBody>
+          <a:bodyPr wrap="square" lIns="0" tIns="0" rIns="0" bIns="0" rtlCol="0" anchor="ctr"/>
+          <a:lstStyle/>
+          <a:p>
+            <a:pPr indent="0" marL="0">
+              <a:buNone/>
+            </a:pPr>
+            <a:r>
+              <a:rPr lang="en-US" sz="1050" dirty="0">
+                <a:solidFill>
+                  <a:srgbClr val="6B7B8A"/>
+                </a:solidFill>
+                <a:latin typeface="Calibri" pitchFamily="34" charset="0"/>
+                <a:ea typeface="Calibri" pitchFamily="34" charset="-122"/>
+                <a:cs typeface="Calibri" pitchFamily="34" charset="-120"/>
+              </a:rPr>
+              <a:t>■ open at peak    ■ spare</a:t>
+            </a:r>
+            <a:endParaRPr lang="en-US" sz="1050" dirty="0"/>
+          </a:p>
+        </p:txBody>
+      </p:sp>
+      <p:sp>
+        <p:nvSpPr>
+          <p:cNvPr id="26" name="Text 24"/>
+          <p:cNvSpPr/>
+          <p:nvPr/>
+        </p:nvSpPr>
+        <p:spPr>
+          <a:xfrm>
+            <a:off x="5943600" y="1517904"/>
+            <a:ext cx="5669280" cy="320040"/>
+          </a:xfrm>
+          <a:prstGeom prst="rect">
+            <a:avLst/>
+          </a:prstGeom>
+          <a:noFill/>
+          <a:ln/>
+        </p:spPr>
+        <p:txBody>
+          <a:bodyPr wrap="square" lIns="0" tIns="0" rIns="0" bIns="0" rtlCol="0" anchor="ctr"/>
+          <a:lstStyle/>
+          <a:p>
+            <a:pPr indent="0" marL="0">
+              <a:buNone/>
+            </a:pPr>
+            <a:r>
+              <a:rPr lang="en-US" sz="1350" b="1" dirty="0">
+                <a:solidFill>
+                  <a:srgbClr val="0A3D5C"/>
+                </a:solidFill>
+                <a:latin typeface="Cambria" pitchFamily="34" charset="0"/>
+                <a:ea typeface="Cambria" pitchFamily="34" charset="-122"/>
+                <a:cs typeface="Cambria" pitchFamily="34" charset="-120"/>
+              </a:rPr>
+              <a:t>If the lane throughput is different… (peak lanes needed)</a:t>
             </a:r>
             <a:endParaRPr lang="en-US" sz="1350" dirty="0"/>
+          </a:p>
+        </p:txBody>
+      </p:sp>
+      <p:graphicFrame>
+        <p:nvGraphicFramePr>
+          <p:cNvPr id="13" name="Table 0"/>
+          <p:cNvGraphicFramePr>
+            <a:graphicFrameLocks noGrp="1"/>
+          </p:cNvGraphicFramePr>
+          <p:nvPr>
+            <p:extLst>
+              <p:ext uri="{D42A27DB-BD31-4B8C-83A1-F6EECF244321}">
+                <p14:modId xmlns:p14="http://schemas.microsoft.com/office/powerpoint/2010/main" val="1579011935"/>
+              </p:ext>
+            </p:extLst>
+          </p:nvPr>
+        </p:nvGraphicFramePr>
+        <p:xfrm>
+          <a:off x="5943600" y="1901952"/>
+          <a:ext cx="5669280" cy="914400"/>
+        </p:xfrm>
+        <a:graphic>
+          <a:graphicData uri="http://schemas.openxmlformats.org/drawingml/2006/table">
+            <a:tbl>
+              <a:tblPr/>
+              <a:tblGrid>
+                <a:gridCol w="2148840"/>
+                <a:gridCol w="1691640"/>
+                <a:gridCol w="1828800"/>
+              </a:tblGrid>
+              <a:tr h="402336">
+                <a:tc>
+                  <a:txBody>
+                    <a:bodyPr/>
+                    <a:lstStyle/>
+                    <a:p>
+                      <a:pPr algn="l" indent="0" marL="0">
+                        <a:buNone/>
+                      </a:pPr>
+                      <a:r>
+                        <a:rPr lang="en-US" sz="1150" b="1" dirty="0">
+                          <a:solidFill>
+                            <a:srgbClr val="FFFFFF"/>
+                          </a:solidFill>
+                          <a:latin typeface="Cambria" pitchFamily="34" charset="0"/>
+                          <a:ea typeface="Cambria" pitchFamily="34" charset="-122"/>
+                          <a:cs typeface="Cambria" pitchFamily="34" charset="-120"/>
+                        </a:rPr>
+                        <a:t>Rate (pax/hr/lane)</a:t>
+                      </a:r>
+                      <a:endParaRPr lang="en-US" sz="1150" dirty="0">
+                        <a:latin typeface="Cambria" charset="0"/>
+                        <a:ea typeface="Cambria" charset="0"/>
+                        <a:cs typeface="Cambria" charset="0"/>
+                      </a:endParaRPr>
+                    </a:p>
+                  </a:txBody>
+                  <a:tcPr marL="63500" marR="63500" marT="25400" marB="25400" anchor="ctr">
+                    <a:lnL w="12700" cap="flat" cmpd="sng" algn="ctr">
+                      <a:solidFill>
+                        <a:srgbClr val="D5DEE5"/>
+                      </a:solidFill>
+                      <a:prstDash val="solid"/>
+                      <a:round/>
+                      <a:headEnd type="none" w="med" len="med"/>
+                      <a:tailEnd type="none" w="med" len="med"/>
+                    </a:lnL>
+                    <a:lnR w="12700" cap="flat" cmpd="sng" algn="ctr">
+                      <a:solidFill>
+                        <a:srgbClr val="D5DEE5"/>
+                      </a:solidFill>
+                      <a:prstDash val="solid"/>
+                      <a:round/>
+                      <a:headEnd type="none" w="med" len="med"/>
+                      <a:tailEnd type="none" w="med" len="med"/>
+                    </a:lnR>
+                    <a:lnT w="12700" cap="flat" cmpd="sng" algn="ctr">
+                      <a:solidFill>
+                        <a:srgbClr val="D5DEE5"/>
+                      </a:solidFill>
+                      <a:prstDash val="solid"/>
+                      <a:round/>
+                      <a:headEnd type="none" w="med" len="med"/>
+                      <a:tailEnd type="none" w="med" len="med"/>
+                    </a:lnT>
+                    <a:lnB w="12700" cap="flat" cmpd="sng" algn="ctr">
+                      <a:solidFill>
+                        <a:srgbClr val="D5DEE5"/>
+                      </a:solidFill>
+                      <a:prstDash val="solid"/>
+                      <a:round/>
+                      <a:headEnd type="none" w="med" len="med"/>
+                      <a:tailEnd type="none" w="med" len="med"/>
+                    </a:lnB>
+                    <a:solidFill>
+                      <a:srgbClr val="0A3D5C"/>
+                    </a:solidFill>
+                  </a:tcPr>
+                </a:tc>
+                <a:tc>
+                  <a:txBody>
+                    <a:bodyPr/>
+                    <a:lstStyle/>
+                    <a:p>
+                      <a:pPr algn="ctr" indent="0" marL="0">
+                        <a:buNone/>
+                      </a:pPr>
+                      <a:r>
+                        <a:rPr lang="en-US" sz="1150" b="1" dirty="0">
+                          <a:solidFill>
+                            <a:srgbClr val="FFFFFF"/>
+                          </a:solidFill>
+                          <a:latin typeface="Cambria" pitchFamily="34" charset="0"/>
+                          <a:ea typeface="Cambria" pitchFamily="34" charset="-122"/>
+                          <a:cs typeface="Cambria" pitchFamily="34" charset="-120"/>
+                        </a:rPr>
+                        <a:t>Peak lanes (of 6)</a:t>
+                      </a:r>
+                      <a:endParaRPr lang="en-US" sz="1150" dirty="0">
+                        <a:latin typeface="Cambria" charset="0"/>
+                        <a:ea typeface="Cambria" charset="0"/>
+                        <a:cs typeface="Cambria" charset="0"/>
+                      </a:endParaRPr>
+                    </a:p>
+                  </a:txBody>
+                  <a:tcPr marL="63500" marR="63500" marT="25400" marB="25400" anchor="ctr">
+                    <a:lnL w="12700" cap="flat" cmpd="sng" algn="ctr">
+                      <a:solidFill>
+                        <a:srgbClr val="D5DEE5"/>
+                      </a:solidFill>
+                      <a:prstDash val="solid"/>
+                      <a:round/>
+                      <a:headEnd type="none" w="med" len="med"/>
+                      <a:tailEnd type="none" w="med" len="med"/>
+                    </a:lnL>
+                    <a:lnR w="12700" cap="flat" cmpd="sng" algn="ctr">
+                      <a:solidFill>
+                        <a:srgbClr val="D5DEE5"/>
+                      </a:solidFill>
+                      <a:prstDash val="solid"/>
+                      <a:round/>
+                      <a:headEnd type="none" w="med" len="med"/>
+                      <a:tailEnd type="none" w="med" len="med"/>
+                    </a:lnR>
+                    <a:lnT w="12700" cap="flat" cmpd="sng" algn="ctr">
+                      <a:solidFill>
+                        <a:srgbClr val="D5DEE5"/>
+                      </a:solidFill>
+                      <a:prstDash val="solid"/>
+                      <a:round/>
+                      <a:headEnd type="none" w="med" len="med"/>
+                      <a:tailEnd type="none" w="med" len="med"/>
+                    </a:lnT>
+                    <a:lnB w="12700" cap="flat" cmpd="sng" algn="ctr">
+                      <a:solidFill>
+                        <a:srgbClr val="D5DEE5"/>
+                      </a:solidFill>
+                      <a:prstDash val="solid"/>
+                      <a:round/>
+                      <a:headEnd type="none" w="med" len="med"/>
+                      <a:tailEnd type="none" w="med" len="med"/>
+                    </a:lnB>
+                    <a:solidFill>
+                      <a:srgbClr val="0A3D5C"/>
+                    </a:solidFill>
+                  </a:tcPr>
+                </a:tc>
+                <a:tc>
+                  <a:txBody>
+                    <a:bodyPr/>
+                    <a:lstStyle/>
+                    <a:p>
+                      <a:pPr algn="ctr" indent="0" marL="0">
+                        <a:buNone/>
+                      </a:pPr>
+                      <a:r>
+                        <a:rPr lang="en-US" sz="1150" b="1" dirty="0">
+                          <a:solidFill>
+                            <a:srgbClr val="FFFFFF"/>
+                          </a:solidFill>
+                          <a:latin typeface="Cambria" pitchFamily="34" charset="0"/>
+                          <a:ea typeface="Cambria" pitchFamily="34" charset="-122"/>
+                          <a:cs typeface="Cambria" pitchFamily="34" charset="-120"/>
+                        </a:rPr>
+                        <a:t>Verdict</a:t>
+                      </a:r>
+                      <a:endParaRPr lang="en-US" sz="1150" dirty="0">
+                        <a:latin typeface="Cambria" charset="0"/>
+                        <a:ea typeface="Cambria" charset="0"/>
+                        <a:cs typeface="Cambria" charset="0"/>
+                      </a:endParaRPr>
+                    </a:p>
+                  </a:txBody>
+                  <a:tcPr marL="63500" marR="63500" marT="25400" marB="25400" anchor="ctr">
+                    <a:lnL w="12700" cap="flat" cmpd="sng" algn="ctr">
+                      <a:solidFill>
+                        <a:srgbClr val="D5DEE5"/>
+                      </a:solidFill>
+                      <a:prstDash val="solid"/>
+                      <a:round/>
+                      <a:headEnd type="none" w="med" len="med"/>
+                      <a:tailEnd type="none" w="med" len="med"/>
+                    </a:lnL>
+                    <a:lnR w="12700" cap="flat" cmpd="sng" algn="ctr">
+                      <a:solidFill>
+                        <a:srgbClr val="D5DEE5"/>
+                      </a:solidFill>
+                      <a:prstDash val="solid"/>
+                      <a:round/>
+                      <a:headEnd type="none" w="med" len="med"/>
+                      <a:tailEnd type="none" w="med" len="med"/>
+                    </a:lnR>
+                    <a:lnT w="12700" cap="flat" cmpd="sng" algn="ctr">
+                      <a:solidFill>
+                        <a:srgbClr val="D5DEE5"/>
+                      </a:solidFill>
+                      <a:prstDash val="solid"/>
+                      <a:round/>
+                      <a:headEnd type="none" w="med" len="med"/>
+                      <a:tailEnd type="none" w="med" len="med"/>
+                    </a:lnT>
+                    <a:lnB w="12700" cap="flat" cmpd="sng" algn="ctr">
+                      <a:solidFill>
+                        <a:srgbClr val="D5DEE5"/>
+                      </a:solidFill>
+                      <a:prstDash val="solid"/>
+                      <a:round/>
+                      <a:headEnd type="none" w="med" len="med"/>
+                      <a:tailEnd type="none" w="med" len="med"/>
+                    </a:lnB>
+                    <a:solidFill>
+                      <a:srgbClr val="0A3D5C"/>
+                    </a:solidFill>
+                  </a:tcPr>
+                </a:tc>
+              </a:tr>
+              <a:tr h="402336">
+                <a:tc>
+                  <a:txBody>
+                    <a:bodyPr/>
+                    <a:lstStyle/>
+                    <a:p>
+                      <a:pPr algn="l" indent="0" marL="0">
+                        <a:buNone/>
+                      </a:pPr>
+                      <a:r>
+                        <a:rPr lang="en-US" sz="1250" dirty="0">
+                          <a:solidFill>
+                            <a:srgbClr val="1E2B37"/>
+                          </a:solidFill>
+                          <a:latin typeface="Calibri" pitchFamily="34" charset="0"/>
+                          <a:ea typeface="Calibri" pitchFamily="34" charset="-122"/>
+                          <a:cs typeface="Calibri" pitchFamily="34" charset="-120"/>
+                        </a:rPr>
+                        <a:t>60</a:t>
+                      </a:r>
+                      <a:endParaRPr lang="en-US" sz="1250" dirty="0">
+                        <a:latin typeface="Calibri" charset="0"/>
+                        <a:ea typeface="Calibri" charset="0"/>
+                        <a:cs typeface="Calibri" charset="0"/>
+                      </a:endParaRPr>
+                    </a:p>
+                  </a:txBody>
+                  <a:tcPr marL="63500" marR="63500" marT="25400" marB="25400" anchor="ctr">
+                    <a:lnL w="12700" cap="flat" cmpd="sng" algn="ctr">
+                      <a:solidFill>
+                        <a:srgbClr val="D5DEE5"/>
+                      </a:solidFill>
+                      <a:prstDash val="solid"/>
+                      <a:round/>
+                      <a:headEnd type="none" w="med" len="med"/>
+                      <a:tailEnd type="none" w="med" len="med"/>
+                    </a:lnL>
+                    <a:lnR w="12700" cap="flat" cmpd="sng" algn="ctr">
+                      <a:solidFill>
+                        <a:srgbClr val="D5DEE5"/>
+                      </a:solidFill>
+                      <a:prstDash val="solid"/>
+                      <a:round/>
+                      <a:headEnd type="none" w="med" len="med"/>
+                      <a:tailEnd type="none" w="med" len="med"/>
+                    </a:lnR>
+                    <a:lnT w="12700" cap="flat" cmpd="sng" algn="ctr">
+                      <a:solidFill>
+                        <a:srgbClr val="D5DEE5"/>
+                      </a:solidFill>
+                      <a:prstDash val="solid"/>
+                      <a:round/>
+                      <a:headEnd type="none" w="med" len="med"/>
+                      <a:tailEnd type="none" w="med" len="med"/>
+                    </a:lnT>
+                    <a:lnB w="12700" cap="flat" cmpd="sng" algn="ctr">
+                      <a:solidFill>
+                        <a:srgbClr val="D5DEE5"/>
+                      </a:solidFill>
+                      <a:prstDash val="solid"/>
+                      <a:round/>
+                      <a:headEnd type="none" w="med" len="med"/>
+                      <a:tailEnd type="none" w="med" len="med"/>
+                    </a:lnB>
+                    <a:solidFill>
+                      <a:srgbClr val="F4F7F9"/>
+                    </a:solidFill>
+                  </a:tcPr>
+                </a:tc>
+                <a:tc>
+                  <a:txBody>
+                    <a:bodyPr/>
+                    <a:lstStyle/>
+                    <a:p>
+                      <a:pPr algn="ctr" indent="0" marL="0">
+                        <a:buNone/>
+                      </a:pPr>
+                      <a:r>
+                        <a:rPr lang="en-US" sz="1250" dirty="0">
+                          <a:solidFill>
+                            <a:srgbClr val="1E2B37"/>
+                          </a:solidFill>
+                          <a:latin typeface="Calibri" pitchFamily="34" charset="0"/>
+                          <a:ea typeface="Calibri" pitchFamily="34" charset="-122"/>
+                          <a:cs typeface="Calibri" pitchFamily="34" charset="-120"/>
+                        </a:rPr>
+                        <a:t>8</a:t>
+                      </a:r>
+                      <a:endParaRPr lang="en-US" sz="1250" dirty="0">
+                        <a:latin typeface="Calibri" charset="0"/>
+                        <a:ea typeface="Calibri" charset="0"/>
+                        <a:cs typeface="Calibri" charset="0"/>
+                      </a:endParaRPr>
+                    </a:p>
+                  </a:txBody>
+                  <a:tcPr marL="63500" marR="63500" marT="25400" marB="25400" anchor="ctr">
+                    <a:lnL w="12700" cap="flat" cmpd="sng" algn="ctr">
+                      <a:solidFill>
+                        <a:srgbClr val="D5DEE5"/>
+                      </a:solidFill>
+                      <a:prstDash val="solid"/>
+                      <a:round/>
+                      <a:headEnd type="none" w="med" len="med"/>
+                      <a:tailEnd type="none" w="med" len="med"/>
+                    </a:lnL>
+                    <a:lnR w="12700" cap="flat" cmpd="sng" algn="ctr">
+                      <a:solidFill>
+                        <a:srgbClr val="D5DEE5"/>
+                      </a:solidFill>
+                      <a:prstDash val="solid"/>
+                      <a:round/>
+                      <a:headEnd type="none" w="med" len="med"/>
+                      <a:tailEnd type="none" w="med" len="med"/>
+                    </a:lnR>
+                    <a:lnT w="12700" cap="flat" cmpd="sng" algn="ctr">
+                      <a:solidFill>
+                        <a:srgbClr val="D5DEE5"/>
+                      </a:solidFill>
+                      <a:prstDash val="solid"/>
+                      <a:round/>
+                      <a:headEnd type="none" w="med" len="med"/>
+                      <a:tailEnd type="none" w="med" len="med"/>
+                    </a:lnT>
+                    <a:lnB w="12700" cap="flat" cmpd="sng" algn="ctr">
+                      <a:solidFill>
+                        <a:srgbClr val="D5DEE5"/>
+                      </a:solidFill>
+                      <a:prstDash val="solid"/>
+                      <a:round/>
+                      <a:headEnd type="none" w="med" len="med"/>
+                      <a:tailEnd type="none" w="med" len="med"/>
+                    </a:lnB>
+                    <a:solidFill>
+                      <a:srgbClr val="F4F7F9"/>
+                    </a:solidFill>
+                  </a:tcPr>
+                </a:tc>
+                <a:tc>
+                  <a:txBody>
+                    <a:bodyPr/>
+                    <a:lstStyle/>
+                    <a:p>
+                      <a:pPr algn="ctr" indent="0" marL="0">
+                        <a:buNone/>
+                      </a:pPr>
+                      <a:r>
+                        <a:rPr lang="en-US" sz="1250" dirty="0">
+                          <a:solidFill>
+                            <a:srgbClr val="C0392B"/>
+                          </a:solidFill>
+                          <a:latin typeface="Calibri" pitchFamily="34" charset="0"/>
+                          <a:ea typeface="Calibri" pitchFamily="34" charset="-122"/>
+                          <a:cs typeface="Calibri" pitchFamily="34" charset="-120"/>
+                        </a:rPr>
+                        <a:t>Short — only 6 exist</a:t>
+                      </a:r>
+                      <a:endParaRPr lang="en-US" sz="1250" dirty="0">
+                        <a:latin typeface="Calibri" charset="0"/>
+                        <a:ea typeface="Calibri" charset="0"/>
+                        <a:cs typeface="Calibri" charset="0"/>
+                      </a:endParaRPr>
+                    </a:p>
+                  </a:txBody>
+                  <a:tcPr marL="63500" marR="63500" marT="25400" marB="25400" anchor="ctr">
+                    <a:lnL w="12700" cap="flat" cmpd="sng" algn="ctr">
+                      <a:solidFill>
+                        <a:srgbClr val="D5DEE5"/>
+                      </a:solidFill>
+                      <a:prstDash val="solid"/>
+                      <a:round/>
+                      <a:headEnd type="none" w="med" len="med"/>
+                      <a:tailEnd type="none" w="med" len="med"/>
+                    </a:lnL>
+                    <a:lnR w="12700" cap="flat" cmpd="sng" algn="ctr">
+                      <a:solidFill>
+                        <a:srgbClr val="D5DEE5"/>
+                      </a:solidFill>
+                      <a:prstDash val="solid"/>
+                      <a:round/>
+                      <a:headEnd type="none" w="med" len="med"/>
+                      <a:tailEnd type="none" w="med" len="med"/>
+                    </a:lnR>
+                    <a:lnT w="12700" cap="flat" cmpd="sng" algn="ctr">
+                      <a:solidFill>
+                        <a:srgbClr val="D5DEE5"/>
+                      </a:solidFill>
+                      <a:prstDash val="solid"/>
+                      <a:round/>
+                      <a:headEnd type="none" w="med" len="med"/>
+                      <a:tailEnd type="none" w="med" len="med"/>
+                    </a:lnT>
+                    <a:lnB w="12700" cap="flat" cmpd="sng" algn="ctr">
+                      <a:solidFill>
+                        <a:srgbClr val="D5DEE5"/>
+                      </a:solidFill>
+                      <a:prstDash val="solid"/>
+                      <a:round/>
+                      <a:headEnd type="none" w="med" len="med"/>
+                      <a:tailEnd type="none" w="med" len="med"/>
+                    </a:lnB>
+                    <a:solidFill>
+                      <a:srgbClr val="F4F7F9"/>
+                    </a:solidFill>
+                  </a:tcPr>
+                </a:tc>
+              </a:tr>
+              <a:tr h="402336">
+                <a:tc>
+                  <a:txBody>
+                    <a:bodyPr/>
+                    <a:lstStyle/>
+                    <a:p>
+                      <a:pPr algn="l" indent="0" marL="0">
+                        <a:buNone/>
+                      </a:pPr>
+                      <a:r>
+                        <a:rPr lang="en-US" sz="1250" dirty="0">
+                          <a:solidFill>
+                            <a:srgbClr val="1E2B37"/>
+                          </a:solidFill>
+                          <a:latin typeface="Calibri" pitchFamily="34" charset="0"/>
+                          <a:ea typeface="Calibri" pitchFamily="34" charset="-122"/>
+                          <a:cs typeface="Calibri" pitchFamily="34" charset="-120"/>
+                        </a:rPr>
+                        <a:t>80</a:t>
+                      </a:r>
+                      <a:endParaRPr lang="en-US" sz="1250" dirty="0">
+                        <a:latin typeface="Calibri" charset="0"/>
+                        <a:ea typeface="Calibri" charset="0"/>
+                        <a:cs typeface="Calibri" charset="0"/>
+                      </a:endParaRPr>
+                    </a:p>
+                  </a:txBody>
+                  <a:tcPr marL="63500" marR="63500" marT="25400" marB="25400" anchor="ctr">
+                    <a:lnL w="12700" cap="flat" cmpd="sng" algn="ctr">
+                      <a:solidFill>
+                        <a:srgbClr val="D5DEE5"/>
+                      </a:solidFill>
+                      <a:prstDash val="solid"/>
+                      <a:round/>
+                      <a:headEnd type="none" w="med" len="med"/>
+                      <a:tailEnd type="none" w="med" len="med"/>
+                    </a:lnL>
+                    <a:lnR w="12700" cap="flat" cmpd="sng" algn="ctr">
+                      <a:solidFill>
+                        <a:srgbClr val="D5DEE5"/>
+                      </a:solidFill>
+                      <a:prstDash val="solid"/>
+                      <a:round/>
+                      <a:headEnd type="none" w="med" len="med"/>
+                      <a:tailEnd type="none" w="med" len="med"/>
+                    </a:lnR>
+                    <a:lnT w="12700" cap="flat" cmpd="sng" algn="ctr">
+                      <a:solidFill>
+                        <a:srgbClr val="D5DEE5"/>
+                      </a:solidFill>
+                      <a:prstDash val="solid"/>
+                      <a:round/>
+                      <a:headEnd type="none" w="med" len="med"/>
+                      <a:tailEnd type="none" w="med" len="med"/>
+                    </a:lnT>
+                    <a:lnB w="12700" cap="flat" cmpd="sng" algn="ctr">
+                      <a:solidFill>
+                        <a:srgbClr val="D5DEE5"/>
+                      </a:solidFill>
+                      <a:prstDash val="solid"/>
+                      <a:round/>
+                      <a:headEnd type="none" w="med" len="med"/>
+                      <a:tailEnd type="none" w="med" len="med"/>
+                    </a:lnB>
+                    <a:solidFill>
+                      <a:srgbClr val="FFFFFF"/>
+                    </a:solidFill>
+                  </a:tcPr>
+                </a:tc>
+                <a:tc>
+                  <a:txBody>
+                    <a:bodyPr/>
+                    <a:lstStyle/>
+                    <a:p>
+                      <a:pPr algn="ctr" indent="0" marL="0">
+                        <a:buNone/>
+                      </a:pPr>
+                      <a:r>
+                        <a:rPr lang="en-US" sz="1250" dirty="0">
+                          <a:solidFill>
+                            <a:srgbClr val="1E2B37"/>
+                          </a:solidFill>
+                          <a:latin typeface="Calibri" pitchFamily="34" charset="0"/>
+                          <a:ea typeface="Calibri" pitchFamily="34" charset="-122"/>
+                          <a:cs typeface="Calibri" pitchFamily="34" charset="-120"/>
+                        </a:rPr>
+                        <a:t>6</a:t>
+                      </a:r>
+                      <a:endParaRPr lang="en-US" sz="1250" dirty="0">
+                        <a:latin typeface="Calibri" charset="0"/>
+                        <a:ea typeface="Calibri" charset="0"/>
+                        <a:cs typeface="Calibri" charset="0"/>
+                      </a:endParaRPr>
+                    </a:p>
+                  </a:txBody>
+                  <a:tcPr marL="63500" marR="63500" marT="25400" marB="25400" anchor="ctr">
+                    <a:lnL w="12700" cap="flat" cmpd="sng" algn="ctr">
+                      <a:solidFill>
+                        <a:srgbClr val="D5DEE5"/>
+                      </a:solidFill>
+                      <a:prstDash val="solid"/>
+                      <a:round/>
+                      <a:headEnd type="none" w="med" len="med"/>
+                      <a:tailEnd type="none" w="med" len="med"/>
+                    </a:lnL>
+                    <a:lnR w="12700" cap="flat" cmpd="sng" algn="ctr">
+                      <a:solidFill>
+                        <a:srgbClr val="D5DEE5"/>
+                      </a:solidFill>
+                      <a:prstDash val="solid"/>
+                      <a:round/>
+                      <a:headEnd type="none" w="med" len="med"/>
+                      <a:tailEnd type="none" w="med" len="med"/>
+                    </a:lnR>
+                    <a:lnT w="12700" cap="flat" cmpd="sng" algn="ctr">
+                      <a:solidFill>
+                        <a:srgbClr val="D5DEE5"/>
+                      </a:solidFill>
+                      <a:prstDash val="solid"/>
+                      <a:round/>
+                      <a:headEnd type="none" w="med" len="med"/>
+                      <a:tailEnd type="none" w="med" len="med"/>
+                    </a:lnT>
+                    <a:lnB w="12700" cap="flat" cmpd="sng" algn="ctr">
+                      <a:solidFill>
+                        <a:srgbClr val="D5DEE5"/>
+                      </a:solidFill>
+                      <a:prstDash val="solid"/>
+                      <a:round/>
+                      <a:headEnd type="none" w="med" len="med"/>
+                      <a:tailEnd type="none" w="med" len="med"/>
+                    </a:lnB>
+                    <a:solidFill>
+                      <a:srgbClr val="FFFFFF"/>
+                    </a:solidFill>
+                  </a:tcPr>
+                </a:tc>
+                <a:tc>
+                  <a:txBody>
+                    <a:bodyPr/>
+                    <a:lstStyle/>
+                    <a:p>
+                      <a:pPr algn="ctr" indent="0" marL="0">
+                        <a:buNone/>
+                      </a:pPr>
+                      <a:r>
+                        <a:rPr lang="en-US" sz="1250" dirty="0">
+                          <a:solidFill>
+                            <a:srgbClr val="D98A2B"/>
+                          </a:solidFill>
+                          <a:latin typeface="Calibri" pitchFamily="34" charset="0"/>
+                          <a:ea typeface="Calibri" pitchFamily="34" charset="-122"/>
+                          <a:cs typeface="Calibri" pitchFamily="34" charset="-120"/>
+                        </a:rPr>
+                        <a:t>All lanes used</a:t>
+                      </a:r>
+                      <a:endParaRPr lang="en-US" sz="1250" dirty="0">
+                        <a:latin typeface="Calibri" charset="0"/>
+                        <a:ea typeface="Calibri" charset="0"/>
+                        <a:cs typeface="Calibri" charset="0"/>
+                      </a:endParaRPr>
+                    </a:p>
+                  </a:txBody>
+                  <a:tcPr marL="63500" marR="63500" marT="25400" marB="25400" anchor="ctr">
+                    <a:lnL w="12700" cap="flat" cmpd="sng" algn="ctr">
+                      <a:solidFill>
+                        <a:srgbClr val="D5DEE5"/>
+                      </a:solidFill>
+                      <a:prstDash val="solid"/>
+                      <a:round/>
+                      <a:headEnd type="none" w="med" len="med"/>
+                      <a:tailEnd type="none" w="med" len="med"/>
+                    </a:lnL>
+                    <a:lnR w="12700" cap="flat" cmpd="sng" algn="ctr">
+                      <a:solidFill>
+                        <a:srgbClr val="D5DEE5"/>
+                      </a:solidFill>
+                      <a:prstDash val="solid"/>
+                      <a:round/>
+                      <a:headEnd type="none" w="med" len="med"/>
+                      <a:tailEnd type="none" w="med" len="med"/>
+                    </a:lnR>
+                    <a:lnT w="12700" cap="flat" cmpd="sng" algn="ctr">
+                      <a:solidFill>
+                        <a:srgbClr val="D5DEE5"/>
+                      </a:solidFill>
+                      <a:prstDash val="solid"/>
+                      <a:round/>
+                      <a:headEnd type="none" w="med" len="med"/>
+                      <a:tailEnd type="none" w="med" len="med"/>
+                    </a:lnT>
+                    <a:lnB w="12700" cap="flat" cmpd="sng" algn="ctr">
+                      <a:solidFill>
+                        <a:srgbClr val="D5DEE5"/>
+                      </a:solidFill>
+                      <a:prstDash val="solid"/>
+                      <a:round/>
+                      <a:headEnd type="none" w="med" len="med"/>
+                      <a:tailEnd type="none" w="med" len="med"/>
+                    </a:lnB>
+                    <a:solidFill>
+                      <a:srgbClr val="FFFFFF"/>
+                    </a:solidFill>
+                  </a:tcPr>
+                </a:tc>
+              </a:tr>
+              <a:tr h="402336">
+                <a:tc>
+                  <a:txBody>
+                    <a:bodyPr/>
+                    <a:lstStyle/>
+                    <a:p>
+                      <a:pPr algn="l" indent="0" marL="0">
+                        <a:buNone/>
+                      </a:pPr>
+                      <a:r>
+                        <a:rPr lang="en-US" sz="1250" dirty="0">
+                          <a:solidFill>
+                            <a:srgbClr val="1E2B37"/>
+                          </a:solidFill>
+                          <a:latin typeface="Calibri" pitchFamily="34" charset="0"/>
+                          <a:ea typeface="Calibri" pitchFamily="34" charset="-122"/>
+                          <a:cs typeface="Calibri" pitchFamily="34" charset="-120"/>
+                        </a:rPr>
+                        <a:t>90</a:t>
+                      </a:r>
+                      <a:endParaRPr lang="en-US" sz="1250" dirty="0">
+                        <a:latin typeface="Calibri" charset="0"/>
+                        <a:ea typeface="Calibri" charset="0"/>
+                        <a:cs typeface="Calibri" charset="0"/>
+                      </a:endParaRPr>
+                    </a:p>
+                  </a:txBody>
+                  <a:tcPr marL="63500" marR="63500" marT="25400" marB="25400" anchor="ctr">
+                    <a:lnL w="12700" cap="flat" cmpd="sng" algn="ctr">
+                      <a:solidFill>
+                        <a:srgbClr val="D5DEE5"/>
+                      </a:solidFill>
+                      <a:prstDash val="solid"/>
+                      <a:round/>
+                      <a:headEnd type="none" w="med" len="med"/>
+                      <a:tailEnd type="none" w="med" len="med"/>
+                    </a:lnL>
+                    <a:lnR w="12700" cap="flat" cmpd="sng" algn="ctr">
+                      <a:solidFill>
+                        <a:srgbClr val="D5DEE5"/>
+                      </a:solidFill>
+                      <a:prstDash val="solid"/>
+                      <a:round/>
+                      <a:headEnd type="none" w="med" len="med"/>
+                      <a:tailEnd type="none" w="med" len="med"/>
+                    </a:lnR>
+                    <a:lnT w="12700" cap="flat" cmpd="sng" algn="ctr">
+                      <a:solidFill>
+                        <a:srgbClr val="D5DEE5"/>
+                      </a:solidFill>
+                      <a:prstDash val="solid"/>
+                      <a:round/>
+                      <a:headEnd type="none" w="med" len="med"/>
+                      <a:tailEnd type="none" w="med" len="med"/>
+                    </a:lnT>
+                    <a:lnB w="12700" cap="flat" cmpd="sng" algn="ctr">
+                      <a:solidFill>
+                        <a:srgbClr val="D5DEE5"/>
+                      </a:solidFill>
+                      <a:prstDash val="solid"/>
+                      <a:round/>
+                      <a:headEnd type="none" w="med" len="med"/>
+                      <a:tailEnd type="none" w="med" len="med"/>
+                    </a:lnB>
+                    <a:solidFill>
+                      <a:srgbClr val="F4F7F9"/>
+                    </a:solidFill>
+                  </a:tcPr>
+                </a:tc>
+                <a:tc>
+                  <a:txBody>
+                    <a:bodyPr/>
+                    <a:lstStyle/>
+                    <a:p>
+                      <a:pPr algn="ctr" indent="0" marL="0">
+                        <a:buNone/>
+                      </a:pPr>
+                      <a:r>
+                        <a:rPr lang="en-US" sz="1250" dirty="0">
+                          <a:solidFill>
+                            <a:srgbClr val="1E2B37"/>
+                          </a:solidFill>
+                          <a:latin typeface="Calibri" pitchFamily="34" charset="0"/>
+                          <a:ea typeface="Calibri" pitchFamily="34" charset="-122"/>
+                          <a:cs typeface="Calibri" pitchFamily="34" charset="-120"/>
+                        </a:rPr>
+                        <a:t>6</a:t>
+                      </a:r>
+                      <a:endParaRPr lang="en-US" sz="1250" dirty="0">
+                        <a:latin typeface="Calibri" charset="0"/>
+                        <a:ea typeface="Calibri" charset="0"/>
+                        <a:cs typeface="Calibri" charset="0"/>
+                      </a:endParaRPr>
+                    </a:p>
+                  </a:txBody>
+                  <a:tcPr marL="63500" marR="63500" marT="25400" marB="25400" anchor="ctr">
+                    <a:lnL w="12700" cap="flat" cmpd="sng" algn="ctr">
+                      <a:solidFill>
+                        <a:srgbClr val="D5DEE5"/>
+                      </a:solidFill>
+                      <a:prstDash val="solid"/>
+                      <a:round/>
+                      <a:headEnd type="none" w="med" len="med"/>
+                      <a:tailEnd type="none" w="med" len="med"/>
+                    </a:lnL>
+                    <a:lnR w="12700" cap="flat" cmpd="sng" algn="ctr">
+                      <a:solidFill>
+                        <a:srgbClr val="D5DEE5"/>
+                      </a:solidFill>
+                      <a:prstDash val="solid"/>
+                      <a:round/>
+                      <a:headEnd type="none" w="med" len="med"/>
+                      <a:tailEnd type="none" w="med" len="med"/>
+                    </a:lnR>
+                    <a:lnT w="12700" cap="flat" cmpd="sng" algn="ctr">
+                      <a:solidFill>
+                        <a:srgbClr val="D5DEE5"/>
+                      </a:solidFill>
+                      <a:prstDash val="solid"/>
+                      <a:round/>
+                      <a:headEnd type="none" w="med" len="med"/>
+                      <a:tailEnd type="none" w="med" len="med"/>
+                    </a:lnT>
+                    <a:lnB w="12700" cap="flat" cmpd="sng" algn="ctr">
+                      <a:solidFill>
+                        <a:srgbClr val="D5DEE5"/>
+                      </a:solidFill>
+                      <a:prstDash val="solid"/>
+                      <a:round/>
+                      <a:headEnd type="none" w="med" len="med"/>
+                      <a:tailEnd type="none" w="med" len="med"/>
+                    </a:lnB>
+                    <a:solidFill>
+                      <a:srgbClr val="F4F7F9"/>
+                    </a:solidFill>
+                  </a:tcPr>
+                </a:tc>
+                <a:tc>
+                  <a:txBody>
+                    <a:bodyPr/>
+                    <a:lstStyle/>
+                    <a:p>
+                      <a:pPr algn="ctr" indent="0" marL="0">
+                        <a:buNone/>
+                      </a:pPr>
+                      <a:r>
+                        <a:rPr lang="en-US" sz="1250" dirty="0">
+                          <a:solidFill>
+                            <a:srgbClr val="D98A2B"/>
+                          </a:solidFill>
+                          <a:latin typeface="Calibri" pitchFamily="34" charset="0"/>
+                          <a:ea typeface="Calibri" pitchFamily="34" charset="-122"/>
+                          <a:cs typeface="Calibri" pitchFamily="34" charset="-120"/>
+                        </a:rPr>
+                        <a:t>All lanes used</a:t>
+                      </a:r>
+                      <a:endParaRPr lang="en-US" sz="1250" dirty="0">
+                        <a:latin typeface="Calibri" charset="0"/>
+                        <a:ea typeface="Calibri" charset="0"/>
+                        <a:cs typeface="Calibri" charset="0"/>
+                      </a:endParaRPr>
+                    </a:p>
+                  </a:txBody>
+                  <a:tcPr marL="63500" marR="63500" marT="25400" marB="25400" anchor="ctr">
+                    <a:lnL w="12700" cap="flat" cmpd="sng" algn="ctr">
+                      <a:solidFill>
+                        <a:srgbClr val="D5DEE5"/>
+                      </a:solidFill>
+                      <a:prstDash val="solid"/>
+                      <a:round/>
+                      <a:headEnd type="none" w="med" len="med"/>
+                      <a:tailEnd type="none" w="med" len="med"/>
+                    </a:lnL>
+                    <a:lnR w="12700" cap="flat" cmpd="sng" algn="ctr">
+                      <a:solidFill>
+                        <a:srgbClr val="D5DEE5"/>
+                      </a:solidFill>
+                      <a:prstDash val="solid"/>
+                      <a:round/>
+                      <a:headEnd type="none" w="med" len="med"/>
+                      <a:tailEnd type="none" w="med" len="med"/>
+                    </a:lnR>
+                    <a:lnT w="12700" cap="flat" cmpd="sng" algn="ctr">
+                      <a:solidFill>
+                        <a:srgbClr val="D5DEE5"/>
+                      </a:solidFill>
+                      <a:prstDash val="solid"/>
+                      <a:round/>
+                      <a:headEnd type="none" w="med" len="med"/>
+                      <a:tailEnd type="none" w="med" len="med"/>
+                    </a:lnT>
+                    <a:lnB w="12700" cap="flat" cmpd="sng" algn="ctr">
+                      <a:solidFill>
+                        <a:srgbClr val="D5DEE5"/>
+                      </a:solidFill>
+                      <a:prstDash val="solid"/>
+                      <a:round/>
+                      <a:headEnd type="none" w="med" len="med"/>
+                      <a:tailEnd type="none" w="med" len="med"/>
+                    </a:lnB>
+                    <a:solidFill>
+                      <a:srgbClr val="F4F7F9"/>
+                    </a:solidFill>
+                  </a:tcPr>
+                </a:tc>
+              </a:tr>
+              <a:tr h="402336">
+                <a:tc>
+                  <a:txBody>
+                    <a:bodyPr/>
+                    <a:lstStyle/>
+                    <a:p>
+                      <a:pPr algn="l" indent="0" marL="0">
+                        <a:buNone/>
+                      </a:pPr>
+                      <a:r>
+                        <a:rPr lang="en-US" sz="1250" dirty="0">
+                          <a:solidFill>
+                            <a:srgbClr val="1E2B37"/>
+                          </a:solidFill>
+                          <a:latin typeface="Calibri" pitchFamily="34" charset="0"/>
+                          <a:ea typeface="Calibri" pitchFamily="34" charset="-122"/>
+                          <a:cs typeface="Calibri" pitchFamily="34" charset="-120"/>
+                        </a:rPr>
+                        <a:t>100</a:t>
+                      </a:r>
+                      <a:endParaRPr lang="en-US" sz="1250" dirty="0">
+                        <a:latin typeface="Calibri" charset="0"/>
+                        <a:ea typeface="Calibri" charset="0"/>
+                        <a:cs typeface="Calibri" charset="0"/>
+                      </a:endParaRPr>
+                    </a:p>
+                  </a:txBody>
+                  <a:tcPr marL="63500" marR="63500" marT="25400" marB="25400" anchor="ctr">
+                    <a:lnL w="12700" cap="flat" cmpd="sng" algn="ctr">
+                      <a:solidFill>
+                        <a:srgbClr val="D5DEE5"/>
+                      </a:solidFill>
+                      <a:prstDash val="solid"/>
+                      <a:round/>
+                      <a:headEnd type="none" w="med" len="med"/>
+                      <a:tailEnd type="none" w="med" len="med"/>
+                    </a:lnL>
+                    <a:lnR w="12700" cap="flat" cmpd="sng" algn="ctr">
+                      <a:solidFill>
+                        <a:srgbClr val="D5DEE5"/>
+                      </a:solidFill>
+                      <a:prstDash val="solid"/>
+                      <a:round/>
+                      <a:headEnd type="none" w="med" len="med"/>
+                      <a:tailEnd type="none" w="med" len="med"/>
+                    </a:lnR>
+                    <a:lnT w="12700" cap="flat" cmpd="sng" algn="ctr">
+                      <a:solidFill>
+                        <a:srgbClr val="D5DEE5"/>
+                      </a:solidFill>
+                      <a:prstDash val="solid"/>
+                      <a:round/>
+                      <a:headEnd type="none" w="med" len="med"/>
+                      <a:tailEnd type="none" w="med" len="med"/>
+                    </a:lnT>
+                    <a:lnB w="12700" cap="flat" cmpd="sng" algn="ctr">
+                      <a:solidFill>
+                        <a:srgbClr val="D5DEE5"/>
+                      </a:solidFill>
+                      <a:prstDash val="solid"/>
+                      <a:round/>
+                      <a:headEnd type="none" w="med" len="med"/>
+                      <a:tailEnd type="none" w="med" len="med"/>
+                    </a:lnB>
+                    <a:solidFill>
+                      <a:srgbClr val="FFFFFF"/>
+                    </a:solidFill>
+                  </a:tcPr>
+                </a:tc>
+                <a:tc>
+                  <a:txBody>
+                    <a:bodyPr/>
+                    <a:lstStyle/>
+                    <a:p>
+                      <a:pPr algn="ctr" indent="0" marL="0">
+                        <a:buNone/>
+                      </a:pPr>
+                      <a:r>
+                        <a:rPr lang="en-US" sz="1250" dirty="0">
+                          <a:solidFill>
+                            <a:srgbClr val="1E2B37"/>
+                          </a:solidFill>
+                          <a:latin typeface="Calibri" pitchFamily="34" charset="0"/>
+                          <a:ea typeface="Calibri" pitchFamily="34" charset="-122"/>
+                          <a:cs typeface="Calibri" pitchFamily="34" charset="-120"/>
+                        </a:rPr>
+                        <a:t>5</a:t>
+                      </a:r>
+                      <a:endParaRPr lang="en-US" sz="1250" dirty="0">
+                        <a:latin typeface="Calibri" charset="0"/>
+                        <a:ea typeface="Calibri" charset="0"/>
+                        <a:cs typeface="Calibri" charset="0"/>
+                      </a:endParaRPr>
+                    </a:p>
+                  </a:txBody>
+                  <a:tcPr marL="63500" marR="63500" marT="25400" marB="25400" anchor="ctr">
+                    <a:lnL w="12700" cap="flat" cmpd="sng" algn="ctr">
+                      <a:solidFill>
+                        <a:srgbClr val="D5DEE5"/>
+                      </a:solidFill>
+                      <a:prstDash val="solid"/>
+                      <a:round/>
+                      <a:headEnd type="none" w="med" len="med"/>
+                      <a:tailEnd type="none" w="med" len="med"/>
+                    </a:lnL>
+                    <a:lnR w="12700" cap="flat" cmpd="sng" algn="ctr">
+                      <a:solidFill>
+                        <a:srgbClr val="D5DEE5"/>
+                      </a:solidFill>
+                      <a:prstDash val="solid"/>
+                      <a:round/>
+                      <a:headEnd type="none" w="med" len="med"/>
+                      <a:tailEnd type="none" w="med" len="med"/>
+                    </a:lnR>
+                    <a:lnT w="12700" cap="flat" cmpd="sng" algn="ctr">
+                      <a:solidFill>
+                        <a:srgbClr val="D5DEE5"/>
+                      </a:solidFill>
+                      <a:prstDash val="solid"/>
+                      <a:round/>
+                      <a:headEnd type="none" w="med" len="med"/>
+                      <a:tailEnd type="none" w="med" len="med"/>
+                    </a:lnT>
+                    <a:lnB w="12700" cap="flat" cmpd="sng" algn="ctr">
+                      <a:solidFill>
+                        <a:srgbClr val="D5DEE5"/>
+                      </a:solidFill>
+                      <a:prstDash val="solid"/>
+                      <a:round/>
+                      <a:headEnd type="none" w="med" len="med"/>
+                      <a:tailEnd type="none" w="med" len="med"/>
+                    </a:lnB>
+                    <a:solidFill>
+                      <a:srgbClr val="FFFFFF"/>
+                    </a:solidFill>
+                  </a:tcPr>
+                </a:tc>
+                <a:tc>
+                  <a:txBody>
+                    <a:bodyPr/>
+                    <a:lstStyle/>
+                    <a:p>
+                      <a:pPr algn="ctr" indent="0" marL="0">
+                        <a:buNone/>
+                      </a:pPr>
+                      <a:r>
+                        <a:rPr lang="en-US" sz="1250" dirty="0">
+                          <a:solidFill>
+                            <a:srgbClr val="1E2B37"/>
+                          </a:solidFill>
+                          <a:latin typeface="Calibri" pitchFamily="34" charset="0"/>
+                          <a:ea typeface="Calibri" pitchFamily="34" charset="-122"/>
+                          <a:cs typeface="Calibri" pitchFamily="34" charset="-120"/>
+                        </a:rPr>
+                        <a:t>Fits — 1 spare</a:t>
+                      </a:r>
+                      <a:endParaRPr lang="en-US" sz="1250" dirty="0">
+                        <a:latin typeface="Calibri" charset="0"/>
+                        <a:ea typeface="Calibri" charset="0"/>
+                        <a:cs typeface="Calibri" charset="0"/>
+                      </a:endParaRPr>
+                    </a:p>
+                  </a:txBody>
+                  <a:tcPr marL="63500" marR="63500" marT="25400" marB="25400" anchor="ctr">
+                    <a:lnL w="12700" cap="flat" cmpd="sng" algn="ctr">
+                      <a:solidFill>
+                        <a:srgbClr val="D5DEE5"/>
+                      </a:solidFill>
+                      <a:prstDash val="solid"/>
+                      <a:round/>
+                      <a:headEnd type="none" w="med" len="med"/>
+                      <a:tailEnd type="none" w="med" len="med"/>
+                    </a:lnL>
+                    <a:lnR w="12700" cap="flat" cmpd="sng" algn="ctr">
+                      <a:solidFill>
+                        <a:srgbClr val="D5DEE5"/>
+                      </a:solidFill>
+                      <a:prstDash val="solid"/>
+                      <a:round/>
+                      <a:headEnd type="none" w="med" len="med"/>
+                      <a:tailEnd type="none" w="med" len="med"/>
+                    </a:lnR>
+                    <a:lnT w="12700" cap="flat" cmpd="sng" algn="ctr">
+                      <a:solidFill>
+                        <a:srgbClr val="D5DEE5"/>
+                      </a:solidFill>
+                      <a:prstDash val="solid"/>
+                      <a:round/>
+                      <a:headEnd type="none" w="med" len="med"/>
+                      <a:tailEnd type="none" w="med" len="med"/>
+                    </a:lnT>
+                    <a:lnB w="12700" cap="flat" cmpd="sng" algn="ctr">
+                      <a:solidFill>
+                        <a:srgbClr val="D5DEE5"/>
+                      </a:solidFill>
+                      <a:prstDash val="solid"/>
+                      <a:round/>
+                      <a:headEnd type="none" w="med" len="med"/>
+                      <a:tailEnd type="none" w="med" len="med"/>
+                    </a:lnB>
+                    <a:solidFill>
+                      <a:srgbClr val="FFFFFF"/>
+                    </a:solidFill>
+                  </a:tcPr>
+                </a:tc>
+              </a:tr>
+              <a:tr h="402336">
+                <a:tc>
+                  <a:txBody>
+                    <a:bodyPr/>
+                    <a:lstStyle/>
+                    <a:p>
+                      <a:pPr algn="l" indent="0" marL="0">
+                        <a:buNone/>
+                      </a:pPr>
+                      <a:r>
+                        <a:rPr lang="en-US" sz="1250" b="1" dirty="0">
+                          <a:solidFill>
+                            <a:srgbClr val="1E2B37"/>
+                          </a:solidFill>
+                          <a:latin typeface="Calibri" pitchFamily="34" charset="0"/>
+                          <a:ea typeface="Calibri" pitchFamily="34" charset="-122"/>
+                          <a:cs typeface="Calibri" pitchFamily="34" charset="-120"/>
+                        </a:rPr>
+                        <a:t>120  (default)</a:t>
+                      </a:r>
+                      <a:endParaRPr lang="en-US" sz="1250" dirty="0">
+                        <a:latin typeface="Calibri" charset="0"/>
+                        <a:ea typeface="Calibri" charset="0"/>
+                        <a:cs typeface="Calibri" charset="0"/>
+                      </a:endParaRPr>
+                    </a:p>
+                  </a:txBody>
+                  <a:tcPr marL="63500" marR="63500" marT="25400" marB="25400" anchor="ctr">
+                    <a:lnL w="12700" cap="flat" cmpd="sng" algn="ctr">
+                      <a:solidFill>
+                        <a:srgbClr val="D5DEE5"/>
+                      </a:solidFill>
+                      <a:prstDash val="solid"/>
+                      <a:round/>
+                      <a:headEnd type="none" w="med" len="med"/>
+                      <a:tailEnd type="none" w="med" len="med"/>
+                    </a:lnL>
+                    <a:lnR w="12700" cap="flat" cmpd="sng" algn="ctr">
+                      <a:solidFill>
+                        <a:srgbClr val="D5DEE5"/>
+                      </a:solidFill>
+                      <a:prstDash val="solid"/>
+                      <a:round/>
+                      <a:headEnd type="none" w="med" len="med"/>
+                      <a:tailEnd type="none" w="med" len="med"/>
+                    </a:lnR>
+                    <a:lnT w="12700" cap="flat" cmpd="sng" algn="ctr">
+                      <a:solidFill>
+                        <a:srgbClr val="D5DEE5"/>
+                      </a:solidFill>
+                      <a:prstDash val="solid"/>
+                      <a:round/>
+                      <a:headEnd type="none" w="med" len="med"/>
+                      <a:tailEnd type="none" w="med" len="med"/>
+                    </a:lnT>
+                    <a:lnB w="12700" cap="flat" cmpd="sng" algn="ctr">
+                      <a:solidFill>
+                        <a:srgbClr val="D5DEE5"/>
+                      </a:solidFill>
+                      <a:prstDash val="solid"/>
+                      <a:round/>
+                      <a:headEnd type="none" w="med" len="med"/>
+                      <a:tailEnd type="none" w="med" len="med"/>
+                    </a:lnB>
+                    <a:solidFill>
+                      <a:srgbClr val="FFF2CC"/>
+                    </a:solidFill>
+                  </a:tcPr>
+                </a:tc>
+                <a:tc>
+                  <a:txBody>
+                    <a:bodyPr/>
+                    <a:lstStyle/>
+                    <a:p>
+                      <a:pPr algn="ctr" indent="0" marL="0">
+                        <a:buNone/>
+                      </a:pPr>
+                      <a:r>
+                        <a:rPr lang="en-US" sz="1250" b="1" dirty="0">
+                          <a:solidFill>
+                            <a:srgbClr val="1E2B37"/>
+                          </a:solidFill>
+                          <a:latin typeface="Calibri" pitchFamily="34" charset="0"/>
+                          <a:ea typeface="Calibri" pitchFamily="34" charset="-122"/>
+                          <a:cs typeface="Calibri" pitchFamily="34" charset="-120"/>
+                        </a:rPr>
+                        <a:t>4</a:t>
+                      </a:r>
+                      <a:endParaRPr lang="en-US" sz="1250" dirty="0">
+                        <a:latin typeface="Calibri" charset="0"/>
+                        <a:ea typeface="Calibri" charset="0"/>
+                        <a:cs typeface="Calibri" charset="0"/>
+                      </a:endParaRPr>
+                    </a:p>
+                  </a:txBody>
+                  <a:tcPr marL="63500" marR="63500" marT="25400" marB="25400" anchor="ctr">
+                    <a:lnL w="12700" cap="flat" cmpd="sng" algn="ctr">
+                      <a:solidFill>
+                        <a:srgbClr val="D5DEE5"/>
+                      </a:solidFill>
+                      <a:prstDash val="solid"/>
+                      <a:round/>
+                      <a:headEnd type="none" w="med" len="med"/>
+                      <a:tailEnd type="none" w="med" len="med"/>
+                    </a:lnL>
+                    <a:lnR w="12700" cap="flat" cmpd="sng" algn="ctr">
+                      <a:solidFill>
+                        <a:srgbClr val="D5DEE5"/>
+                      </a:solidFill>
+                      <a:prstDash val="solid"/>
+                      <a:round/>
+                      <a:headEnd type="none" w="med" len="med"/>
+                      <a:tailEnd type="none" w="med" len="med"/>
+                    </a:lnR>
+                    <a:lnT w="12700" cap="flat" cmpd="sng" algn="ctr">
+                      <a:solidFill>
+                        <a:srgbClr val="D5DEE5"/>
+                      </a:solidFill>
+                      <a:prstDash val="solid"/>
+                      <a:round/>
+                      <a:headEnd type="none" w="med" len="med"/>
+                      <a:tailEnd type="none" w="med" len="med"/>
+                    </a:lnT>
+                    <a:lnB w="12700" cap="flat" cmpd="sng" algn="ctr">
+                      <a:solidFill>
+                        <a:srgbClr val="D5DEE5"/>
+                      </a:solidFill>
+                      <a:prstDash val="solid"/>
+                      <a:round/>
+                      <a:headEnd type="none" w="med" len="med"/>
+                      <a:tailEnd type="none" w="med" len="med"/>
+                    </a:lnB>
+                    <a:solidFill>
+                      <a:srgbClr val="FFF2CC"/>
+                    </a:solidFill>
+                  </a:tcPr>
+                </a:tc>
+                <a:tc>
+                  <a:txBody>
+                    <a:bodyPr/>
+                    <a:lstStyle/>
+                    <a:p>
+                      <a:pPr algn="ctr" indent="0" marL="0">
+                        <a:buNone/>
+                      </a:pPr>
+                      <a:r>
+                        <a:rPr lang="en-US" sz="1250" b="1" dirty="0">
+                          <a:solidFill>
+                            <a:srgbClr val="2E8B57"/>
+                          </a:solidFill>
+                          <a:latin typeface="Calibri" pitchFamily="34" charset="0"/>
+                          <a:ea typeface="Calibri" pitchFamily="34" charset="-122"/>
+                          <a:cs typeface="Calibri" pitchFamily="34" charset="-120"/>
+                        </a:rPr>
+                        <a:t>Comfortable — 2 spare</a:t>
+                      </a:r>
+                      <a:endParaRPr lang="en-US" sz="1250" dirty="0">
+                        <a:latin typeface="Calibri" charset="0"/>
+                        <a:ea typeface="Calibri" charset="0"/>
+                        <a:cs typeface="Calibri" charset="0"/>
+                      </a:endParaRPr>
+                    </a:p>
+                  </a:txBody>
+                  <a:tcPr marL="63500" marR="63500" marT="25400" marB="25400" anchor="ctr">
+                    <a:lnL w="12700" cap="flat" cmpd="sng" algn="ctr">
+                      <a:solidFill>
+                        <a:srgbClr val="D5DEE5"/>
+                      </a:solidFill>
+                      <a:prstDash val="solid"/>
+                      <a:round/>
+                      <a:headEnd type="none" w="med" len="med"/>
+                      <a:tailEnd type="none" w="med" len="med"/>
+                    </a:lnL>
+                    <a:lnR w="12700" cap="flat" cmpd="sng" algn="ctr">
+                      <a:solidFill>
+                        <a:srgbClr val="D5DEE5"/>
+                      </a:solidFill>
+                      <a:prstDash val="solid"/>
+                      <a:round/>
+                      <a:headEnd type="none" w="med" len="med"/>
+                      <a:tailEnd type="none" w="med" len="med"/>
+                    </a:lnR>
+                    <a:lnT w="12700" cap="flat" cmpd="sng" algn="ctr">
+                      <a:solidFill>
+                        <a:srgbClr val="D5DEE5"/>
+                      </a:solidFill>
+                      <a:prstDash val="solid"/>
+                      <a:round/>
+                      <a:headEnd type="none" w="med" len="med"/>
+                      <a:tailEnd type="none" w="med" len="med"/>
+                    </a:lnT>
+                    <a:lnB w="12700" cap="flat" cmpd="sng" algn="ctr">
+                      <a:solidFill>
+                        <a:srgbClr val="D5DEE5"/>
+                      </a:solidFill>
+                      <a:prstDash val="solid"/>
+                      <a:round/>
+                      <a:headEnd type="none" w="med" len="med"/>
+                      <a:tailEnd type="none" w="med" len="med"/>
+                    </a:lnB>
+                    <a:solidFill>
+                      <a:srgbClr val="FFF2CC"/>
+                    </a:solidFill>
+                  </a:tcPr>
+                </a:tc>
+              </a:tr>
+              <a:tr h="402336">
+                <a:tc>
+                  <a:txBody>
+                    <a:bodyPr/>
+                    <a:lstStyle/>
+                    <a:p>
+                      <a:pPr algn="l" indent="0" marL="0">
+                        <a:buNone/>
+                      </a:pPr>
+                      <a:r>
+                        <a:rPr lang="en-US" sz="1250" dirty="0">
+                          <a:solidFill>
+                            <a:srgbClr val="1E2B37"/>
+                          </a:solidFill>
+                          <a:latin typeface="Calibri" pitchFamily="34" charset="0"/>
+                          <a:ea typeface="Calibri" pitchFamily="34" charset="-122"/>
+                          <a:cs typeface="Calibri" pitchFamily="34" charset="-120"/>
+                        </a:rPr>
+                        <a:t>150</a:t>
+                      </a:r>
+                      <a:endParaRPr lang="en-US" sz="1250" dirty="0">
+                        <a:latin typeface="Calibri" charset="0"/>
+                        <a:ea typeface="Calibri" charset="0"/>
+                        <a:cs typeface="Calibri" charset="0"/>
+                      </a:endParaRPr>
+                    </a:p>
+                  </a:txBody>
+                  <a:tcPr marL="63500" marR="63500" marT="25400" marB="25400" anchor="ctr">
+                    <a:lnL w="12700" cap="flat" cmpd="sng" algn="ctr">
+                      <a:solidFill>
+                        <a:srgbClr val="D5DEE5"/>
+                      </a:solidFill>
+                      <a:prstDash val="solid"/>
+                      <a:round/>
+                      <a:headEnd type="none" w="med" len="med"/>
+                      <a:tailEnd type="none" w="med" len="med"/>
+                    </a:lnL>
+                    <a:lnR w="12700" cap="flat" cmpd="sng" algn="ctr">
+                      <a:solidFill>
+                        <a:srgbClr val="D5DEE5"/>
+                      </a:solidFill>
+                      <a:prstDash val="solid"/>
+                      <a:round/>
+                      <a:headEnd type="none" w="med" len="med"/>
+                      <a:tailEnd type="none" w="med" len="med"/>
+                    </a:lnR>
+                    <a:lnT w="12700" cap="flat" cmpd="sng" algn="ctr">
+                      <a:solidFill>
+                        <a:srgbClr val="D5DEE5"/>
+                      </a:solidFill>
+                      <a:prstDash val="solid"/>
+                      <a:round/>
+                      <a:headEnd type="none" w="med" len="med"/>
+                      <a:tailEnd type="none" w="med" len="med"/>
+                    </a:lnT>
+                    <a:lnB w="12700" cap="flat" cmpd="sng" algn="ctr">
+                      <a:solidFill>
+                        <a:srgbClr val="D5DEE5"/>
+                      </a:solidFill>
+                      <a:prstDash val="solid"/>
+                      <a:round/>
+                      <a:headEnd type="none" w="med" len="med"/>
+                      <a:tailEnd type="none" w="med" len="med"/>
+                    </a:lnB>
+                    <a:solidFill>
+                      <a:srgbClr val="FFFFFF"/>
+                    </a:solidFill>
+                  </a:tcPr>
+                </a:tc>
+                <a:tc>
+                  <a:txBody>
+                    <a:bodyPr/>
+                    <a:lstStyle/>
+                    <a:p>
+                      <a:pPr algn="ctr" indent="0" marL="0">
+                        <a:buNone/>
+                      </a:pPr>
+                      <a:r>
+                        <a:rPr lang="en-US" sz="1250" dirty="0">
+                          <a:solidFill>
+                            <a:srgbClr val="1E2B37"/>
+                          </a:solidFill>
+                          <a:latin typeface="Calibri" pitchFamily="34" charset="0"/>
+                          <a:ea typeface="Calibri" pitchFamily="34" charset="-122"/>
+                          <a:cs typeface="Calibri" pitchFamily="34" charset="-120"/>
+                        </a:rPr>
+                        <a:t>4</a:t>
+                      </a:r>
+                      <a:endParaRPr lang="en-US" sz="1250" dirty="0">
+                        <a:latin typeface="Calibri" charset="0"/>
+                        <a:ea typeface="Calibri" charset="0"/>
+                        <a:cs typeface="Calibri" charset="0"/>
+                      </a:endParaRPr>
+                    </a:p>
+                  </a:txBody>
+                  <a:tcPr marL="63500" marR="63500" marT="25400" marB="25400" anchor="ctr">
+                    <a:lnL w="12700" cap="flat" cmpd="sng" algn="ctr">
+                      <a:solidFill>
+                        <a:srgbClr val="D5DEE5"/>
+                      </a:solidFill>
+                      <a:prstDash val="solid"/>
+                      <a:round/>
+                      <a:headEnd type="none" w="med" len="med"/>
+                      <a:tailEnd type="none" w="med" len="med"/>
+                    </a:lnL>
+                    <a:lnR w="12700" cap="flat" cmpd="sng" algn="ctr">
+                      <a:solidFill>
+                        <a:srgbClr val="D5DEE5"/>
+                      </a:solidFill>
+                      <a:prstDash val="solid"/>
+                      <a:round/>
+                      <a:headEnd type="none" w="med" len="med"/>
+                      <a:tailEnd type="none" w="med" len="med"/>
+                    </a:lnR>
+                    <a:lnT w="12700" cap="flat" cmpd="sng" algn="ctr">
+                      <a:solidFill>
+                        <a:srgbClr val="D5DEE5"/>
+                      </a:solidFill>
+                      <a:prstDash val="solid"/>
+                      <a:round/>
+                      <a:headEnd type="none" w="med" len="med"/>
+                      <a:tailEnd type="none" w="med" len="med"/>
+                    </a:lnT>
+                    <a:lnB w="12700" cap="flat" cmpd="sng" algn="ctr">
+                      <a:solidFill>
+                        <a:srgbClr val="D5DEE5"/>
+                      </a:solidFill>
+                      <a:prstDash val="solid"/>
+                      <a:round/>
+                      <a:headEnd type="none" w="med" len="med"/>
+                      <a:tailEnd type="none" w="med" len="med"/>
+                    </a:lnB>
+                    <a:solidFill>
+                      <a:srgbClr val="FFFFFF"/>
+                    </a:solidFill>
+                  </a:tcPr>
+                </a:tc>
+                <a:tc>
+                  <a:txBody>
+                    <a:bodyPr/>
+                    <a:lstStyle/>
+                    <a:p>
+                      <a:pPr algn="ctr" indent="0" marL="0">
+                        <a:buNone/>
+                      </a:pPr>
+                      <a:r>
+                        <a:rPr lang="en-US" sz="1250" dirty="0">
+                          <a:solidFill>
+                            <a:srgbClr val="2E8B57"/>
+                          </a:solidFill>
+                          <a:latin typeface="Calibri" pitchFamily="34" charset="0"/>
+                          <a:ea typeface="Calibri" pitchFamily="34" charset="-122"/>
+                          <a:cs typeface="Calibri" pitchFamily="34" charset="-120"/>
+                        </a:rPr>
+                        <a:t>Comfortable</a:t>
+                      </a:r>
+                      <a:endParaRPr lang="en-US" sz="1250" dirty="0">
+                        <a:latin typeface="Calibri" charset="0"/>
+                        <a:ea typeface="Calibri" charset="0"/>
+                        <a:cs typeface="Calibri" charset="0"/>
+                      </a:endParaRPr>
+                    </a:p>
+                  </a:txBody>
+                  <a:tcPr marL="63500" marR="63500" marT="25400" marB="25400" anchor="ctr">
+                    <a:lnL w="12700" cap="flat" cmpd="sng" algn="ctr">
+                      <a:solidFill>
+                        <a:srgbClr val="D5DEE5"/>
+                      </a:solidFill>
+                      <a:prstDash val="solid"/>
+                      <a:round/>
+                      <a:headEnd type="none" w="med" len="med"/>
+                      <a:tailEnd type="none" w="med" len="med"/>
+                    </a:lnL>
+                    <a:lnR w="12700" cap="flat" cmpd="sng" algn="ctr">
+                      <a:solidFill>
+                        <a:srgbClr val="D5DEE5"/>
+                      </a:solidFill>
+                      <a:prstDash val="solid"/>
+                      <a:round/>
+                      <a:headEnd type="none" w="med" len="med"/>
+                      <a:tailEnd type="none" w="med" len="med"/>
+                    </a:lnR>
+                    <a:lnT w="12700" cap="flat" cmpd="sng" algn="ctr">
+                      <a:solidFill>
+                        <a:srgbClr val="D5DEE5"/>
+                      </a:solidFill>
+                      <a:prstDash val="solid"/>
+                      <a:round/>
+                      <a:headEnd type="none" w="med" len="med"/>
+                      <a:tailEnd type="none" w="med" len="med"/>
+                    </a:lnT>
+                    <a:lnB w="12700" cap="flat" cmpd="sng" algn="ctr">
+                      <a:solidFill>
+                        <a:srgbClr val="D5DEE5"/>
+                      </a:solidFill>
+                      <a:prstDash val="solid"/>
+                      <a:round/>
+                      <a:headEnd type="none" w="med" len="med"/>
+                      <a:tailEnd type="none" w="med" len="med"/>
+                    </a:lnB>
+                    <a:solidFill>
+                      <a:srgbClr val="FFFFFF"/>
+                    </a:solidFill>
+                  </a:tcPr>
+                </a:tc>
+              </a:tr>
+              <a:tr h="402336">
+                <a:tc>
+                  <a:txBody>
+                    <a:bodyPr/>
+                    <a:lstStyle/>
+                    <a:p>
+                      <a:pPr algn="l" indent="0" marL="0">
+                        <a:buNone/>
+                      </a:pPr>
+                      <a:r>
+                        <a:rPr lang="en-US" sz="1250" dirty="0">
+                          <a:solidFill>
+                            <a:srgbClr val="1E2B37"/>
+                          </a:solidFill>
+                          <a:latin typeface="Calibri" pitchFamily="34" charset="0"/>
+                          <a:ea typeface="Calibri" pitchFamily="34" charset="-122"/>
+                          <a:cs typeface="Calibri" pitchFamily="34" charset="-120"/>
+                        </a:rPr>
+                        <a:t>180</a:t>
+                      </a:r>
+                      <a:endParaRPr lang="en-US" sz="1250" dirty="0">
+                        <a:latin typeface="Calibri" charset="0"/>
+                        <a:ea typeface="Calibri" charset="0"/>
+                        <a:cs typeface="Calibri" charset="0"/>
+                      </a:endParaRPr>
+                    </a:p>
+                  </a:txBody>
+                  <a:tcPr marL="63500" marR="63500" marT="25400" marB="25400" anchor="ctr">
+                    <a:lnL w="12700" cap="flat" cmpd="sng" algn="ctr">
+                      <a:solidFill>
+                        <a:srgbClr val="D5DEE5"/>
+                      </a:solidFill>
+                      <a:prstDash val="solid"/>
+                      <a:round/>
+                      <a:headEnd type="none" w="med" len="med"/>
+                      <a:tailEnd type="none" w="med" len="med"/>
+                    </a:lnL>
+                    <a:lnR w="12700" cap="flat" cmpd="sng" algn="ctr">
+                      <a:solidFill>
+                        <a:srgbClr val="D5DEE5"/>
+                      </a:solidFill>
+                      <a:prstDash val="solid"/>
+                      <a:round/>
+                      <a:headEnd type="none" w="med" len="med"/>
+                      <a:tailEnd type="none" w="med" len="med"/>
+                    </a:lnR>
+                    <a:lnT w="12700" cap="flat" cmpd="sng" algn="ctr">
+                      <a:solidFill>
+                        <a:srgbClr val="D5DEE5"/>
+                      </a:solidFill>
+                      <a:prstDash val="solid"/>
+                      <a:round/>
+                      <a:headEnd type="none" w="med" len="med"/>
+                      <a:tailEnd type="none" w="med" len="med"/>
+                    </a:lnT>
+                    <a:lnB w="12700" cap="flat" cmpd="sng" algn="ctr">
+                      <a:solidFill>
+                        <a:srgbClr val="D5DEE5"/>
+                      </a:solidFill>
+                      <a:prstDash val="solid"/>
+                      <a:round/>
+                      <a:headEnd type="none" w="med" len="med"/>
+                      <a:tailEnd type="none" w="med" len="med"/>
+                    </a:lnB>
+                    <a:solidFill>
+                      <a:srgbClr val="F4F7F9"/>
+                    </a:solidFill>
+                  </a:tcPr>
+                </a:tc>
+                <a:tc>
+                  <a:txBody>
+                    <a:bodyPr/>
+                    <a:lstStyle/>
+                    <a:p>
+                      <a:pPr algn="ctr" indent="0" marL="0">
+                        <a:buNone/>
+                      </a:pPr>
+                      <a:r>
+                        <a:rPr lang="en-US" sz="1250" dirty="0">
+                          <a:solidFill>
+                            <a:srgbClr val="1E2B37"/>
+                          </a:solidFill>
+                          <a:latin typeface="Calibri" pitchFamily="34" charset="0"/>
+                          <a:ea typeface="Calibri" pitchFamily="34" charset="-122"/>
+                          <a:cs typeface="Calibri" pitchFamily="34" charset="-120"/>
+                        </a:rPr>
+                        <a:t>3</a:t>
+                      </a:r>
+                      <a:endParaRPr lang="en-US" sz="1250" dirty="0">
+                        <a:latin typeface="Calibri" charset="0"/>
+                        <a:ea typeface="Calibri" charset="0"/>
+                        <a:cs typeface="Calibri" charset="0"/>
+                      </a:endParaRPr>
+                    </a:p>
+                  </a:txBody>
+                  <a:tcPr marL="63500" marR="63500" marT="25400" marB="25400" anchor="ctr">
+                    <a:lnL w="12700" cap="flat" cmpd="sng" algn="ctr">
+                      <a:solidFill>
+                        <a:srgbClr val="D5DEE5"/>
+                      </a:solidFill>
+                      <a:prstDash val="solid"/>
+                      <a:round/>
+                      <a:headEnd type="none" w="med" len="med"/>
+                      <a:tailEnd type="none" w="med" len="med"/>
+                    </a:lnL>
+                    <a:lnR w="12700" cap="flat" cmpd="sng" algn="ctr">
+                      <a:solidFill>
+                        <a:srgbClr val="D5DEE5"/>
+                      </a:solidFill>
+                      <a:prstDash val="solid"/>
+                      <a:round/>
+                      <a:headEnd type="none" w="med" len="med"/>
+                      <a:tailEnd type="none" w="med" len="med"/>
+                    </a:lnR>
+                    <a:lnT w="12700" cap="flat" cmpd="sng" algn="ctr">
+                      <a:solidFill>
+                        <a:srgbClr val="D5DEE5"/>
+                      </a:solidFill>
+                      <a:prstDash val="solid"/>
+                      <a:round/>
+                      <a:headEnd type="none" w="med" len="med"/>
+                      <a:tailEnd type="none" w="med" len="med"/>
+                    </a:lnT>
+                    <a:lnB w="12700" cap="flat" cmpd="sng" algn="ctr">
+                      <a:solidFill>
+                        <a:srgbClr val="D5DEE5"/>
+                      </a:solidFill>
+                      <a:prstDash val="solid"/>
+                      <a:round/>
+                      <a:headEnd type="none" w="med" len="med"/>
+                      <a:tailEnd type="none" w="med" len="med"/>
+                    </a:lnB>
+                    <a:solidFill>
+                      <a:srgbClr val="F4F7F9"/>
+                    </a:solidFill>
+                  </a:tcPr>
+                </a:tc>
+                <a:tc>
+                  <a:txBody>
+                    <a:bodyPr/>
+                    <a:lstStyle/>
+                    <a:p>
+                      <a:pPr algn="ctr" indent="0" marL="0">
+                        <a:buNone/>
+                      </a:pPr>
+                      <a:r>
+                        <a:rPr lang="en-US" sz="1250" dirty="0">
+                          <a:solidFill>
+                            <a:srgbClr val="2E8B57"/>
+                          </a:solidFill>
+                          <a:latin typeface="Calibri" pitchFamily="34" charset="0"/>
+                          <a:ea typeface="Calibri" pitchFamily="34" charset="-122"/>
+                          <a:cs typeface="Calibri" pitchFamily="34" charset="-120"/>
+                        </a:rPr>
+                        <a:t>Lots of spare</a:t>
+                      </a:r>
+                      <a:endParaRPr lang="en-US" sz="1250" dirty="0">
+                        <a:latin typeface="Calibri" charset="0"/>
+                        <a:ea typeface="Calibri" charset="0"/>
+                        <a:cs typeface="Calibri" charset="0"/>
+                      </a:endParaRPr>
+                    </a:p>
+                  </a:txBody>
+                  <a:tcPr marL="63500" marR="63500" marT="25400" marB="25400" anchor="ctr">
+                    <a:lnL w="12700" cap="flat" cmpd="sng" algn="ctr">
+                      <a:solidFill>
+                        <a:srgbClr val="D5DEE5"/>
+                      </a:solidFill>
+                      <a:prstDash val="solid"/>
+                      <a:round/>
+                      <a:headEnd type="none" w="med" len="med"/>
+                      <a:tailEnd type="none" w="med" len="med"/>
+                    </a:lnL>
+                    <a:lnR w="12700" cap="flat" cmpd="sng" algn="ctr">
+                      <a:solidFill>
+                        <a:srgbClr val="D5DEE5"/>
+                      </a:solidFill>
+                      <a:prstDash val="solid"/>
+                      <a:round/>
+                      <a:headEnd type="none" w="med" len="med"/>
+                      <a:tailEnd type="none" w="med" len="med"/>
+                    </a:lnR>
+                    <a:lnT w="12700" cap="flat" cmpd="sng" algn="ctr">
+                      <a:solidFill>
+                        <a:srgbClr val="D5DEE5"/>
+                      </a:solidFill>
+                      <a:prstDash val="solid"/>
+                      <a:round/>
+                      <a:headEnd type="none" w="med" len="med"/>
+                      <a:tailEnd type="none" w="med" len="med"/>
+                    </a:lnT>
+                    <a:lnB w="12700" cap="flat" cmpd="sng" algn="ctr">
+                      <a:solidFill>
+                        <a:srgbClr val="D5DEE5"/>
+                      </a:solidFill>
+                      <a:prstDash val="solid"/>
+                      <a:round/>
+                      <a:headEnd type="none" w="med" len="med"/>
+                      <a:tailEnd type="none" w="med" len="med"/>
+                    </a:lnB>
+                    <a:solidFill>
+                      <a:srgbClr val="F4F7F9"/>
+                    </a:solidFill>
+                  </a:tcPr>
+                </a:tc>
+              </a:tr>
+            </a:tbl>
+          </a:graphicData>
+        </a:graphic>
+      </p:graphicFrame>
+      <p:sp>
+        <p:nvSpPr>
+          <p:cNvPr id="28" name="Shape 25"/>
+          <p:cNvSpPr/>
+          <p:nvPr/>
+        </p:nvSpPr>
+        <p:spPr>
+          <a:xfrm>
+            <a:off x="5943600" y="5440680"/>
+            <a:ext cx="5669280" cy="914400"/>
+          </a:xfrm>
+          <a:prstGeom prst="roundRect">
+            <a:avLst>
+              <a:gd name="adj" fmla="val 6000"/>
+            </a:avLst>
+          </a:prstGeom>
+          <a:solidFill>
+            <a:srgbClr val="EAF6F5"/>
+          </a:solidFill>
+          <a:ln/>
+        </p:spPr>
+      </p:sp>
+      <p:sp>
+        <p:nvSpPr>
+          <p:cNvPr id="29" name="Text 26"/>
+          <p:cNvSpPr/>
+          <p:nvPr/>
+        </p:nvSpPr>
+        <p:spPr>
+          <a:xfrm>
+            <a:off x="6144768" y="5532120"/>
+            <a:ext cx="5303520" cy="731520"/>
+          </a:xfrm>
+          <a:prstGeom prst="rect">
+            <a:avLst/>
+          </a:prstGeom>
+          <a:noFill/>
+          <a:ln/>
+        </p:spPr>
+        <p:txBody>
+          <a:bodyPr wrap="square" lIns="0" tIns="0" rIns="0" bIns="0" rtlCol="0" anchor="ctr"/>
+          <a:lstStyle/>
+          <a:p>
+            <a:pPr indent="0" marL="0">
+              <a:buNone/>
+            </a:pPr>
+            <a:r>
+              <a:rPr lang="en-US" sz="1250" b="1" dirty="0">
+                <a:solidFill>
+                  <a:srgbClr val="0A3D5C"/>
+                </a:solidFill>
+                <a:latin typeface="Calibri" pitchFamily="34" charset="0"/>
+                <a:ea typeface="Calibri" pitchFamily="34" charset="-122"/>
+                <a:cs typeface="Calibri" pitchFamily="34" charset="-120"/>
+              </a:rPr>
+              <a:t>Decision for Avra:  </a:t>
+            </a:r>
+            <a:pPr indent="0" marL="0">
+              <a:buNone/>
+            </a:pPr>
+            <a:r>
+              <a:rPr lang="en-US" sz="1250" dirty="0">
+                <a:solidFill>
+                  <a:srgbClr val="1E2B37"/>
+                </a:solidFill>
+                <a:latin typeface="Calibri" pitchFamily="34" charset="0"/>
+                <a:ea typeface="Calibri" pitchFamily="34" charset="-122"/>
+                <a:cs typeface="Calibri" pitchFamily="34" charset="-120"/>
+              </a:rPr>
+              <a:t>at ≥100 pax/hr/lane the 3 gates cope; below ~80 every lane is used and capacity gets tight. Confirm the ATRS rate — one constant re-runs everything.</a:t>
+            </a:r>
+            <a:endParaRPr lang="en-US" sz="1250" dirty="0"/>
           </a:p>
         </p:txBody>
       </p:sp>
@@ -6432,6 +8533,635 @@
 <file path=ppt/slides/slide13.xml><?xml version="1.0" encoding="utf-8"?>
 <p:sld xmlns:a="http://schemas.openxmlformats.org/drawingml/2006/main" xmlns:r="http://schemas.openxmlformats.org/officeDocument/2006/relationships" xmlns:p="http://schemas.openxmlformats.org/presentationml/2006/main">
   <p:cSld name="Slide 13">
+    <p:bg>
+      <p:bgPr>
+        <a:solidFill>
+          <a:srgbClr val="FFFFFF"/>
+        </a:solidFill>
+      </p:bgPr>
+    </p:bg>
+    <p:spTree>
+      <p:nvGrpSpPr>
+        <p:cNvPr id="1" name=""/>
+        <p:cNvGrpSpPr/>
+        <p:nvPr/>
+      </p:nvGrpSpPr>
+      <p:grpSpPr>
+        <a:xfrm>
+          <a:off x="0" y="0"/>
+          <a:ext cx="0" cy="0"/>
+          <a:chOff x="0" y="0"/>
+          <a:chExt cx="0" cy="0"/>
+        </a:xfrm>
+      </p:grpSpPr>
+      <p:sp>
+        <p:nvSpPr>
+          <p:cNvPr id="2" name="Text 0"/>
+          <p:cNvSpPr/>
+          <p:nvPr/>
+        </p:nvSpPr>
+        <p:spPr>
+          <a:xfrm>
+            <a:off x="640080" y="457200"/>
+            <a:ext cx="7315200" cy="274320"/>
+          </a:xfrm>
+          <a:prstGeom prst="rect">
+            <a:avLst/>
+          </a:prstGeom>
+          <a:noFill/>
+          <a:ln/>
+        </p:spPr>
+        <p:txBody>
+          <a:bodyPr wrap="square" lIns="0" tIns="0" rIns="0" bIns="0" rtlCol="0" anchor="ctr"/>
+          <a:lstStyle/>
+          <a:p>
+            <a:pPr indent="0" marL="0">
+              <a:buNone/>
+            </a:pPr>
+            <a:r>
+              <a:rPr lang="en-US" sz="1200" b="1" spc="200" kern="0" dirty="0">
+                <a:solidFill>
+                  <a:srgbClr val="16A0AD"/>
+                </a:solidFill>
+                <a:latin typeface="Calibri" pitchFamily="34" charset="0"/>
+                <a:ea typeface="Calibri" pitchFamily="34" charset="-122"/>
+                <a:cs typeface="Calibri" pitchFamily="34" charset="-120"/>
+              </a:rPr>
+              <a:t>TO CONFIRM WITH AVRA</a:t>
+            </a:r>
+            <a:endParaRPr lang="en-US" sz="1200" dirty="0"/>
+          </a:p>
+        </p:txBody>
+      </p:sp>
+      <p:sp>
+        <p:nvSpPr>
+          <p:cNvPr id="3" name="Text 1"/>
+          <p:cNvSpPr/>
+          <p:nvPr/>
+        </p:nvSpPr>
+        <p:spPr>
+          <a:xfrm>
+            <a:off x="640080" y="731520"/>
+            <a:ext cx="10972800" cy="731520"/>
+          </a:xfrm>
+          <a:prstGeom prst="rect">
+            <a:avLst/>
+          </a:prstGeom>
+          <a:noFill/>
+          <a:ln/>
+        </p:spPr>
+        <p:txBody>
+          <a:bodyPr wrap="square" lIns="0" tIns="0" rIns="0" bIns="0" rtlCol="0" anchor="ctr"/>
+          <a:lstStyle/>
+          <a:p>
+            <a:pPr indent="0" marL="0">
+              <a:buNone/>
+            </a:pPr>
+            <a:r>
+              <a:rPr lang="en-US" sz="3000" b="1" dirty="0">
+                <a:solidFill>
+                  <a:srgbClr val="1E2B37"/>
+                </a:solidFill>
+                <a:latin typeface="Cambria" pitchFamily="34" charset="0"/>
+                <a:ea typeface="Cambria" pitchFamily="34" charset="-122"/>
+                <a:cs typeface="Cambria" pitchFamily="34" charset="-120"/>
+              </a:rPr>
+              <a:t>Open questions before sign-off</a:t>
+            </a:r>
+            <a:endParaRPr lang="en-US" sz="3000" dirty="0"/>
+          </a:p>
+        </p:txBody>
+      </p:sp>
+      <p:sp>
+        <p:nvSpPr>
+          <p:cNvPr id="4" name="Shape 2"/>
+          <p:cNvSpPr/>
+          <p:nvPr/>
+        </p:nvSpPr>
+        <p:spPr>
+          <a:xfrm>
+            <a:off x="640080" y="1783080"/>
+            <a:ext cx="10972800" cy="1234440"/>
+          </a:xfrm>
+          <a:prstGeom prst="roundRect">
+            <a:avLst>
+              <a:gd name="adj" fmla="val 5926"/>
+            </a:avLst>
+          </a:prstGeom>
+          <a:solidFill>
+            <a:srgbClr val="F4F7F9"/>
+          </a:solidFill>
+          <a:ln w="12700">
+            <a:solidFill>
+              <a:srgbClr val="E2E9EE"/>
+            </a:solidFill>
+            <a:prstDash val="solid"/>
+          </a:ln>
+          <a:effectLst>
+            <a:outerShdw sx="100000" sy="100000" kx="0" ky="0" algn="bl" rotWithShape="0" blurRad="76200" dist="25400" dir="5400000">
+              <a:srgbClr val="9FB0BC">
+                <a:alpha val="35000"/>
+              </a:srgbClr>
+            </a:outerShdw>
+          </a:effectLst>
+        </p:spPr>
+      </p:sp>
+      <p:sp>
+        <p:nvSpPr>
+          <p:cNvPr id="5" name="Shape 3"/>
+          <p:cNvSpPr/>
+          <p:nvPr/>
+        </p:nvSpPr>
+        <p:spPr>
+          <a:xfrm>
+            <a:off x="868680" y="2039112"/>
+            <a:ext cx="731520" cy="731520"/>
+          </a:xfrm>
+          <a:prstGeom prst="roundRect">
+            <a:avLst>
+              <a:gd name="adj" fmla="val 50000"/>
+            </a:avLst>
+          </a:prstGeom>
+          <a:solidFill>
+            <a:srgbClr val="D98A2B"/>
+          </a:solidFill>
+          <a:ln/>
+        </p:spPr>
+      </p:sp>
+      <p:sp>
+        <p:nvSpPr>
+          <p:cNvPr id="6" name="Text 4"/>
+          <p:cNvSpPr/>
+          <p:nvPr/>
+        </p:nvSpPr>
+        <p:spPr>
+          <a:xfrm>
+            <a:off x="868680" y="2039112"/>
+            <a:ext cx="731520" cy="731520"/>
+          </a:xfrm>
+          <a:prstGeom prst="rect">
+            <a:avLst/>
+          </a:prstGeom>
+          <a:noFill/>
+          <a:ln/>
+        </p:spPr>
+        <p:txBody>
+          <a:bodyPr wrap="square" lIns="0" tIns="0" rIns="0" bIns="0" rtlCol="0" anchor="ctr"/>
+          <a:lstStyle/>
+          <a:p>
+            <a:pPr algn="ctr" indent="0" marL="0">
+              <a:buNone/>
+            </a:pPr>
+            <a:r>
+              <a:rPr lang="en-US" sz="3000" b="1" dirty="0">
+                <a:solidFill>
+                  <a:srgbClr val="FFFFFF"/>
+                </a:solidFill>
+                <a:latin typeface="Cambria" pitchFamily="34" charset="0"/>
+                <a:ea typeface="Cambria" pitchFamily="34" charset="-122"/>
+                <a:cs typeface="Cambria" pitchFamily="34" charset="-120"/>
+              </a:rPr>
+              <a:t>?</a:t>
+            </a:r>
+            <a:endParaRPr lang="en-US" sz="3000" dirty="0"/>
+          </a:p>
+        </p:txBody>
+      </p:sp>
+      <p:sp>
+        <p:nvSpPr>
+          <p:cNvPr id="7" name="Text 5"/>
+          <p:cNvSpPr/>
+          <p:nvPr/>
+        </p:nvSpPr>
+        <p:spPr>
+          <a:xfrm>
+            <a:off x="1828800" y="1984248"/>
+            <a:ext cx="9509760" cy="411480"/>
+          </a:xfrm>
+          <a:prstGeom prst="rect">
+            <a:avLst/>
+          </a:prstGeom>
+          <a:noFill/>
+          <a:ln/>
+        </p:spPr>
+        <p:txBody>
+          <a:bodyPr wrap="square" lIns="0" tIns="0" rIns="0" bIns="0" rtlCol="0" anchor="ctr"/>
+          <a:lstStyle/>
+          <a:p>
+            <a:pPr indent="0" marL="0">
+              <a:buNone/>
+            </a:pPr>
+            <a:r>
+              <a:rPr lang="en-US" sz="1800" b="1" dirty="0">
+                <a:solidFill>
+                  <a:srgbClr val="1E2B37"/>
+                </a:solidFill>
+                <a:latin typeface="Cambria" pitchFamily="34" charset="0"/>
+                <a:ea typeface="Cambria" pitchFamily="34" charset="-122"/>
+                <a:cs typeface="Cambria" pitchFamily="34" charset="-120"/>
+              </a:rPr>
+              <a:t>E-boarding = 2 days only</a:t>
+            </a:r>
+            <a:endParaRPr lang="en-US" sz="1800" dirty="0"/>
+          </a:p>
+        </p:txBody>
+      </p:sp>
+      <p:sp>
+        <p:nvSpPr>
+          <p:cNvPr id="8" name="Text 6"/>
+          <p:cNvSpPr/>
+          <p:nvPr/>
+        </p:nvSpPr>
+        <p:spPr>
+          <a:xfrm>
+            <a:off x="1828800" y="2404872"/>
+            <a:ext cx="9509760" cy="502920"/>
+          </a:xfrm>
+          <a:prstGeom prst="rect">
+            <a:avLst/>
+          </a:prstGeom>
+          <a:noFill/>
+          <a:ln/>
+        </p:spPr>
+        <p:txBody>
+          <a:bodyPr wrap="square" lIns="0" tIns="0" rIns="0" bIns="0" rtlCol="0" anchor="ctr"/>
+          <a:lstStyle/>
+          <a:p>
+            <a:pPr indent="0" marL="0">
+              <a:buNone/>
+            </a:pPr>
+            <a:r>
+              <a:rPr lang="en-US" sz="1350" dirty="0">
+                <a:solidFill>
+                  <a:srgbClr val="6B7B8A"/>
+                </a:solidFill>
+                <a:latin typeface="Calibri" pitchFamily="34" charset="0"/>
+                <a:ea typeface="Calibri" pitchFamily="34" charset="-122"/>
+                <a:cs typeface="Calibri" pitchFamily="34" charset="-120"/>
+              </a:rPr>
+              <a:t>Great for the overall show-up profile, but a full month is needed for day-of-week splits.</a:t>
+            </a:r>
+            <a:endParaRPr lang="en-US" sz="1350" dirty="0"/>
+          </a:p>
+        </p:txBody>
+      </p:sp>
+      <p:sp>
+        <p:nvSpPr>
+          <p:cNvPr id="9" name="Shape 7"/>
+          <p:cNvSpPr/>
+          <p:nvPr/>
+        </p:nvSpPr>
+        <p:spPr>
+          <a:xfrm>
+            <a:off x="640080" y="3200400"/>
+            <a:ext cx="10972800" cy="1234440"/>
+          </a:xfrm>
+          <a:prstGeom prst="roundRect">
+            <a:avLst>
+              <a:gd name="adj" fmla="val 5926"/>
+            </a:avLst>
+          </a:prstGeom>
+          <a:solidFill>
+            <a:srgbClr val="F4F7F9"/>
+          </a:solidFill>
+          <a:ln w="12700">
+            <a:solidFill>
+              <a:srgbClr val="E2E9EE"/>
+            </a:solidFill>
+            <a:prstDash val="solid"/>
+          </a:ln>
+          <a:effectLst>
+            <a:outerShdw sx="100000" sy="100000" kx="0" ky="0" algn="bl" rotWithShape="0" blurRad="76200" dist="25400" dir="5400000">
+              <a:srgbClr val="9FB0BC">
+                <a:alpha val="35000"/>
+              </a:srgbClr>
+            </a:outerShdw>
+          </a:effectLst>
+        </p:spPr>
+      </p:sp>
+      <p:sp>
+        <p:nvSpPr>
+          <p:cNvPr id="10" name="Shape 8"/>
+          <p:cNvSpPr/>
+          <p:nvPr/>
+        </p:nvSpPr>
+        <p:spPr>
+          <a:xfrm>
+            <a:off x="868680" y="3456432"/>
+            <a:ext cx="731520" cy="731520"/>
+          </a:xfrm>
+          <a:prstGeom prst="roundRect">
+            <a:avLst>
+              <a:gd name="adj" fmla="val 50000"/>
+            </a:avLst>
+          </a:prstGeom>
+          <a:solidFill>
+            <a:srgbClr val="D98A2B"/>
+          </a:solidFill>
+          <a:ln/>
+        </p:spPr>
+      </p:sp>
+      <p:sp>
+        <p:nvSpPr>
+          <p:cNvPr id="11" name="Text 9"/>
+          <p:cNvSpPr/>
+          <p:nvPr/>
+        </p:nvSpPr>
+        <p:spPr>
+          <a:xfrm>
+            <a:off x="868680" y="3456432"/>
+            <a:ext cx="731520" cy="731520"/>
+          </a:xfrm>
+          <a:prstGeom prst="rect">
+            <a:avLst/>
+          </a:prstGeom>
+          <a:noFill/>
+          <a:ln/>
+        </p:spPr>
+        <p:txBody>
+          <a:bodyPr wrap="square" lIns="0" tIns="0" rIns="0" bIns="0" rtlCol="0" anchor="ctr"/>
+          <a:lstStyle/>
+          <a:p>
+            <a:pPr algn="ctr" indent="0" marL="0">
+              <a:buNone/>
+            </a:pPr>
+            <a:r>
+              <a:rPr lang="en-US" sz="3000" b="1" dirty="0">
+                <a:solidFill>
+                  <a:srgbClr val="FFFFFF"/>
+                </a:solidFill>
+                <a:latin typeface="Cambria" pitchFamily="34" charset="0"/>
+                <a:ea typeface="Cambria" pitchFamily="34" charset="-122"/>
+                <a:cs typeface="Cambria" pitchFamily="34" charset="-120"/>
+              </a:rPr>
+              <a:t>?</a:t>
+            </a:r>
+            <a:endParaRPr lang="en-US" sz="3000" dirty="0"/>
+          </a:p>
+        </p:txBody>
+      </p:sp>
+      <p:sp>
+        <p:nvSpPr>
+          <p:cNvPr id="12" name="Text 10"/>
+          <p:cNvSpPr/>
+          <p:nvPr/>
+        </p:nvSpPr>
+        <p:spPr>
+          <a:xfrm>
+            <a:off x="1828800" y="3401568"/>
+            <a:ext cx="9509760" cy="411480"/>
+          </a:xfrm>
+          <a:prstGeom prst="rect">
+            <a:avLst/>
+          </a:prstGeom>
+          <a:noFill/>
+          <a:ln/>
+        </p:spPr>
+        <p:txBody>
+          <a:bodyPr wrap="square" lIns="0" tIns="0" rIns="0" bIns="0" rtlCol="0" anchor="ctr"/>
+          <a:lstStyle/>
+          <a:p>
+            <a:pPr indent="0" marL="0">
+              <a:buNone/>
+            </a:pPr>
+            <a:r>
+              <a:rPr lang="en-US" sz="1800" b="1" dirty="0">
+                <a:solidFill>
+                  <a:srgbClr val="1E2B37"/>
+                </a:solidFill>
+                <a:latin typeface="Cambria" pitchFamily="34" charset="0"/>
+                <a:ea typeface="Cambria" pitchFamily="34" charset="-122"/>
+                <a:cs typeface="Cambria" pitchFamily="34" charset="-120"/>
+              </a:rPr>
+              <a:t>June sheet ambiguity</a:t>
+            </a:r>
+            <a:endParaRPr lang="en-US" sz="1800" dirty="0"/>
+          </a:p>
+        </p:txBody>
+      </p:sp>
+      <p:sp>
+        <p:nvSpPr>
+          <p:cNvPr id="13" name="Text 11"/>
+          <p:cNvSpPr/>
+          <p:nvPr/>
+        </p:nvSpPr>
+        <p:spPr>
+          <a:xfrm>
+            <a:off x="1828800" y="3822192"/>
+            <a:ext cx="9509760" cy="502920"/>
+          </a:xfrm>
+          <a:prstGeom prst="rect">
+            <a:avLst/>
+          </a:prstGeom>
+          <a:noFill/>
+          <a:ln/>
+        </p:spPr>
+        <p:txBody>
+          <a:bodyPr wrap="square" lIns="0" tIns="0" rIns="0" bIns="0" rtlCol="0" anchor="ctr"/>
+          <a:lstStyle/>
+          <a:p>
+            <a:pPr indent="0" marL="0">
+              <a:buNone/>
+            </a:pPr>
+            <a:r>
+              <a:rPr lang="en-US" sz="1350" dirty="0">
+                <a:solidFill>
+                  <a:srgbClr val="6B7B8A"/>
+                </a:solidFill>
+                <a:latin typeface="Calibri" pitchFamily="34" charset="0"/>
+                <a:ea typeface="Calibri" pitchFamily="34" charset="-122"/>
+                <a:cs typeface="Calibri" pitchFamily="34" charset="-120"/>
+              </a:rPr>
+              <a:t>The workbook’s second sheet is a July-labelled calculated copy; we used the clean June sheet only — confirm.</a:t>
+            </a:r>
+            <a:endParaRPr lang="en-US" sz="1350" dirty="0"/>
+          </a:p>
+        </p:txBody>
+      </p:sp>
+      <p:sp>
+        <p:nvSpPr>
+          <p:cNvPr id="14" name="Shape 12"/>
+          <p:cNvSpPr/>
+          <p:nvPr/>
+        </p:nvSpPr>
+        <p:spPr>
+          <a:xfrm>
+            <a:off x="640080" y="4617720"/>
+            <a:ext cx="10972800" cy="1234440"/>
+          </a:xfrm>
+          <a:prstGeom prst="roundRect">
+            <a:avLst>
+              <a:gd name="adj" fmla="val 5926"/>
+            </a:avLst>
+          </a:prstGeom>
+          <a:solidFill>
+            <a:srgbClr val="F4F7F9"/>
+          </a:solidFill>
+          <a:ln w="12700">
+            <a:solidFill>
+              <a:srgbClr val="E2E9EE"/>
+            </a:solidFill>
+            <a:prstDash val="solid"/>
+          </a:ln>
+          <a:effectLst>
+            <a:outerShdw sx="100000" sy="100000" kx="0" ky="0" algn="bl" rotWithShape="0" blurRad="76200" dist="25400" dir="5400000">
+              <a:srgbClr val="9FB0BC">
+                <a:alpha val="35000"/>
+              </a:srgbClr>
+            </a:outerShdw>
+          </a:effectLst>
+        </p:spPr>
+      </p:sp>
+      <p:sp>
+        <p:nvSpPr>
+          <p:cNvPr id="15" name="Shape 13"/>
+          <p:cNvSpPr/>
+          <p:nvPr/>
+        </p:nvSpPr>
+        <p:spPr>
+          <a:xfrm>
+            <a:off x="868680" y="4873752"/>
+            <a:ext cx="731520" cy="731520"/>
+          </a:xfrm>
+          <a:prstGeom prst="roundRect">
+            <a:avLst>
+              <a:gd name="adj" fmla="val 50000"/>
+            </a:avLst>
+          </a:prstGeom>
+          <a:solidFill>
+            <a:srgbClr val="D98A2B"/>
+          </a:solidFill>
+          <a:ln/>
+        </p:spPr>
+      </p:sp>
+      <p:sp>
+        <p:nvSpPr>
+          <p:cNvPr id="16" name="Text 14"/>
+          <p:cNvSpPr/>
+          <p:nvPr/>
+        </p:nvSpPr>
+        <p:spPr>
+          <a:xfrm>
+            <a:off x="868680" y="4873752"/>
+            <a:ext cx="731520" cy="731520"/>
+          </a:xfrm>
+          <a:prstGeom prst="rect">
+            <a:avLst/>
+          </a:prstGeom>
+          <a:noFill/>
+          <a:ln/>
+        </p:spPr>
+        <p:txBody>
+          <a:bodyPr wrap="square" lIns="0" tIns="0" rIns="0" bIns="0" rtlCol="0" anchor="ctr"/>
+          <a:lstStyle/>
+          <a:p>
+            <a:pPr algn="ctr" indent="0" marL="0">
+              <a:buNone/>
+            </a:pPr>
+            <a:r>
+              <a:rPr lang="en-US" sz="3000" b="1" dirty="0">
+                <a:solidFill>
+                  <a:srgbClr val="FFFFFF"/>
+                </a:solidFill>
+                <a:latin typeface="Cambria" pitchFamily="34" charset="0"/>
+                <a:ea typeface="Cambria" pitchFamily="34" charset="-122"/>
+                <a:cs typeface="Cambria" pitchFamily="34" charset="-120"/>
+              </a:rPr>
+              <a:t>?</a:t>
+            </a:r>
+            <a:endParaRPr lang="en-US" sz="3000" dirty="0"/>
+          </a:p>
+        </p:txBody>
+      </p:sp>
+      <p:sp>
+        <p:nvSpPr>
+          <p:cNvPr id="17" name="Text 15"/>
+          <p:cNvSpPr/>
+          <p:nvPr/>
+        </p:nvSpPr>
+        <p:spPr>
+          <a:xfrm>
+            <a:off x="1828800" y="4818888"/>
+            <a:ext cx="9509760" cy="411480"/>
+          </a:xfrm>
+          <a:prstGeom prst="rect">
+            <a:avLst/>
+          </a:prstGeom>
+          <a:noFill/>
+          <a:ln/>
+        </p:spPr>
+        <p:txBody>
+          <a:bodyPr wrap="square" lIns="0" tIns="0" rIns="0" bIns="0" rtlCol="0" anchor="ctr"/>
+          <a:lstStyle/>
+          <a:p>
+            <a:pPr indent="0" marL="0">
+              <a:buNone/>
+            </a:pPr>
+            <a:r>
+              <a:rPr lang="en-US" sz="1800" b="1" dirty="0">
+                <a:solidFill>
+                  <a:srgbClr val="1E2B37"/>
+                </a:solidFill>
+                <a:latin typeface="Cambria" pitchFamily="34" charset="0"/>
+                <a:ea typeface="Cambria" pitchFamily="34" charset="-122"/>
+                <a:cs typeface="Cambria" pitchFamily="34" charset="-120"/>
+              </a:rPr>
+              <a:t>Throughput assumption</a:t>
+            </a:r>
+            <a:endParaRPr lang="en-US" sz="1800" dirty="0"/>
+          </a:p>
+        </p:txBody>
+      </p:sp>
+      <p:sp>
+        <p:nvSpPr>
+          <p:cNvPr id="18" name="Text 16"/>
+          <p:cNvSpPr/>
+          <p:nvPr/>
+        </p:nvSpPr>
+        <p:spPr>
+          <a:xfrm>
+            <a:off x="1828800" y="5239512"/>
+            <a:ext cx="9509760" cy="502920"/>
+          </a:xfrm>
+          <a:prstGeom prst="rect">
+            <a:avLst/>
+          </a:prstGeom>
+          <a:noFill/>
+          <a:ln/>
+        </p:spPr>
+        <p:txBody>
+          <a:bodyPr wrap="square" lIns="0" tIns="0" rIns="0" bIns="0" rtlCol="0" anchor="ctr"/>
+          <a:lstStyle/>
+          <a:p>
+            <a:pPr indent="0" marL="0">
+              <a:buNone/>
+            </a:pPr>
+            <a:r>
+              <a:rPr lang="en-US" sz="1350" dirty="0">
+                <a:solidFill>
+                  <a:srgbClr val="6B7B8A"/>
+                </a:solidFill>
+                <a:latin typeface="Calibri" pitchFamily="34" charset="0"/>
+                <a:ea typeface="Calibri" pitchFamily="34" charset="-122"/>
+                <a:cs typeface="Calibri" pitchFamily="34" charset="-120"/>
+              </a:rPr>
+              <a:t>ATRS 180 trays/hr and 1.5 trays/pax → 120 pax/hr/lane (60 per 30 min). Confirm the rate.</a:t>
+            </a:r>
+            <a:endParaRPr lang="en-US" sz="1350" dirty="0"/>
+          </a:p>
+        </p:txBody>
+      </p:sp>
+    </p:spTree>
+  </p:cSld>
+  <p:clrMapOvr>
+    <a:masterClrMapping/>
+  </p:clrMapOvr>
+</p:sld>
+</file>
+
+<file path=ppt/slides/slide14.xml><?xml version="1.0" encoding="utf-8"?>
+<p:sld xmlns:a="http://schemas.openxmlformats.org/drawingml/2006/main" xmlns:r="http://schemas.openxmlformats.org/officeDocument/2006/relationships" xmlns:p="http://schemas.openxmlformats.org/presentationml/2006/main">
+  <p:cSld name="Slide 14">
     <p:bg>
       <p:bgPr>
         <a:solidFill>

</xml_diff>

<commit_message>
POD2 deck: reflect the 3-gate x A/B change on the Step 6 deliverable slide
Slide 10 now shows the gate structure: formula ends "gate-lanes = ceil(demand/60)",
headline stat reads "4 of 6 gate-lanes at peak, 3 gates x A/B", total aligned to the
actual workbook (~882,800), and the note cites the layout + lane-speed caveat. Keeps
slide 10 (the deliverable summary) consistent with slide 12 (gate detail).

Co-Authored-By: Claude Opus 4.8 <noreply@anthropic.com>
</commit_message>
<xml_diff>
--- a/POD2/POD2_Entry_Overview.pptx
+++ b/POD2/POD2_Entry_Overview.pptx
@@ -3130,7 +3130,7 @@
                 <a:ea typeface="Calibri" pitchFamily="34" charset="-122"/>
                 <a:cs typeface="Calibri" pitchFamily="34" charset="-120"/>
               </a:rPr>
-              <a:t>lanes = ⌈demand / 60⌉</a:t>
+              <a:t>gate-lanes = ⌈demand / 60⌉</a:t>
             </a:r>
             <a:endParaRPr lang="en-US" sz="1200" dirty="0"/>
           </a:p>
@@ -3195,7 +3195,7 @@
               <a:buNone/>
             </a:pPr>
             <a:r>
-              <a:rPr lang="en-US" sz="3400" b="1" dirty="0">
+              <a:rPr lang="en-US" sz="2600" b="1" dirty="0">
                 <a:solidFill>
                   <a:srgbClr val="0B6E99"/>
                 </a:solidFill>
@@ -3205,7 +3205,7 @@
               </a:rPr>
               <a:t>5,820</a:t>
             </a:r>
-            <a:endParaRPr lang="en-US" sz="3400" dirty="0"/>
+            <a:endParaRPr lang="en-US" sz="2600" dirty="0"/>
           </a:p>
         </p:txBody>
       </p:sp>
@@ -3307,7 +3307,7 @@
               <a:buNone/>
             </a:pPr>
             <a:r>
-              <a:rPr lang="en-US" sz="3400" b="1" dirty="0">
+              <a:rPr lang="en-US" sz="2600" b="1" dirty="0">
                 <a:solidFill>
                   <a:srgbClr val="16A0AD"/>
                 </a:solidFill>
@@ -3315,9 +3315,9 @@
                 <a:ea typeface="Cambria" pitchFamily="34" charset="-122"/>
                 <a:cs typeface="Cambria" pitchFamily="34" charset="-120"/>
               </a:rPr>
-              <a:t>~873,500</a:t>
-            </a:r>
-            <a:endParaRPr lang="en-US" sz="3400" dirty="0"/>
+              <a:t>~882,800</a:t>
+            </a:r>
+            <a:endParaRPr lang="en-US" sz="2600" dirty="0"/>
           </a:p>
         </p:txBody>
       </p:sp>
@@ -3354,7 +3354,7 @@
                 <a:ea typeface="Calibri" pitchFamily="34" charset="-122"/>
                 <a:cs typeface="Calibri" pitchFamily="34" charset="-120"/>
               </a:rPr>
-              <a:t>season entry passengers (~4,159/day)</a:t>
+              <a:t>season entry passengers (~4,200/day)</a:t>
             </a:r>
             <a:endParaRPr lang="en-US" sz="1250" dirty="0"/>
           </a:p>
@@ -3419,7 +3419,7 @@
               <a:buNone/>
             </a:pPr>
             <a:r>
-              <a:rPr lang="en-US" sz="3400" b="1" dirty="0">
+              <a:rPr lang="en-US" sz="2600" b="1" dirty="0">
                 <a:solidFill>
                   <a:srgbClr val="2E8B57"/>
                 </a:solidFill>
@@ -3427,9 +3427,9 @@
                 <a:ea typeface="Cambria" pitchFamily="34" charset="-122"/>
                 <a:cs typeface="Cambria" pitchFamily="34" charset="-120"/>
               </a:rPr>
-              <a:t>4</a:t>
-            </a:r>
-            <a:endParaRPr lang="en-US" sz="3400" dirty="0"/>
+              <a:t>4 of 6</a:t>
+            </a:r>
+            <a:endParaRPr lang="en-US" sz="2600" dirty="0"/>
           </a:p>
         </p:txBody>
       </p:sp>
@@ -3466,7 +3466,7 @@
                 <a:ea typeface="Calibri" pitchFamily="34" charset="-122"/>
                 <a:cs typeface="Calibri" pitchFamily="34" charset="-120"/>
               </a:rPr>
-              <a:t>peak entry lanes required</a:t>
+              <a:t>gate-lanes open at peak · 3 gates × A/B</a:t>
             </a:r>
             <a:endParaRPr lang="en-US" sz="1250" dirty="0"/>
           </a:p>
@@ -3578,7 +3578,7 @@
                 <a:ea typeface="Calibri" pitchFamily="34" charset="-122"/>
                 <a:cs typeface="Calibri" pitchFamily="34" charset="-120"/>
               </a:rPr>
-              <a:t>peak 30-min demand (busiest day, 17:25)</a:t>
+              <a:t>peak 30-min demand (busiest day, ~17:30)</a:t>
             </a:r>
             <a:endParaRPr lang="en-US" sz="1250" dirty="0"/>
           </a:p>
@@ -3617,7 +3617,7 @@
                 <a:ea typeface="Calibri" pitchFamily="34" charset="-122"/>
                 <a:cs typeface="Calibri" pitchFamily="34" charset="-120"/>
               </a:rPr>
-              <a:t>Season entry pax rose from the twin’s 827k because the real ~82% load factor replaced the flat ~78%.</a:t>
+              <a:t>Built on the real VTZ schedule. At peak only 4 of the 6 gate-lanes (3 gates × A/B) are needed — 2 to spare. Lane speed to be confirmed with Avra.</a:t>
             </a:r>
             <a:endParaRPr lang="en-US" sz="1300" dirty="0"/>
           </a:p>

</xml_diff>

<commit_message>
POD2: June data confirmed by Avra (both sheets are June)
Avra confirmed the load workbook is June - both sheets are June, the July label was
wrong. No numeric change (we already used the June aircraft-category breakdown); this
just closes the open question.

- xlsx Read Me: moved the June item from "to confirm" to a "Confirmed by Avra" section
- deck caveats slide: replaced the June-ambiguity card; open items now lane throughput /
  gate opening rule / show-up days, plus a green "Confirmed by Avra: June" note
- README + COMPARISON.md: reworded to "confirmed both sheets are June"

Co-Authored-By: Claude Opus 4.8 <noreply@anthropic.com>
</commit_message>
<xml_diff>
--- a/POD2/POD2_Entry_Overview.pptx
+++ b/POD2/POD2_Entry_Overview.pptx
@@ -8640,12 +8640,12 @@
         </p:nvSpPr>
         <p:spPr>
           <a:xfrm>
-            <a:off x="640080" y="1783080"/>
-            <a:ext cx="10972800" cy="1234440"/>
+            <a:off x="640080" y="1737360"/>
+            <a:ext cx="10972800" cy="1097280"/>
           </a:xfrm>
           <a:prstGeom prst="roundRect">
             <a:avLst>
-              <a:gd name="adj" fmla="val 5926"/>
+              <a:gd name="adj" fmla="val 6667"/>
             </a:avLst>
           </a:prstGeom>
           <a:solidFill>
@@ -8674,8 +8674,8 @@
         </p:nvSpPr>
         <p:spPr>
           <a:xfrm>
-            <a:off x="868680" y="2039112"/>
-            <a:ext cx="731520" cy="731520"/>
+            <a:off x="868680" y="1956816"/>
+            <a:ext cx="658368" cy="658368"/>
           </a:xfrm>
           <a:prstGeom prst="roundRect">
             <a:avLst>
@@ -8696,8 +8696,8 @@
         </p:nvSpPr>
         <p:spPr>
           <a:xfrm>
-            <a:off x="868680" y="2039112"/>
-            <a:ext cx="731520" cy="731520"/>
+            <a:off x="868680" y="1956816"/>
+            <a:ext cx="658368" cy="658368"/>
           </a:xfrm>
           <a:prstGeom prst="rect">
             <a:avLst/>
@@ -8713,7 +8713,7 @@
               <a:buNone/>
             </a:pPr>
             <a:r>
-              <a:rPr lang="en-US" sz="3000" b="1" dirty="0">
+              <a:rPr lang="en-US" sz="2800" b="1" dirty="0">
                 <a:solidFill>
                   <a:srgbClr val="FFFFFF"/>
                 </a:solidFill>
@@ -8723,7 +8723,7 @@
               </a:rPr>
               <a:t>?</a:t>
             </a:r>
-            <a:endParaRPr lang="en-US" sz="3000" dirty="0"/>
+            <a:endParaRPr lang="en-US" sz="2800" dirty="0"/>
           </a:p>
         </p:txBody>
       </p:sp>
@@ -8735,8 +8735,8 @@
         </p:nvSpPr>
         <p:spPr>
           <a:xfrm>
-            <a:off x="1828800" y="1984248"/>
-            <a:ext cx="9509760" cy="411480"/>
+            <a:off x="1737360" y="1901952"/>
+            <a:ext cx="9601200" cy="384048"/>
           </a:xfrm>
           <a:prstGeom prst="rect">
             <a:avLst/>
@@ -8752,7 +8752,7 @@
               <a:buNone/>
             </a:pPr>
             <a:r>
-              <a:rPr lang="en-US" sz="1800" b="1" dirty="0">
+              <a:rPr lang="en-US" sz="1700" b="1" dirty="0">
                 <a:solidFill>
                   <a:srgbClr val="1E2B37"/>
                 </a:solidFill>
@@ -8760,9 +8760,9 @@
                 <a:ea typeface="Cambria" pitchFamily="34" charset="-122"/>
                 <a:cs typeface="Cambria" pitchFamily="34" charset="-120"/>
               </a:rPr>
-              <a:t>E-boarding = 2 days only</a:t>
-            </a:r>
-            <a:endParaRPr lang="en-US" sz="1800" dirty="0"/>
+              <a:t>Lane throughput</a:t>
+            </a:r>
+            <a:endParaRPr lang="en-US" sz="1700" dirty="0"/>
           </a:p>
         </p:txBody>
       </p:sp>
@@ -8774,8 +8774,8 @@
         </p:nvSpPr>
         <p:spPr>
           <a:xfrm>
-            <a:off x="1828800" y="2404872"/>
-            <a:ext cx="9509760" cy="502920"/>
+            <a:off x="1737360" y="2286000"/>
+            <a:ext cx="9601200" cy="457200"/>
           </a:xfrm>
           <a:prstGeom prst="rect">
             <a:avLst/>
@@ -8791,7 +8791,7 @@
               <a:buNone/>
             </a:pPr>
             <a:r>
-              <a:rPr lang="en-US" sz="1350" dirty="0">
+              <a:rPr lang="en-US" sz="1300" dirty="0">
                 <a:solidFill>
                   <a:srgbClr val="6B7B8A"/>
                 </a:solidFill>
@@ -8799,9 +8799,9 @@
                 <a:ea typeface="Calibri" pitchFamily="34" charset="-122"/>
                 <a:cs typeface="Calibri" pitchFamily="34" charset="-120"/>
               </a:rPr>
-              <a:t>Great for the overall show-up profile, but a full month is needed for day-of-week splits.</a:t>
-            </a:r>
-            <a:endParaRPr lang="en-US" sz="1350" dirty="0"/>
+              <a:t>We assumed 120 pax/hr/lane (ATRS 180 trays/hr, 1.5 trays/pax). Please confirm the rate — one constant re-runs the whole plan.</a:t>
+            </a:r>
+            <a:endParaRPr lang="en-US" sz="1300" dirty="0"/>
           </a:p>
         </p:txBody>
       </p:sp>
@@ -8813,12 +8813,12 @@
         </p:nvSpPr>
         <p:spPr>
           <a:xfrm>
-            <a:off x="640080" y="3200400"/>
-            <a:ext cx="10972800" cy="1234440"/>
+            <a:off x="640080" y="3017520"/>
+            <a:ext cx="10972800" cy="1097280"/>
           </a:xfrm>
           <a:prstGeom prst="roundRect">
             <a:avLst>
-              <a:gd name="adj" fmla="val 5926"/>
+              <a:gd name="adj" fmla="val 6667"/>
             </a:avLst>
           </a:prstGeom>
           <a:solidFill>
@@ -8847,8 +8847,8 @@
         </p:nvSpPr>
         <p:spPr>
           <a:xfrm>
-            <a:off x="868680" y="3456432"/>
-            <a:ext cx="731520" cy="731520"/>
+            <a:off x="868680" y="3236976"/>
+            <a:ext cx="658368" cy="658368"/>
           </a:xfrm>
           <a:prstGeom prst="roundRect">
             <a:avLst>
@@ -8869,8 +8869,8 @@
         </p:nvSpPr>
         <p:spPr>
           <a:xfrm>
-            <a:off x="868680" y="3456432"/>
-            <a:ext cx="731520" cy="731520"/>
+            <a:off x="868680" y="3236976"/>
+            <a:ext cx="658368" cy="658368"/>
           </a:xfrm>
           <a:prstGeom prst="rect">
             <a:avLst/>
@@ -8886,7 +8886,7 @@
               <a:buNone/>
             </a:pPr>
             <a:r>
-              <a:rPr lang="en-US" sz="3000" b="1" dirty="0">
+              <a:rPr lang="en-US" sz="2800" b="1" dirty="0">
                 <a:solidFill>
                   <a:srgbClr val="FFFFFF"/>
                 </a:solidFill>
@@ -8896,7 +8896,7 @@
               </a:rPr>
               <a:t>?</a:t>
             </a:r>
-            <a:endParaRPr lang="en-US" sz="3000" dirty="0"/>
+            <a:endParaRPr lang="en-US" sz="2800" dirty="0"/>
           </a:p>
         </p:txBody>
       </p:sp>
@@ -8908,8 +8908,8 @@
         </p:nvSpPr>
         <p:spPr>
           <a:xfrm>
-            <a:off x="1828800" y="3401568"/>
-            <a:ext cx="9509760" cy="411480"/>
+            <a:off x="1737360" y="3182112"/>
+            <a:ext cx="9601200" cy="384048"/>
           </a:xfrm>
           <a:prstGeom prst="rect">
             <a:avLst/>
@@ -8925,7 +8925,7 @@
               <a:buNone/>
             </a:pPr>
             <a:r>
-              <a:rPr lang="en-US" sz="1800" b="1" dirty="0">
+              <a:rPr lang="en-US" sz="1700" b="1" dirty="0">
                 <a:solidFill>
                   <a:srgbClr val="1E2B37"/>
                 </a:solidFill>
@@ -8933,9 +8933,9 @@
                 <a:ea typeface="Cambria" pitchFamily="34" charset="-122"/>
                 <a:cs typeface="Cambria" pitchFamily="34" charset="-120"/>
               </a:rPr>
-              <a:t>June sheet ambiguity</a:t>
-            </a:r>
-            <a:endParaRPr lang="en-US" sz="1800" dirty="0"/>
+              <a:t>Gate opening rule</a:t>
+            </a:r>
+            <a:endParaRPr lang="en-US" sz="1700" dirty="0"/>
           </a:p>
         </p:txBody>
       </p:sp>
@@ -8947,8 +8947,8 @@
         </p:nvSpPr>
         <p:spPr>
           <a:xfrm>
-            <a:off x="1828800" y="3822192"/>
-            <a:ext cx="9509760" cy="502920"/>
+            <a:off x="1737360" y="3566160"/>
+            <a:ext cx="9601200" cy="457200"/>
           </a:xfrm>
           <a:prstGeom prst="rect">
             <a:avLst/>
@@ -8964,7 +8964,7 @@
               <a:buNone/>
             </a:pPr>
             <a:r>
-              <a:rPr lang="en-US" sz="1350" dirty="0">
+              <a:rPr lang="en-US" sz="1300" dirty="0">
                 <a:solidFill>
                   <a:srgbClr val="6B7B8A"/>
                 </a:solidFill>
@@ -8972,9 +8972,9 @@
                 <a:ea typeface="Calibri" pitchFamily="34" charset="-122"/>
                 <a:cs typeface="Calibri" pitchFamily="34" charset="-120"/>
               </a:rPr>
-              <a:t>The workbook’s second sheet is a July-labelled calculated copy; we used the clean June sheet only — confirm.</a:t>
-            </a:r>
-            <a:endParaRPr lang="en-US" sz="1350" dirty="0"/>
+              <a:t>We assumed balancing across the 3 gates (one lane per gate first). Confirm this vs filling gate by gate.</a:t>
+            </a:r>
+            <a:endParaRPr lang="en-US" sz="1300" dirty="0"/>
           </a:p>
         </p:txBody>
       </p:sp>
@@ -8986,12 +8986,12 @@
         </p:nvSpPr>
         <p:spPr>
           <a:xfrm>
-            <a:off x="640080" y="4617720"/>
-            <a:ext cx="10972800" cy="1234440"/>
+            <a:off x="640080" y="4297680"/>
+            <a:ext cx="10972800" cy="1097280"/>
           </a:xfrm>
           <a:prstGeom prst="roundRect">
             <a:avLst>
-              <a:gd name="adj" fmla="val 5926"/>
+              <a:gd name="adj" fmla="val 6667"/>
             </a:avLst>
           </a:prstGeom>
           <a:solidFill>
@@ -9020,8 +9020,8 @@
         </p:nvSpPr>
         <p:spPr>
           <a:xfrm>
-            <a:off x="868680" y="4873752"/>
-            <a:ext cx="731520" cy="731520"/>
+            <a:off x="868680" y="4517136"/>
+            <a:ext cx="658368" cy="658368"/>
           </a:xfrm>
           <a:prstGeom prst="roundRect">
             <a:avLst>
@@ -9042,8 +9042,8 @@
         </p:nvSpPr>
         <p:spPr>
           <a:xfrm>
-            <a:off x="868680" y="4873752"/>
-            <a:ext cx="731520" cy="731520"/>
+            <a:off x="868680" y="4517136"/>
+            <a:ext cx="658368" cy="658368"/>
           </a:xfrm>
           <a:prstGeom prst="rect">
             <a:avLst/>
@@ -9059,7 +9059,7 @@
               <a:buNone/>
             </a:pPr>
             <a:r>
-              <a:rPr lang="en-US" sz="3000" b="1" dirty="0">
+              <a:rPr lang="en-US" sz="2800" b="1" dirty="0">
                 <a:solidFill>
                   <a:srgbClr val="FFFFFF"/>
                 </a:solidFill>
@@ -9069,7 +9069,7 @@
               </a:rPr>
               <a:t>?</a:t>
             </a:r>
-            <a:endParaRPr lang="en-US" sz="3000" dirty="0"/>
+            <a:endParaRPr lang="en-US" sz="2800" dirty="0"/>
           </a:p>
         </p:txBody>
       </p:sp>
@@ -9081,8 +9081,8 @@
         </p:nvSpPr>
         <p:spPr>
           <a:xfrm>
-            <a:off x="1828800" y="4818888"/>
-            <a:ext cx="9509760" cy="411480"/>
+            <a:off x="1737360" y="4462272"/>
+            <a:ext cx="9601200" cy="384048"/>
           </a:xfrm>
           <a:prstGeom prst="rect">
             <a:avLst/>
@@ -9098,7 +9098,7 @@
               <a:buNone/>
             </a:pPr>
             <a:r>
-              <a:rPr lang="en-US" sz="1800" b="1" dirty="0">
+              <a:rPr lang="en-US" sz="1700" b="1" dirty="0">
                 <a:solidFill>
                   <a:srgbClr val="1E2B37"/>
                 </a:solidFill>
@@ -9106,9 +9106,9 @@
                 <a:ea typeface="Cambria" pitchFamily="34" charset="-122"/>
                 <a:cs typeface="Cambria" pitchFamily="34" charset="-120"/>
               </a:rPr>
-              <a:t>Throughput assumption</a:t>
-            </a:r>
-            <a:endParaRPr lang="en-US" sz="1800" dirty="0"/>
+              <a:t>Show-up data</a:t>
+            </a:r>
+            <a:endParaRPr lang="en-US" sz="1700" dirty="0"/>
           </a:p>
         </p:txBody>
       </p:sp>
@@ -9120,8 +9120,8 @@
         </p:nvSpPr>
         <p:spPr>
           <a:xfrm>
-            <a:off x="1828800" y="5239512"/>
-            <a:ext cx="9509760" cy="502920"/>
+            <a:off x="1737360" y="4846320"/>
+            <a:ext cx="9601200" cy="457200"/>
           </a:xfrm>
           <a:prstGeom prst="rect">
             <a:avLst/>
@@ -9137,7 +9137,7 @@
               <a:buNone/>
             </a:pPr>
             <a:r>
-              <a:rPr lang="en-US" sz="1350" dirty="0">
+              <a:rPr lang="en-US" sz="1300" dirty="0">
                 <a:solidFill>
                   <a:srgbClr val="6B7B8A"/>
                 </a:solidFill>
@@ -9145,9 +9145,143 @@
                 <a:ea typeface="Calibri" pitchFamily="34" charset="-122"/>
                 <a:cs typeface="Calibri" pitchFamily="34" charset="-120"/>
               </a:rPr>
-              <a:t>ATRS 180 trays/hr and 1.5 trays/pax → 120 pax/hr/lane (60 per 30 min). Confirm the rate.</a:t>
-            </a:r>
-            <a:endParaRPr lang="en-US" sz="1350" dirty="0"/>
+              <a:t>The e-boarding sample is 2 days — a fuller month would sharpen the day-of-week view.</a:t>
+            </a:r>
+            <a:endParaRPr lang="en-US" sz="1300" dirty="0"/>
+          </a:p>
+        </p:txBody>
+      </p:sp>
+      <p:sp>
+        <p:nvSpPr>
+          <p:cNvPr id="19" name="Shape 17"/>
+          <p:cNvSpPr/>
+          <p:nvPr/>
+        </p:nvSpPr>
+        <p:spPr>
+          <a:xfrm>
+            <a:off x="640080" y="5623560"/>
+            <a:ext cx="10972800" cy="685800"/>
+          </a:xfrm>
+          <a:prstGeom prst="roundRect">
+            <a:avLst>
+              <a:gd name="adj" fmla="val 8000"/>
+            </a:avLst>
+          </a:prstGeom>
+          <a:solidFill>
+            <a:srgbClr val="E6F4EA"/>
+          </a:solidFill>
+          <a:ln/>
+        </p:spPr>
+      </p:sp>
+      <p:sp>
+        <p:nvSpPr>
+          <p:cNvPr id="20" name="Shape 18"/>
+          <p:cNvSpPr/>
+          <p:nvPr/>
+        </p:nvSpPr>
+        <p:spPr>
+          <a:xfrm>
+            <a:off x="868680" y="5788152"/>
+            <a:ext cx="365760" cy="365760"/>
+          </a:xfrm>
+          <a:prstGeom prst="ellipse">
+            <a:avLst/>
+          </a:prstGeom>
+          <a:solidFill>
+            <a:srgbClr val="2E8B57"/>
+          </a:solidFill>
+          <a:ln/>
+        </p:spPr>
+      </p:sp>
+      <p:sp>
+        <p:nvSpPr>
+          <p:cNvPr id="21" name="Text 19"/>
+          <p:cNvSpPr/>
+          <p:nvPr/>
+        </p:nvSpPr>
+        <p:spPr>
+          <a:xfrm>
+            <a:off x="868680" y="5788152"/>
+            <a:ext cx="365760" cy="365760"/>
+          </a:xfrm>
+          <a:prstGeom prst="rect">
+            <a:avLst/>
+          </a:prstGeom>
+          <a:noFill/>
+          <a:ln/>
+        </p:spPr>
+        <p:txBody>
+          <a:bodyPr wrap="square" lIns="0" tIns="0" rIns="0" bIns="0" rtlCol="0" anchor="ctr"/>
+          <a:lstStyle/>
+          <a:p>
+            <a:pPr algn="ctr" indent="0" marL="0">
+              <a:buNone/>
+            </a:pPr>
+            <a:r>
+              <a:rPr lang="en-US" sz="1600" b="1" dirty="0">
+                <a:solidFill>
+                  <a:srgbClr val="FFFFFF"/>
+                </a:solidFill>
+                <a:latin typeface="Cambria" pitchFamily="34" charset="0"/>
+                <a:ea typeface="Cambria" pitchFamily="34" charset="-122"/>
+                <a:cs typeface="Cambria" pitchFamily="34" charset="-120"/>
+              </a:rPr>
+              <a:t>✓</a:t>
+            </a:r>
+            <a:endParaRPr lang="en-US" sz="1600" dirty="0"/>
+          </a:p>
+        </p:txBody>
+      </p:sp>
+      <p:sp>
+        <p:nvSpPr>
+          <p:cNvPr id="22" name="Text 20"/>
+          <p:cNvSpPr/>
+          <p:nvPr/>
+        </p:nvSpPr>
+        <p:spPr>
+          <a:xfrm>
+            <a:off x="1417320" y="5623560"/>
+            <a:ext cx="9875520" cy="685800"/>
+          </a:xfrm>
+          <a:prstGeom prst="rect">
+            <a:avLst/>
+          </a:prstGeom>
+          <a:noFill/>
+          <a:ln/>
+        </p:spPr>
+        <p:txBody>
+          <a:bodyPr wrap="square" lIns="0" tIns="0" rIns="0" bIns="0" rtlCol="0" anchor="ctr"/>
+          <a:lstStyle/>
+          <a:p>
+            <a:pPr indent="0" marL="0">
+              <a:buNone/>
+            </a:pPr>
+            <a:r>
+              <a:rPr lang="en-US" sz="1300" b="1" dirty="0">
+                <a:solidFill>
+                  <a:srgbClr val="1E6B3A"/>
+                </a:solidFill>
+                <a:latin typeface="Calibri" pitchFamily="34" charset="0"/>
+                <a:ea typeface="Calibri" pitchFamily="34" charset="-122"/>
+                <a:cs typeface="Calibri" pitchFamily="34" charset="-120"/>
+              </a:rPr>
+              <a:t>Confirmed by Avra:  </a:t>
+            </a:r>
+            <a:pPr indent="0" marL="0">
+              <a:buNone/>
+            </a:pPr>
+            <a:r>
+              <a:rPr lang="en-US" sz="1300" dirty="0">
+                <a:solidFill>
+                  <a:srgbClr val="1E2B37"/>
+                </a:solidFill>
+                <a:latin typeface="Calibri" pitchFamily="34" charset="0"/>
+                <a:ea typeface="Calibri" pitchFamily="34" charset="-122"/>
+                <a:cs typeface="Calibri" pitchFamily="34" charset="-120"/>
+              </a:rPr>
+              <a:t>the load data is June (both sheets are June — the July label was wrong). Using June actuals.</a:t>
+            </a:r>
+            <a:endParaRPr lang="en-US" sz="1300" dirty="0"/>
           </a:p>
         </p:txBody>
       </p:sp>

</xml_diff>